<commit_message>
docs: inclui pré-flop, raise e all-in na análise de poker
</commit_message>
<xml_diff>
--- a/apresentacao/slides.pptx
+++ b/apresentacao/slides.pptx
@@ -2,24 +2,24 @@
 <file path=ppt/presentation.xml><?xml version="1.0" encoding="utf-8"?>
 <p:presentation xmlns:p="http://schemas.openxmlformats.org/presentationml/2006/main">
   <p:sldMasterIdLst>
-    <p:sldMasterId xmlns:r="http://schemas.openxmlformats.org/officeDocument/2006/relationships" id="2147483648" r:id="Rd23ec6ac782f4df5"/>
+    <p:sldMasterId xmlns:r="http://schemas.openxmlformats.org/officeDocument/2006/relationships" id="2147483648" r:id="Rd38427a096644d9b"/>
   </p:sldMasterIdLst>
   <p:notesMasterIdLst>
-    <p:notesMasterId xmlns:r="http://schemas.openxmlformats.org/officeDocument/2006/relationships" r:id="R99577ae4963846ac"/>
+    <p:notesMasterId xmlns:r="http://schemas.openxmlformats.org/officeDocument/2006/relationships" r:id="R0abed77a871940ae"/>
   </p:notesMasterIdLst>
   <p:sldIdLst>
-    <p:sldId xmlns:r="http://schemas.openxmlformats.org/officeDocument/2006/relationships" id="256" r:id="Rc2c1aa71325e40e9"/>
-    <p:sldId xmlns:r="http://schemas.openxmlformats.org/officeDocument/2006/relationships" id="257" r:id="R1c890e9fae5348c6"/>
-    <p:sldId xmlns:r="http://schemas.openxmlformats.org/officeDocument/2006/relationships" id="258" r:id="Ra2917d7cb1f24736"/>
-    <p:sldId xmlns:r="http://schemas.openxmlformats.org/officeDocument/2006/relationships" id="259" r:id="R56e2dd698e384083"/>
-    <p:sldId xmlns:r="http://schemas.openxmlformats.org/officeDocument/2006/relationships" id="260" r:id="R996e373ab01948cd"/>
-    <p:sldId xmlns:r="http://schemas.openxmlformats.org/officeDocument/2006/relationships" id="261" r:id="Rd46578a62db14ace"/>
-    <p:sldId xmlns:r="http://schemas.openxmlformats.org/officeDocument/2006/relationships" id="262" r:id="R3dfb50a268f54454"/>
-    <p:sldId xmlns:r="http://schemas.openxmlformats.org/officeDocument/2006/relationships" id="263" r:id="Rcd0a566337f440c1"/>
-    <p:sldId xmlns:r="http://schemas.openxmlformats.org/officeDocument/2006/relationships" id="264" r:id="R193f61e559a340c2"/>
-    <p:sldId xmlns:r="http://schemas.openxmlformats.org/officeDocument/2006/relationships" id="265" r:id="R9cd6605bfc62430d"/>
-    <p:sldId xmlns:r="http://schemas.openxmlformats.org/officeDocument/2006/relationships" id="266" r:id="R24e3ab122dea45d5"/>
-    <p:sldId xmlns:r="http://schemas.openxmlformats.org/officeDocument/2006/relationships" id="267" r:id="R4cd376b3e0514275"/>
+    <p:sldId xmlns:r="http://schemas.openxmlformats.org/officeDocument/2006/relationships" id="256" r:id="R137e381d852643ea"/>
+    <p:sldId xmlns:r="http://schemas.openxmlformats.org/officeDocument/2006/relationships" id="257" r:id="R0787c6c2874f4ce2"/>
+    <p:sldId xmlns:r="http://schemas.openxmlformats.org/officeDocument/2006/relationships" id="258" r:id="Rfe2aee3268884f0f"/>
+    <p:sldId xmlns:r="http://schemas.openxmlformats.org/officeDocument/2006/relationships" id="259" r:id="Rd7bb33d73029403b"/>
+    <p:sldId xmlns:r="http://schemas.openxmlformats.org/officeDocument/2006/relationships" id="260" r:id="R5e19af5675634f78"/>
+    <p:sldId xmlns:r="http://schemas.openxmlformats.org/officeDocument/2006/relationships" id="261" r:id="Re0f244a3d4f345c6"/>
+    <p:sldId xmlns:r="http://schemas.openxmlformats.org/officeDocument/2006/relationships" id="262" r:id="R4a2cb2ce3f4d484c"/>
+    <p:sldId xmlns:r="http://schemas.openxmlformats.org/officeDocument/2006/relationships" id="263" r:id="R539accbb9e264954"/>
+    <p:sldId xmlns:r="http://schemas.openxmlformats.org/officeDocument/2006/relationships" id="264" r:id="Rb39e84e8cb5143a7"/>
+    <p:sldId xmlns:r="http://schemas.openxmlformats.org/officeDocument/2006/relationships" id="265" r:id="R618a110478994bf1"/>
+    <p:sldId xmlns:r="http://schemas.openxmlformats.org/officeDocument/2006/relationships" id="266" r:id="R6a65515d42b64873"/>
+    <p:sldId xmlns:r="http://schemas.openxmlformats.org/officeDocument/2006/relationships" id="267" r:id="R059ea6cb228346ff"/>
   </p:sldIdLst>
   <p:sldSz cx="12192000" cy="6858000"/>
   <p:notesSz cx="6858000" cy="9144000"/>
@@ -463,7 +463,7 @@
           </a:p>
           <a:p xmlns:a="http://schemas.openxmlformats.org/drawingml/2006/main">
             <a:r>
-              <a:t>Fontes consultadas em 05/10/2026:</a:t>
+              <a:t>Fontes consultadas em 05/10/2026, regras de poker reconferidas em 06/10/2026:</a:t>
             </a:r>
           </a:p>
           <a:p xmlns:a="http://schemas.openxmlformats.org/drawingml/2006/main">
@@ -553,7 +553,7 @@
           </a:p>
           <a:p xmlns:a="http://schemas.openxmlformats.org/drawingml/2006/main">
             <a:r>
-              <a:t>Fontes consultadas em 05/10/2026:</a:t>
+              <a:t>Fontes consultadas em 05/10/2026, regras de poker reconferidas em 06/10/2026:</a:t>
             </a:r>
           </a:p>
           <a:p xmlns:a="http://schemas.openxmlformats.org/drawingml/2006/main">
@@ -638,7 +638,7 @@
           <a:lstStyle xmlns:a="http://schemas.openxmlformats.org/drawingml/2006/main"/>
           <a:p xmlns:a="http://schemas.openxmlformats.org/drawingml/2006/main">
             <a:r>
-              <a:t>A arquitetura possui motor e estado, provedor de visões, agentes, validador, executor e registro de eventos. O motor prepara a visão autorizada; o agente decide; a ação é validada; então o estado é atualizado. No Trabalho 2, verificaremos execução das três rodadas, conservação das fichas, sigilo e rejeição de ações inválidas. Também verificaremos o encerramento de decisões que excedem o orçamento. Para demonstrar adaptação, o registro interno relacionará observação, política anterior, política atual e ação, sem expor raciocínio privado ao oponente. Assim, poderemos conferir por que B passou a induzir apostas e por que A mudou sua pressão. Esses são critérios planejados, ainda sujeitos à implementação e aos testes.</a:t>
+              <a:t>A arquitetura possui motor e estado, provedor de visões, agentes, validador, executor e registro. Além de vez e saldo, o estado guarda contribuição por etapa, valor a pagar e último aumento completo. O motor calcula quanto transferir em raise, call e all-in. All-in pago devolve excesso e entra em runout sem pedir novas apostas. No Trabalho 2, verificaremos o percurso até 50 e 170, os ramos de all-in, conservação de fichas, sigilo e rejeição de ações inválidas. Os registros privados ligam observação, política anterior, política atual e custo, sem entregar o raciocínio ao oponente. São critérios planejados para implementação futura.</a:t>
             </a:r>
           </a:p>
           <a:p xmlns:a="http://schemas.openxmlformats.org/drawingml/2006/main">
@@ -648,7 +648,7 @@
           </a:p>
           <a:p xmlns:a="http://schemas.openxmlformats.org/drawingml/2006/main">
             <a:r>
-              <a:t>Fontes consultadas em 05/10/2026:</a:t>
+              <a:t>Fontes consultadas em 05/10/2026, regras de poker reconferidas em 06/10/2026:</a:t>
             </a:r>
           </a:p>
           <a:p xmlns:a="http://schemas.openxmlformats.org/drawingml/2006/main">
@@ -743,7 +743,7 @@
           </a:p>
           <a:p xmlns:a="http://schemas.openxmlformats.org/drawingml/2006/main">
             <a:r>
-              <a:t>Fontes consultadas em 05/10/2026:</a:t>
+              <a:t>Fontes consultadas em 05/10/2026, regras de poker reconferidas em 06/10/2026:</a:t>
             </a:r>
           </a:p>
           <a:p xmlns:a="http://schemas.openxmlformats.org/drawingml/2006/main">
@@ -774,6 +774,11 @@
           <a:p xmlns:a="http://schemas.openxmlformats.org/drawingml/2006/main">
             <a:r>
               <a:t>R6: https://cheatsheetseries.owasp.org/cheatsheets/Logging_Cheat_Sheet.html</a:t>
+            </a:r>
+          </a:p>
+          <a:p xmlns:a="http://schemas.openxmlformats.org/drawingml/2006/main">
+            <a:r>
+              <a:t>R7: https://www.pokerstars.com/help/articles/poker-rules-master/229168/</a:t>
             </a:r>
           </a:p>
           <a:p xmlns:a="http://schemas.openxmlformats.org/drawingml/2006/main">
@@ -848,7 +853,7 @@
           <a:lstStyle xmlns:a="http://schemas.openxmlformats.org/drawingml/2006/main"/>
           <a:p xmlns:a="http://schemas.openxmlformats.org/drawingml/2006/main">
             <a:r>
-              <a:t>Delimitamos uma mão com três etapas: flop, turn e river. A preparação é fornecida como estado inicial, sem analisar decisões anteriores. Cada agente recebe suas cartas e observa as cartas públicas, as apostas, os saldos e o pote. O motor controla a vez e valida as decisões. Permitimos check, aposta, pagamento e desistência, com uma aposta de 10 ou 20 por etapa, estritamente menor que o saldo de cada agente. Excluímos aumentos, all-in e potes paralelos. Depois de duas ações check ou de uma aposta paga, avançamos de etapa; uma desistência encerra a mão. Usamos fichas virtuais num ambiente local. Essas simplificações mantêm a proposta viável para o Trabalho 2.</a:t>
+              <a:t>A mão começa antes do flop, com duas cartas privadas para cada agente e nenhuma comunitária aberta. A coloca small blind de 5 e B, big blind de 10. A age primeiro no pré-flop e B nas etapas seguintes. Permitimos check, bet, call, fold, raise e all-in, com fichas inteiras até o saldo. Um raise indica o total da etapa; call paga apenas a diferença. O mínimo de aposta é 10 e o de aumento acompanha o último aumento completo. All-in pago encerra as decisões de aposta: devolvemos excesso não coberto e revelamos as cartas restantes. O relatório também traz um blefe all-in pré-flop, além do percurso principal com quatro etapas.</a:t>
             </a:r>
           </a:p>
           <a:p xmlns:a="http://schemas.openxmlformats.org/drawingml/2006/main">
@@ -858,12 +863,17 @@
           </a:p>
           <a:p xmlns:a="http://schemas.openxmlformats.org/drawingml/2006/main">
             <a:r>
-              <a:t>Fontes consultadas em 05/10/2026:</a:t>
+              <a:t>Fontes consultadas em 05/10/2026, regras de poker reconferidas em 06/10/2026:</a:t>
             </a:r>
           </a:p>
           <a:p xmlns:a="http://schemas.openxmlformats.org/drawingml/2006/main">
             <a:r>
               <a:t>R1: https://www.pokerstars.com/poker/games/texas-holdem/</a:t>
+            </a:r>
+          </a:p>
+          <a:p xmlns:a="http://schemas.openxmlformats.org/drawingml/2006/main">
+            <a:r>
+              <a:t>R7: https://www.pokerstars.com/help/articles/poker-rules-master/229168/</a:t>
             </a:r>
           </a:p>
           <a:p xmlns:a="http://schemas.openxmlformats.org/drawingml/2006/main">
@@ -948,7 +958,7 @@
           </a:p>
           <a:p xmlns:a="http://schemas.openxmlformats.org/drawingml/2006/main">
             <a:r>
-              <a:t>Fontes consultadas em 05/10/2026:</a:t>
+              <a:t>Fontes consultadas em 05/10/2026, regras de poker reconferidas em 06/10/2026:</a:t>
             </a:r>
           </a:p>
           <a:p xmlns:a="http://schemas.openxmlformats.org/drawingml/2006/main">
@@ -1028,7 +1038,7 @@
           <a:lstStyle xmlns:a="http://schemas.openxmlformats.org/drawingml/2006/main"/>
           <a:p xmlns:a="http://schemas.openxmlformats.org/drawingml/2006/main">
             <a:r>
-              <a:t>Esta matriz analisa retrospectivamente um cenário fixo: pote de 40, aposta de 20 e cartas com as quais B vence na revelação. O analista conhece os resultados; durante a mão, os agentes não conhecem as cartas do outro. A pode apostar ou dar check. B paga ou desiste diante da aposta; após check, ambas as políticas seguem para revelação. Se B paga, A perde 20 adicionais e B ganha 60 a partir desse ponto. Se B desiste, A ganha 40. Com check, A ganha zero e B recebe 40. A tabela converte esses ganhos em preferências. O equilíbrio descreve esse jogo reduzido, sem resolver a incerteza dos agentes durante a mão.</a:t>
+              <a:t>Esta matriz analisa o river após o check inicial de B, com pote de 80, aposta de 20 e cartas com as quais B vence. O analista conhece os resultados; os agentes não conhecem as cartas do outro. A aposta ou dá check. B paga ou desiste diante da aposta; check de A encerra a etapa. Raises e all-in continuam permitidos no sistema, mas estão fora desta tabela reduzida. Com call, A perde 20 adicionais e B ganha 100 desse ponto em diante. Com fold, A ganha 80. Com check, A ganha zero e B recebe 80. A tabela converte esses ganhos em preferências. Seu equilíbrio não resolve a incerteza durante a mão.</a:t>
             </a:r>
           </a:p>
           <a:p xmlns:a="http://schemas.openxmlformats.org/drawingml/2006/main">
@@ -1038,7 +1048,7 @@
           </a:p>
           <a:p xmlns:a="http://schemas.openxmlformats.org/drawingml/2006/main">
             <a:r>
-              <a:t>Fontes consultadas em 05/10/2026:</a:t>
+              <a:t>Fontes consultadas em 05/10/2026, regras de poker reconferidas em 06/10/2026:</a:t>
             </a:r>
           </a:p>
           <a:p xmlns:a="http://schemas.openxmlformats.org/drawingml/2006/main">
@@ -1128,7 +1138,7 @@
           </a:p>
           <a:p xmlns:a="http://schemas.openxmlformats.org/drawingml/2006/main">
             <a:r>
-              <a:t>Fontes consultadas em 05/10/2026:</a:t>
+              <a:t>Fontes consultadas em 05/10/2026, regras de poker reconferidas em 06/10/2026:</a:t>
             </a:r>
           </a:p>
           <a:p xmlns:a="http://schemas.openxmlformats.org/drawingml/2006/main">
@@ -1208,7 +1218,7 @@
           <a:lstStyle xmlns:a="http://schemas.openxmlformats.org/drawingml/2006/main"/>
           <a:p xmlns:a="http://schemas.openxmlformats.org/drawingml/2006/main">
             <a:r>
-              <a:t>Cada agente começa com 100 fichas e o pote contém 20 anteriores. No flop, A aposta 10 e B paga. A observa resistência e passa a dar check para observar. B vê a iniciativa de A e muda sua política: em vez de apostar ao receber check, tenta induzir outra aposta. No turn, ambos dão check. B aceita perder uma oportunidade de ganho; A interpreta esse sinal como fraqueza. No river, A blefa 20 e B paga, vencendo com trinca de ases. Os saldos finais são 70 e 150, conservando 220 fichas. A leitura de A falhou. Essa decisão fora do equilíbrio retrospectivo é possível porque os agentes usam heurísticas e informação parcial. Uma mão não demonstra uma estratégia ótima.</a:t>
+              <a:t>No pré-flop, A aumenta para 20 e B paga, levando o pote a 40. A mantém pressão pequena. No flop, B dá check, A aposta 10 e B aumenta para 20. A paga só mais 10. O pote chega a 80. O raise leva A à cautela; o call leva B a trocar aposta por valor por check visando indução. No turn, B dá check e A também. A interpreta a ausência de nova aposta como fraqueza. No river, B repete check, A blefa 20 e B paga. B vence com trinca: A termina com 50 e B com 170. No ramo all-in pré-flop, fold dá 120 a A; call leva à revelação sem novas apostas e, nesta mesa, B termina com 220.</a:t>
             </a:r>
           </a:p>
           <a:p xmlns:a="http://schemas.openxmlformats.org/drawingml/2006/main">
@@ -1218,12 +1228,22 @@
           </a:p>
           <a:p xmlns:a="http://schemas.openxmlformats.org/drawingml/2006/main">
             <a:r>
-              <a:t>Fontes consultadas em 05/10/2026:</a:t>
+              <a:t>Fontes consultadas em 05/10/2026, regras de poker reconferidas em 06/10/2026:</a:t>
+            </a:r>
+          </a:p>
+          <a:p xmlns:a="http://schemas.openxmlformats.org/drawingml/2006/main">
+            <a:r>
+              <a:t>R1: https://www.pokerstars.com/poker/games/texas-holdem/</a:t>
             </a:r>
           </a:p>
           <a:p xmlns:a="http://schemas.openxmlformats.org/drawingml/2006/main">
             <a:r>
               <a:t>R2: https://www.pokerstars.com/poker/games/rules/hand-rankings/</a:t>
+            </a:r>
+          </a:p>
+          <a:p xmlns:a="http://schemas.openxmlformats.org/drawingml/2006/main">
+            <a:r>
+              <a:t>R7: https://www.pokerstars.com/help/articles/poker-rules-master/229168/</a:t>
             </a:r>
           </a:p>
           <a:p xmlns:a="http://schemas.openxmlformats.org/drawingml/2006/main">
@@ -1298,7 +1318,7 @@
           <a:lstStyle xmlns:a="http://schemas.openxmlformats.org/drawingml/2006/main"/>
           <a:p xmlns:a="http://schemas.openxmlformats.org/drawingml/2006/main">
             <a:r>
-              <a:t>As três rodadas usam chamadas de observação, decisão e validação. Nessas mesmas interfaces, analisamos três desvios: T1 expõe cartas na visão de estado; T2 aceita uma ação inválida; T3 deixa uma decisão bloquear a execução. São cenários hipotéticos anteriores aos controles, supondo um agente deliberadamente adversarial e a fraqueza indicada. O diagrama liga cada ponto ao ativo afetado. As rodadas apresentadas seguem ações legais; os riscos mostram o que poderia falhar nessas chamadas. Blefar continua permitido. Perder legitimamente é diferente de perder porque o adversário recebeu informação privada ou alterou as regras.</a:t>
+              <a:t>As quatro etapas usam chamadas de observação, decisão e validação. Nessas mesmas interfaces, analisamos três desvios: T1 expõe cartas na visão de estado; T2 aceita uma ação inválida; T3 deixa uma decisão bloquear a execução. São cenários hipotéticos anteriores aos controles, supondo um agente deliberadamente adversarial e a fraqueza indicada. O diagrama liga cada ponto ao ativo afetado. As etapas apresentadas seguem ações legais; os riscos mostram o que poderia falhar nessas chamadas. Blefar continua permitido. Perder legitimamente é diferente de perder porque o adversário recebeu informação privada ou alterou as regras.</a:t>
             </a:r>
           </a:p>
           <a:p xmlns:a="http://schemas.openxmlformats.org/drawingml/2006/main">
@@ -1308,7 +1328,7 @@
           </a:p>
           <a:p xmlns:a="http://schemas.openxmlformats.org/drawingml/2006/main">
             <a:r>
-              <a:t>Fontes consultadas em 05/10/2026:</a:t>
+              <a:t>Fontes consultadas em 05/10/2026, regras de poker reconferidas em 06/10/2026:</a:t>
             </a:r>
           </a:p>
           <a:p xmlns:a="http://schemas.openxmlformats.org/drawingml/2006/main">
@@ -1398,7 +1418,7 @@
           </a:p>
           <a:p xmlns:a="http://schemas.openxmlformats.org/drawingml/2006/main">
             <a:r>
-              <a:t>Fontes consultadas em 05/10/2026:</a:t>
+              <a:t>Fontes consultadas em 05/10/2026, regras de poker reconferidas em 06/10/2026:</a:t>
             </a:r>
           </a:p>
           <a:p xmlns:a="http://schemas.openxmlformats.org/drawingml/2006/main">
@@ -1488,7 +1508,7 @@
           </a:p>
           <a:p xmlns:a="http://schemas.openxmlformats.org/drawingml/2006/main">
             <a:r>
-              <a:t>Fontes consultadas em 05/10/2026:</a:t>
+              <a:t>Fontes consultadas em 05/10/2026, regras de poker reconferidas em 06/10/2026:</a:t>
             </a:r>
           </a:p>
           <a:p xmlns:a="http://schemas.openxmlformats.org/drawingml/2006/main">
@@ -1566,7 +1586,7 @@
   </p:cSld>
   <p:clrMap bg1="lt1" tx1="dk1" bg2="lt2" tx2="dk2" accent1="accent1" accent2="accent2" accent3="accent3" accent4="accent4" accent5="accent5" accent6="accent6" hlink="hlink" folHlink="folHlink"/>
   <p:sldLayoutIdLst>
-    <p:sldLayoutId xmlns:r="http://schemas.openxmlformats.org/officeDocument/2006/relationships" id="2147483649" r:id="Rded4f01d8c224460"/>
+    <p:sldLayoutId xmlns:r="http://schemas.openxmlformats.org/officeDocument/2006/relationships" id="2147483649" r:id="R5bd41a7dbbb34125"/>
   </p:sldLayoutIdLst>
   <p:txStyles>
     <p:titleStyle>
@@ -2117,7 +2137,7 @@
           <p:cNvPr id="6" name="Poker Adversarial">
             <a:extLst xmlns:a="http://schemas.openxmlformats.org/drawingml/2006/main">
               <a:ext uri="{FF2B5EF4-FFF2-40B4-BE49-F238E27FC236}">
-                <a16:creationId xmlns:a16="http://schemas.microsoft.com/office/drawing/2014/main" id="{0D4A84D0-4D41-4562-A8F9-43DE56C081FD}"/>
+                <a16:creationId xmlns:a16="http://schemas.microsoft.com/office/drawing/2014/main" id="{6739A509-98EA-4838-BE28-704F1A4B29B9}"/>
               </a:ext>
             </a:extLst>
           </p:cNvPr>
@@ -2174,7 +2194,7 @@
           <p:cNvPr id="2" name="Grupo 7 · Poker Adversarial · 1/12">
             <a:extLst xmlns:a="http://schemas.openxmlformats.org/drawingml/2006/main">
               <a:ext uri="{FF2B5EF4-FFF2-40B4-BE49-F238E27FC236}">
-                <a16:creationId xmlns:a16="http://schemas.microsoft.com/office/drawing/2014/main" id="{D462E0DE-1743-4D0C-8CDD-760E570FE09D}"/>
+                <a16:creationId xmlns:a16="http://schemas.microsoft.com/office/drawing/2014/main" id="{5E784C1C-85DB-4A46-A8DF-6799C460B686}"/>
               </a:ext>
             </a:extLst>
           </p:cNvPr>
@@ -2231,7 +2251,7 @@
           <p:cNvPr id="3" name="Dois agentes decidem com informação parcial">
             <a:extLst xmlns:a="http://schemas.openxmlformats.org/drawingml/2006/main">
               <a:ext uri="{FF2B5EF4-FFF2-40B4-BE49-F238E27FC236}">
-                <a16:creationId xmlns:a16="http://schemas.microsoft.com/office/drawing/2014/main" id="{D1503122-5936-4D7D-AB4A-1C16697DDBE9}"/>
+                <a16:creationId xmlns:a16="http://schemas.microsoft.com/office/drawing/2014/main" id="{EED01BC1-723C-4407-A029-9910BA589D52}"/>
               </a:ext>
             </a:extLst>
           </p:cNvPr>
@@ -2288,7 +2308,7 @@
           <p:cNvPr id="4" name="Trabalho 1 · Engenharia de Software Adversarial">
             <a:extLst xmlns:a="http://schemas.openxmlformats.org/drawingml/2006/main">
               <a:ext uri="{FF2B5EF4-FFF2-40B4-BE49-F238E27FC236}">
-                <a16:creationId xmlns:a16="http://schemas.microsoft.com/office/drawing/2014/main" id="{294A5FF2-6D4A-44B9-AE87-ED9E681EF0D0}"/>
+                <a16:creationId xmlns:a16="http://schemas.microsoft.com/office/drawing/2014/main" id="{9C532547-F0DB-46EF-B61A-6A8098F65D3C}"/>
               </a:ext>
             </a:extLst>
           </p:cNvPr>
@@ -2345,7 +2365,7 @@
           <p:cNvPr id="5" name="Rafael Barboza Torres&#10;Elton Henrique Lunardi Gimenes&#10;Frederico Ma">
             <a:extLst xmlns:a="http://schemas.openxmlformats.org/drawingml/2006/main">
               <a:ext uri="{FF2B5EF4-FFF2-40B4-BE49-F238E27FC236}">
-                <a16:creationId xmlns:a16="http://schemas.microsoft.com/office/drawing/2014/main" id="{0917A25B-E34D-4CE7-BAFE-423761D5EEDB}"/>
+                <a16:creationId xmlns:a16="http://schemas.microsoft.com/office/drawing/2014/main" id="{35C7BDD5-EA6B-4E73-B254-33005E82BA59}"/>
               </a:ext>
             </a:extLst>
           </p:cNvPr>
@@ -2469,7 +2489,7 @@
     </p:spTree>
     <p:extLst>
       <p:ext uri="{BB962C8B-B14F-4D97-AF65-F5344CB8AC3E}">
-        <p14:creationId xmlns:p14="http://schemas.microsoft.com/office/powerpoint/2010/main" val="661040930"/>
+        <p14:creationId xmlns:p14="http://schemas.microsoft.com/office/powerpoint/2010/main" val="891450135"/>
       </p:ext>
     </p:extLst>
   </p:cSld>
@@ -2500,7 +2520,7 @@
           <p:cNvPr id="6" name="Redesenho e custos">
             <a:extLst xmlns:a="http://schemas.openxmlformats.org/drawingml/2006/main">
               <a:ext uri="{FF2B5EF4-FFF2-40B4-BE49-F238E27FC236}">
-                <a16:creationId xmlns:a16="http://schemas.microsoft.com/office/drawing/2014/main" id="{EE02F283-DD94-4C63-9784-19971D58D829}"/>
+                <a16:creationId xmlns:a16="http://schemas.microsoft.com/office/drawing/2014/main" id="{DB716ABB-F3B2-4F12-8C61-5ACC22B71D25}"/>
               </a:ext>
             </a:extLst>
           </p:cNvPr>
@@ -2557,7 +2577,7 @@
           <p:cNvPr id="2" name="Grupo 7 · Poker Adversarial · 10/12">
             <a:extLst xmlns:a="http://schemas.openxmlformats.org/drawingml/2006/main">
               <a:ext uri="{FF2B5EF4-FFF2-40B4-BE49-F238E27FC236}">
-                <a16:creationId xmlns:a16="http://schemas.microsoft.com/office/drawing/2014/main" id="{A208D65F-38E0-4AB6-B410-D7D228647132}"/>
+                <a16:creationId xmlns:a16="http://schemas.microsoft.com/office/drawing/2014/main" id="{5347C417-E905-425C-AAFD-D060FDD869A6}"/>
               </a:ext>
             </a:extLst>
           </p:cNvPr>
@@ -2969,7 +2989,7 @@
           <p:cNvPr id="4" name="Ação padrão: check quando legal, fold diante de aposta pendente.">
             <a:extLst xmlns:a="http://schemas.openxmlformats.org/drawingml/2006/main">
               <a:ext uri="{FF2B5EF4-FFF2-40B4-BE49-F238E27FC236}">
-                <a16:creationId xmlns:a16="http://schemas.microsoft.com/office/drawing/2014/main" id="{25B5EF63-53C9-44DA-8BA0-AAC98500DB2A}"/>
+                <a16:creationId xmlns:a16="http://schemas.microsoft.com/office/drawing/2014/main" id="{EEC8EA07-129C-4124-BED4-192334A53B74}"/>
               </a:ext>
             </a:extLst>
           </p:cNvPr>
@@ -3026,7 +3046,7 @@
           <p:cNvPr id="5" name="Auditoria e invariantes ajudam a detectar falhas. O risco residua">
             <a:extLst xmlns:a="http://schemas.openxmlformats.org/drawingml/2006/main">
               <a:ext uri="{FF2B5EF4-FFF2-40B4-BE49-F238E27FC236}">
-                <a16:creationId xmlns:a16="http://schemas.microsoft.com/office/drawing/2014/main" id="{6C6C1036-0FCC-4EF6-A533-B3EAD571AC93}"/>
+                <a16:creationId xmlns:a16="http://schemas.microsoft.com/office/drawing/2014/main" id="{86DC25DB-6EDF-4160-A787-A056FE011516}"/>
               </a:ext>
             </a:extLst>
           </p:cNvPr>
@@ -3081,7 +3101,7 @@
     </p:spTree>
     <p:extLst>
       <p:ext uri="{BB962C8B-B14F-4D97-AF65-F5344CB8AC3E}">
-        <p14:creationId xmlns:p14="http://schemas.microsoft.com/office/powerpoint/2010/main" val="2073789570"/>
+        <p14:creationId xmlns:p14="http://schemas.microsoft.com/office/powerpoint/2010/main" val="770480844"/>
       </p:ext>
     </p:extLst>
   </p:cSld>
@@ -3109,10 +3129,10 @@
       </p:grpSpPr>
       <p:sp>
         <p:nvSpPr>
-          <p:cNvPr id="16" name="Arquitetura para o Trabalho 2">
+          <p:cNvPr id="17" name="Arquitetura para o Trabalho 2">
             <a:extLst xmlns:a="http://schemas.openxmlformats.org/drawingml/2006/main">
               <a:ext uri="{FF2B5EF4-FFF2-40B4-BE49-F238E27FC236}">
-                <a16:creationId xmlns:a16="http://schemas.microsoft.com/office/drawing/2014/main" id="{7AF2092B-698B-4CD7-B489-F03D7BFC6DA6}"/>
+                <a16:creationId xmlns:a16="http://schemas.microsoft.com/office/drawing/2014/main" id="{2B261291-AFC2-4BB3-B74E-6451E78E93EC}"/>
               </a:ext>
             </a:extLst>
           </p:cNvPr>
@@ -3169,7 +3189,7 @@
           <p:cNvPr id="2" name="Grupo 7 · Poker Adversarial · 11/12">
             <a:extLst xmlns:a="http://schemas.openxmlformats.org/drawingml/2006/main">
               <a:ext uri="{FF2B5EF4-FFF2-40B4-BE49-F238E27FC236}">
-                <a16:creationId xmlns:a16="http://schemas.microsoft.com/office/drawing/2014/main" id="{3ECFECFE-541C-4696-9143-D103050BA04A}"/>
+                <a16:creationId xmlns:a16="http://schemas.microsoft.com/office/drawing/2014/main" id="{677E4621-77AC-4DAD-B473-2EB15AE65854}"/>
               </a:ext>
             </a:extLst>
           </p:cNvPr>
@@ -3226,7 +3246,7 @@
           <p:cNvPr id="3" name="Motor e estado">
             <a:extLst xmlns:a="http://schemas.openxmlformats.org/drawingml/2006/main">
               <a:ext uri="{FF2B5EF4-FFF2-40B4-BE49-F238E27FC236}">
-                <a16:creationId xmlns:a16="http://schemas.microsoft.com/office/drawing/2014/main" id="{2B3B98C8-A25E-4F9F-BE28-E5EB7FC24B5D}"/>
+                <a16:creationId xmlns:a16="http://schemas.microsoft.com/office/drawing/2014/main" id="{234C62EA-0793-4E78-B8C6-A94A93331FDD}"/>
               </a:ext>
             </a:extLst>
           </p:cNvPr>
@@ -3287,7 +3307,7 @@
           <p:cNvPr id="4" name="Visão filtrada">
             <a:extLst xmlns:a="http://schemas.openxmlformats.org/drawingml/2006/main">
               <a:ext uri="{FF2B5EF4-FFF2-40B4-BE49-F238E27FC236}">
-                <a16:creationId xmlns:a16="http://schemas.microsoft.com/office/drawing/2014/main" id="{65EE24F8-D66F-4FC8-86A6-8A9942C8869D}"/>
+                <a16:creationId xmlns:a16="http://schemas.microsoft.com/office/drawing/2014/main" id="{5501ADF6-F6B2-4E9D-8BA3-D32AF3969CBE}"/>
               </a:ext>
             </a:extLst>
           </p:cNvPr>
@@ -3348,7 +3368,7 @@
           <p:cNvPr id="5" name="Agente e executor">
             <a:extLst xmlns:a="http://schemas.openxmlformats.org/drawingml/2006/main">
               <a:ext uri="{FF2B5EF4-FFF2-40B4-BE49-F238E27FC236}">
-                <a16:creationId xmlns:a16="http://schemas.microsoft.com/office/drawing/2014/main" id="{0B5FF3DE-454E-49EE-8D0A-2B63963D9497}"/>
+                <a16:creationId xmlns:a16="http://schemas.microsoft.com/office/drawing/2014/main" id="{17CDFACB-FFBF-44E7-AA40-EFEC25B8679A}"/>
               </a:ext>
             </a:extLst>
           </p:cNvPr>
@@ -3409,7 +3429,7 @@
           <p:cNvPr id="6" name="Validação">
             <a:extLst xmlns:a="http://schemas.openxmlformats.org/drawingml/2006/main">
               <a:ext uri="{FF2B5EF4-FFF2-40B4-BE49-F238E27FC236}">
-                <a16:creationId xmlns:a16="http://schemas.microsoft.com/office/drawing/2014/main" id="{AD16CFA4-DA49-4199-BC64-FF032F13B46C}"/>
+                <a16:creationId xmlns:a16="http://schemas.microsoft.com/office/drawing/2014/main" id="{FD124136-D67F-4BA6-B14E-20C5182923D7}"/>
               </a:ext>
             </a:extLst>
           </p:cNvPr>
@@ -3470,7 +3490,7 @@
           <p:cNvPr id="7" name="Atualização e registro">
             <a:extLst xmlns:a="http://schemas.openxmlformats.org/drawingml/2006/main">
               <a:ext uri="{FF2B5EF4-FFF2-40B4-BE49-F238E27FC236}">
-                <a16:creationId xmlns:a16="http://schemas.microsoft.com/office/drawing/2014/main" id="{D38DD9BF-D0A3-4B55-ABF6-CED078CCBB1E}"/>
+                <a16:creationId xmlns:a16="http://schemas.microsoft.com/office/drawing/2014/main" id="{0ADDCB0E-A79D-47BD-94CB-AB15E33A70EA}"/>
               </a:ext>
             </a:extLst>
           </p:cNvPr>
@@ -3528,7 +3548,7 @@
       </p:sp>
       <p:cxnSp>
         <p:nvCxnSpPr>
-          <p:cNvPr id="23" name=""/>
+          <p:cNvPr id="24" name=""/>
           <p:cNvCxnSpPr>
             <a:stCxn xmlns:a="http://schemas.openxmlformats.org/drawingml/2006/main" id="3" idx="3"/>
             <a:endCxn xmlns:a="http://schemas.openxmlformats.org/drawingml/2006/main" id="4" idx="1"/>
@@ -3554,7 +3574,7 @@
       </p:cxnSp>
       <p:cxnSp>
         <p:nvCxnSpPr>
-          <p:cNvPr id="24" name=""/>
+          <p:cNvPr id="25" name=""/>
           <p:cNvCxnSpPr>
             <a:stCxn xmlns:a="http://schemas.openxmlformats.org/drawingml/2006/main" id="4" idx="3"/>
             <a:endCxn xmlns:a="http://schemas.openxmlformats.org/drawingml/2006/main" id="5" idx="1"/>
@@ -3580,7 +3600,7 @@
       </p:cxnSp>
       <p:cxnSp>
         <p:nvCxnSpPr>
-          <p:cNvPr id="25" name=""/>
+          <p:cNvPr id="26" name=""/>
           <p:cNvCxnSpPr>
             <a:stCxn xmlns:a="http://schemas.openxmlformats.org/drawingml/2006/main" id="5" idx="2"/>
             <a:endCxn xmlns:a="http://schemas.openxmlformats.org/drawingml/2006/main" id="6" idx="0"/>
@@ -3606,7 +3626,7 @@
       </p:cxnSp>
       <p:cxnSp>
         <p:nvCxnSpPr>
-          <p:cNvPr id="26" name=""/>
+          <p:cNvPr id="27" name=""/>
           <p:cNvCxnSpPr>
             <a:stCxn xmlns:a="http://schemas.openxmlformats.org/drawingml/2006/main" id="6" idx="1"/>
             <a:endCxn xmlns:a="http://schemas.openxmlformats.org/drawingml/2006/main" id="7" idx="3"/>
@@ -3632,7 +3652,7 @@
       </p:cxnSp>
       <p:cxnSp>
         <p:nvCxnSpPr>
-          <p:cNvPr id="27" name=""/>
+          <p:cNvPr id="28" name=""/>
           <p:cNvCxnSpPr>
             <a:stCxn xmlns:a="http://schemas.openxmlformats.org/drawingml/2006/main" id="7" idx="1"/>
             <a:endCxn xmlns:a="http://schemas.openxmlformats.org/drawingml/2006/main" id="3" idx="2"/>
@@ -3661,7 +3681,7 @@
           <p:cNvPr id="13" name="Critérios: 220 fichas, visões autorizadas e ações aplicadas uma v">
             <a:extLst xmlns:a="http://schemas.openxmlformats.org/drawingml/2006/main">
               <a:ext uri="{FF2B5EF4-FFF2-40B4-BE49-F238E27FC236}">
-                <a16:creationId xmlns:a16="http://schemas.microsoft.com/office/drawing/2014/main" id="{CF5E1467-A708-4EFA-B692-C409BD4FA16C}"/>
+                <a16:creationId xmlns:a16="http://schemas.microsoft.com/office/drawing/2014/main" id="{3D03A2C4-3641-453C-A0D8-75E98054EABA}"/>
               </a:ext>
             </a:extLst>
           </p:cNvPr>
@@ -3715,10 +3735,10 @@
       </p:sp>
       <p:sp>
         <p:nvSpPr>
-          <p:cNvPr id="14" name="Registro interno: observação, política anterior, política atual e">
+          <p:cNvPr id="14" name="Estado: contribuição por etapa, valor a pagar e aumento mínimo.">
             <a:extLst xmlns:a="http://schemas.openxmlformats.org/drawingml/2006/main">
               <a:ext uri="{FF2B5EF4-FFF2-40B4-BE49-F238E27FC236}">
-                <a16:creationId xmlns:a16="http://schemas.microsoft.com/office/drawing/2014/main" id="{B3D824B5-BBBD-430B-96BA-6D0E7A734B3E}"/>
+                <a16:creationId xmlns:a16="http://schemas.microsoft.com/office/drawing/2014/main" id="{95C766FC-49F7-4E15-BB26-D7BE017C9783}"/>
               </a:ext>
             </a:extLst>
           </p:cNvPr>
@@ -3729,8 +3749,8 @@
         </p:nvSpPr>
         <p:spPr>
           <a:xfrm xmlns:a="http://schemas.openxmlformats.org/drawingml/2006/main">
-            <a:off x="571500" y="5543550"/>
-            <a:ext cx="11049000" cy="571500"/>
+            <a:off x="571500" y="5524500"/>
+            <a:ext cx="11049000" cy="428625"/>
           </a:xfrm>
           <a:prstGeom xmlns:a="http://schemas.openxmlformats.org/drawingml/2006/main" prst="rect">
             <a:avLst/>
@@ -3747,7 +3767,7 @@
           <a:lstStyle xmlns:a="http://schemas.openxmlformats.org/drawingml/2006/main"/>
           <a:p xmlns:a="http://schemas.openxmlformats.org/drawingml/2006/main">
             <a:pPr algn="l">
-              <a:defRPr sz="2100" b="0">
+              <a:defRPr sz="2025" b="0">
                 <a:solidFill>
                   <a:srgbClr val="143042"/>
                 </a:solidFill>
@@ -3757,7 +3777,7 @@
               </a:defRPr>
             </a:pPr>
             <a:r>
-              <a:rPr sz="2100" b="0">
+              <a:rPr sz="2025" b="0">
                 <a:solidFill>
                   <a:srgbClr val="143042"/>
                 </a:solidFill>
@@ -3765,17 +3785,74 @@
                 <a:ea typeface="Arial"/>
                 <a:cs typeface="Arial"/>
               </a:rPr>
-              <a:t>Registro interno: observação, política anterior, política atual e ação.</a:t>
-            </a:r>
-          </a:p>
-        </p:txBody>
-      </p:sp>
-      <p:sp>
-        <p:nvSpPr>
-          <p:cNvPr id="15" name="Planejamento de implementação. Critérios ainda não testados em mo">
+              <a:t>Estado: contribuição por etapa, valor a pagar e aumento mínimo.</a:t>
+            </a:r>
+          </a:p>
+        </p:txBody>
+      </p:sp>
+      <p:sp>
+        <p:nvSpPr>
+          <p:cNvPr id="15" name="Registro privado: observação, mudança de política e custo.">
             <a:extLst xmlns:a="http://schemas.openxmlformats.org/drawingml/2006/main">
               <a:ext uri="{FF2B5EF4-FFF2-40B4-BE49-F238E27FC236}">
-                <a16:creationId xmlns:a16="http://schemas.microsoft.com/office/drawing/2014/main" id="{AA3C6C15-AB39-40F9-8D81-8888BEB4256E}"/>
+                <a16:creationId xmlns:a16="http://schemas.microsoft.com/office/drawing/2014/main" id="{B2A6E3E1-686F-4432-8392-3673A76903AB}"/>
+              </a:ext>
+            </a:extLst>
+          </p:cNvPr>
+          <p:cNvSpPr>
+            <a:spLocks xmlns:a="http://schemas.openxmlformats.org/drawingml/2006/main" noGrp="1"/>
+          </p:cNvSpPr>
+          <p:nvPr/>
+        </p:nvSpPr>
+        <p:spPr>
+          <a:xfrm xmlns:a="http://schemas.openxmlformats.org/drawingml/2006/main">
+            <a:off x="571500" y="5905500"/>
+            <a:ext cx="11049000" cy="285750"/>
+          </a:xfrm>
+          <a:prstGeom xmlns:a="http://schemas.openxmlformats.org/drawingml/2006/main" prst="rect">
+            <a:avLst/>
+          </a:prstGeom>
+          <a:noFill xmlns:a="http://schemas.openxmlformats.org/drawingml/2006/main"/>
+          <a:ln xmlns:a="http://schemas.openxmlformats.org/drawingml/2006/main" w="0">
+            <a:noFill/>
+          </a:ln>
+        </p:spPr>
+        <p:txBody>
+          <a:bodyPr xmlns:a="http://schemas.openxmlformats.org/drawingml/2006/main" wrap="square" lIns="0" tIns="0" rIns="0" bIns="0" anchor="t">
+            <a:noAutofit/>
+          </a:bodyPr>
+          <a:lstStyle xmlns:a="http://schemas.openxmlformats.org/drawingml/2006/main"/>
+          <a:p xmlns:a="http://schemas.openxmlformats.org/drawingml/2006/main">
+            <a:pPr algn="l">
+              <a:defRPr sz="1650" b="0">
+                <a:solidFill>
+                  <a:srgbClr val="486274"/>
+                </a:solidFill>
+                <a:latin typeface="Arial"/>
+                <a:ea typeface="Arial"/>
+                <a:cs typeface="Arial"/>
+              </a:defRPr>
+            </a:pPr>
+            <a:r>
+              <a:rPr sz="1650" b="0">
+                <a:solidFill>
+                  <a:srgbClr val="486274"/>
+                </a:solidFill>
+                <a:latin typeface="Arial"/>
+                <a:ea typeface="Arial"/>
+                <a:cs typeface="Arial"/>
+              </a:rPr>
+              <a:t>Registro privado: observação, mudança de política e custo.</a:t>
+            </a:r>
+          </a:p>
+        </p:txBody>
+      </p:sp>
+      <p:sp>
+        <p:nvSpPr>
+          <p:cNvPr id="16" name="Planejamento de implementação. Critérios ainda não testados em mo">
+            <a:extLst xmlns:a="http://schemas.openxmlformats.org/drawingml/2006/main">
+              <a:ext uri="{FF2B5EF4-FFF2-40B4-BE49-F238E27FC236}">
+                <a16:creationId xmlns:a16="http://schemas.microsoft.com/office/drawing/2014/main" id="{C2D91753-364F-415A-B68C-135D59DDCE8A}"/>
               </a:ext>
             </a:extLst>
           </p:cNvPr>
@@ -3830,7 +3907,7 @@
     </p:spTree>
     <p:extLst>
       <p:ext uri="{BB962C8B-B14F-4D97-AF65-F5344CB8AC3E}">
-        <p14:creationId xmlns:p14="http://schemas.microsoft.com/office/powerpoint/2010/main" val="71864688"/>
+        <p14:creationId xmlns:p14="http://schemas.microsoft.com/office/powerpoint/2010/main" val="1523609523"/>
       </p:ext>
     </p:extLst>
   </p:cSld>
@@ -3861,7 +3938,7 @@
           <p:cNvPr id="8" name="Aprendizado e propriedades preservadas">
             <a:extLst xmlns:a="http://schemas.openxmlformats.org/drawingml/2006/main">
               <a:ext uri="{FF2B5EF4-FFF2-40B4-BE49-F238E27FC236}">
-                <a16:creationId xmlns:a16="http://schemas.microsoft.com/office/drawing/2014/main" id="{F1895B62-7230-4315-AC45-39705C5B52E6}"/>
+                <a16:creationId xmlns:a16="http://schemas.microsoft.com/office/drawing/2014/main" id="{25AEE371-97B8-492F-88FB-3D5041532E5A}"/>
               </a:ext>
             </a:extLst>
           </p:cNvPr>
@@ -3918,7 +3995,7 @@
           <p:cNvPr id="2" name="Grupo 7 · Poker Adversarial · 12/12">
             <a:extLst xmlns:a="http://schemas.openxmlformats.org/drawingml/2006/main">
               <a:ext uri="{FF2B5EF4-FFF2-40B4-BE49-F238E27FC236}">
-                <a16:creationId xmlns:a16="http://schemas.microsoft.com/office/drawing/2014/main" id="{83300B7E-6E1C-4DBD-9064-E6C9ABC6FD66}"/>
+                <a16:creationId xmlns:a16="http://schemas.microsoft.com/office/drawing/2014/main" id="{F6B87696-541A-47FB-B728-3845961B2898}"/>
               </a:ext>
             </a:extLst>
           </p:cNvPr>
@@ -3975,7 +4052,7 @@
           <p:cNvPr id="3" name="O outro lado aprende com ações e limites observáveis">
             <a:extLst xmlns:a="http://schemas.openxmlformats.org/drawingml/2006/main">
               <a:ext uri="{FF2B5EF4-FFF2-40B4-BE49-F238E27FC236}">
-                <a16:creationId xmlns:a16="http://schemas.microsoft.com/office/drawing/2014/main" id="{7F4F01B9-6BCB-4259-BA76-23E4A85D5296}"/>
+                <a16:creationId xmlns:a16="http://schemas.microsoft.com/office/drawing/2014/main" id="{91E3030D-B2F9-4A7C-93BE-AF0C7F5AFF74}"/>
               </a:ext>
             </a:extLst>
           </p:cNvPr>
@@ -4032,7 +4109,7 @@
           <p:cNvPr id="4" name="Pode rever blefes, decisões de pagar e caminhos de acesso à infor">
             <a:extLst xmlns:a="http://schemas.openxmlformats.org/drawingml/2006/main">
               <a:ext uri="{FF2B5EF4-FFF2-40B4-BE49-F238E27FC236}">
-                <a16:creationId xmlns:a16="http://schemas.microsoft.com/office/drawing/2014/main" id="{FA4F85E0-F936-4D93-A979-A55FA2A3A1D3}"/>
+                <a16:creationId xmlns:a16="http://schemas.microsoft.com/office/drawing/2014/main" id="{D8CAD620-A6BB-4929-BE64-7D7750A22AE1}"/>
               </a:ext>
             </a:extLst>
           </p:cNvPr>
@@ -4089,7 +4166,7 @@
           <p:cNvPr id="5" name="O motor preserva sigilo, fichas e progresso da mão.">
             <a:extLst xmlns:a="http://schemas.openxmlformats.org/drawingml/2006/main">
               <a:ext uri="{FF2B5EF4-FFF2-40B4-BE49-F238E27FC236}">
-                <a16:creationId xmlns:a16="http://schemas.microsoft.com/office/drawing/2014/main" id="{983D5CC8-F303-4D01-94B0-CD683301432C}"/>
+                <a16:creationId xmlns:a16="http://schemas.microsoft.com/office/drawing/2014/main" id="{1FD3B433-2411-4BB1-B240-3C999D688F29}"/>
               </a:ext>
             </a:extLst>
           </p:cNvPr>
@@ -4146,7 +4223,7 @@
           <p:cNvPr id="6" name="Fontes: PokerStars (regras e mãos), MIT (teoria dos jogos)&#10;e OWAS">
             <a:extLst xmlns:a="http://schemas.openxmlformats.org/drawingml/2006/main">
               <a:ext uri="{FF2B5EF4-FFF2-40B4-BE49-F238E27FC236}">
-                <a16:creationId xmlns:a16="http://schemas.microsoft.com/office/drawing/2014/main" id="{3AA12633-60AD-425B-A172-481036C04A3F}"/>
+                <a16:creationId xmlns:a16="http://schemas.microsoft.com/office/drawing/2014/main" id="{0F0C17CF-289B-4A84-B47B-1E2DA83A6FBB}"/>
               </a:ext>
             </a:extLst>
           </p:cNvPr>
@@ -4226,7 +4303,7 @@
           <p:cNvPr id="7" name="Uso de IA: Codex na pesquisa, redação e produção dos materiais.&#10;R">
             <a:extLst xmlns:a="http://schemas.openxmlformats.org/drawingml/2006/main">
               <a:ext uri="{FF2B5EF4-FFF2-40B4-BE49-F238E27FC236}">
-                <a16:creationId xmlns:a16="http://schemas.microsoft.com/office/drawing/2014/main" id="{47757BB0-76E4-41FD-8699-BF00C0384357}"/>
+                <a16:creationId xmlns:a16="http://schemas.microsoft.com/office/drawing/2014/main" id="{B9C090B7-A1F3-4ABF-969E-A7CD552580C8}"/>
               </a:ext>
             </a:extLst>
           </p:cNvPr>
@@ -4304,7 +4381,7 @@
     </p:spTree>
     <p:extLst>
       <p:ext uri="{BB962C8B-B14F-4D97-AF65-F5344CB8AC3E}">
-        <p14:creationId xmlns:p14="http://schemas.microsoft.com/office/powerpoint/2010/main" val="346338006"/>
+        <p14:creationId xmlns:p14="http://schemas.microsoft.com/office/powerpoint/2010/main" val="1365784652"/>
       </p:ext>
     </p:extLst>
   </p:cSld>
@@ -4335,7 +4412,7 @@
           <p:cNvPr id="6" name="Recorte e regras">
             <a:extLst xmlns:a="http://schemas.openxmlformats.org/drawingml/2006/main">
               <a:ext uri="{FF2B5EF4-FFF2-40B4-BE49-F238E27FC236}">
-                <a16:creationId xmlns:a16="http://schemas.microsoft.com/office/drawing/2014/main" id="{B4EFD324-E050-4CE1-AB50-B154E0BB5262}"/>
+                <a16:creationId xmlns:a16="http://schemas.microsoft.com/office/drawing/2014/main" id="{68527DD5-8F5B-405A-BF3A-64F84A2B101E}"/>
               </a:ext>
             </a:extLst>
           </p:cNvPr>
@@ -4392,7 +4469,7 @@
           <p:cNvPr id="2" name="Grupo 7 · Poker Adversarial · 2/12">
             <a:extLst xmlns:a="http://schemas.openxmlformats.org/drawingml/2006/main">
               <a:ext uri="{FF2B5EF4-FFF2-40B4-BE49-F238E27FC236}">
-                <a16:creationId xmlns:a16="http://schemas.microsoft.com/office/drawing/2014/main" id="{44990B41-A348-495F-BE6F-A9890D7B74C7}"/>
+                <a16:creationId xmlns:a16="http://schemas.microsoft.com/office/drawing/2014/main" id="{1DFA1AE9-3EA8-4FCD-8D59-FF0086B0F202}"/>
               </a:ext>
             </a:extLst>
           </p:cNvPr>
@@ -4563,7 +4640,7 @@
                           <a:ea typeface="Arial"/>
                           <a:cs typeface="Arial"/>
                         </a:rPr>
-                        <a:t>Flop, turn e river</a:t>
+                        <a:t>Pré-flop, flop, turn e river</a:t>
                       </a:r>
                     </a:p>
                   </a:txBody>
@@ -4619,7 +4696,7 @@
                           <a:ea typeface="Arial"/>
                           <a:cs typeface="Arial"/>
                         </a:rPr>
-                        <a:t>Check, bet, call e fold</a:t>
+                        <a:t>Check, bet, call, fold, raise e all-in</a:t>
                       </a:r>
                     </a:p>
                   </a:txBody>
@@ -4675,7 +4752,7 @@
                           <a:ea typeface="Arial"/>
                           <a:cs typeface="Arial"/>
                         </a:rPr>
-                        <a:t>10 ou 20, sem all-in ou aumentos</a:t>
+                        <a:t>Blinds 5/10. Raise mínimo e saldo finito</a:t>
                       </a:r>
                     </a:p>
                   </a:txBody>
@@ -4731,7 +4808,7 @@
                           <a:ea typeface="Arial"/>
                           <a:cs typeface="Arial"/>
                         </a:rPr>
-                        <a:t>Fold ou revelação após o river</a:t>
+                        <a:t>Fold, river ou all-in pago com runout</a:t>
                       </a:r>
                     </a:p>
                   </a:txBody>
@@ -4748,10 +4825,10 @@
       </p:graphicFrame>
       <p:sp>
         <p:nvSpPr>
-          <p:cNvPr id="4" name="Estado inicial sintético · fichas virtuais · execução local">
+          <p:cNvPr id="4" name="All-in pago: devolver excesso e revelar sem novas apostas">
             <a:extLst xmlns:a="http://schemas.openxmlformats.org/drawingml/2006/main">
               <a:ext uri="{FF2B5EF4-FFF2-40B4-BE49-F238E27FC236}">
-                <a16:creationId xmlns:a16="http://schemas.microsoft.com/office/drawing/2014/main" id="{D13F91AD-C0F9-4415-920E-6BAE7DB694DF}"/>
+                <a16:creationId xmlns:a16="http://schemas.microsoft.com/office/drawing/2014/main" id="{5C7AFBCF-A559-44F7-81F2-EF02BBFDFFEC}"/>
               </a:ext>
             </a:extLst>
           </p:cNvPr>
@@ -4798,17 +4875,17 @@
                 <a:ea typeface="Arial"/>
                 <a:cs typeface="Arial"/>
               </a:rPr>
-              <a:t>Estado inicial sintético · fichas virtuais · execução local</a:t>
-            </a:r>
-          </a:p>
-        </p:txBody>
-      </p:sp>
-      <p:sp>
-        <p:nvSpPr>
-          <p:cNvPr id="5" name="Regras de cartas: PokerStars. Limites de apostas: simplificação p">
+              <a:t>All-in pago: devolver excesso e revelar sem novas apostas</a:t>
+            </a:r>
+          </a:p>
+        </p:txBody>
+      </p:sp>
+      <p:sp>
+        <p:nvSpPr>
+          <p:cNvPr id="5" name="A age primeiro no pré-flop. B age primeiro nas etapas seguintes.">
             <a:extLst xmlns:a="http://schemas.openxmlformats.org/drawingml/2006/main">
               <a:ext uri="{FF2B5EF4-FFF2-40B4-BE49-F238E27FC236}">
-                <a16:creationId xmlns:a16="http://schemas.microsoft.com/office/drawing/2014/main" id="{5F261BB2-EEE7-408A-B9CC-EBB3D220C542}"/>
+                <a16:creationId xmlns:a16="http://schemas.microsoft.com/office/drawing/2014/main" id="{44300525-B881-464B-B813-FD4B6B2EF083}"/>
               </a:ext>
             </a:extLst>
           </p:cNvPr>
@@ -4855,7 +4932,7 @@
                 <a:ea typeface="Arial"/>
                 <a:cs typeface="Arial"/>
               </a:rPr>
-              <a:t>Regras de cartas: PokerStars. Limites de apostas: simplificação própria.</a:t>
+              <a:t>A age primeiro no pré-flop. B age primeiro nas etapas seguintes.</a:t>
             </a:r>
           </a:p>
         </p:txBody>
@@ -4863,7 +4940,7 @@
     </p:spTree>
     <p:extLst>
       <p:ext uri="{BB962C8B-B14F-4D97-AF65-F5344CB8AC3E}">
-        <p14:creationId xmlns:p14="http://schemas.microsoft.com/office/powerpoint/2010/main" val="1841826318"/>
+        <p14:creationId xmlns:p14="http://schemas.microsoft.com/office/powerpoint/2010/main" val="1228094071"/>
       </p:ext>
     </p:extLst>
   </p:cSld>
@@ -4894,7 +4971,7 @@
           <p:cNvPr id="15" name="Atores e propriedades preservadas">
             <a:extLst xmlns:a="http://schemas.openxmlformats.org/drawingml/2006/main">
               <a:ext uri="{FF2B5EF4-FFF2-40B4-BE49-F238E27FC236}">
-                <a16:creationId xmlns:a16="http://schemas.microsoft.com/office/drawing/2014/main" id="{D8342799-0DFF-442C-8335-08F8C10ADB9A}"/>
+                <a16:creationId xmlns:a16="http://schemas.microsoft.com/office/drawing/2014/main" id="{4A77FA7D-9425-4C13-A1D0-D016CF39F5ED}"/>
               </a:ext>
             </a:extLst>
           </p:cNvPr>
@@ -4951,7 +5028,7 @@
           <p:cNvPr id="2" name="Grupo 7 · Poker Adversarial · 3/12">
             <a:extLst xmlns:a="http://schemas.openxmlformats.org/drawingml/2006/main">
               <a:ext uri="{FF2B5EF4-FFF2-40B4-BE49-F238E27FC236}">
-                <a16:creationId xmlns:a16="http://schemas.microsoft.com/office/drawing/2014/main" id="{B2BC67EA-571E-4301-9D46-35B4A7607333}"/>
+                <a16:creationId xmlns:a16="http://schemas.microsoft.com/office/drawing/2014/main" id="{D6954AF9-ED15-4838-A821-FBD0529C7B34}"/>
               </a:ext>
             </a:extLst>
           </p:cNvPr>
@@ -5008,7 +5085,7 @@
           <p:cNvPr id="3" name="Ações chegam ao motor. Visões filtradas retornam aos agentes.">
             <a:extLst xmlns:a="http://schemas.openxmlformats.org/drawingml/2006/main">
               <a:ext uri="{FF2B5EF4-FFF2-40B4-BE49-F238E27FC236}">
-                <a16:creationId xmlns:a16="http://schemas.microsoft.com/office/drawing/2014/main" id="{3F275AB8-8D9E-473F-9233-37B9B5D5DED3}"/>
+                <a16:creationId xmlns:a16="http://schemas.microsoft.com/office/drawing/2014/main" id="{A8B35D28-D492-41F7-9E9B-FDB5C7008719}"/>
               </a:ext>
             </a:extLst>
           </p:cNvPr>
@@ -5065,7 +5142,7 @@
           <p:cNvPr id="4" name="Agente A Ganhar fichas">
             <a:extLst xmlns:a="http://schemas.openxmlformats.org/drawingml/2006/main">
               <a:ext uri="{FF2B5EF4-FFF2-40B4-BE49-F238E27FC236}">
-                <a16:creationId xmlns:a16="http://schemas.microsoft.com/office/drawing/2014/main" id="{F1C72AA0-847A-459A-888C-6DC9B7E72C69}"/>
+                <a16:creationId xmlns:a16="http://schemas.microsoft.com/office/drawing/2014/main" id="{C6CD197C-B2B6-43C0-8B20-8DF553E3514D}"/>
               </a:ext>
             </a:extLst>
           </p:cNvPr>
@@ -5149,7 +5226,7 @@
           <p:cNvPr id="5" name="Agente B Ganhar fichas">
             <a:extLst xmlns:a="http://schemas.openxmlformats.org/drawingml/2006/main">
               <a:ext uri="{FF2B5EF4-FFF2-40B4-BE49-F238E27FC236}">
-                <a16:creationId xmlns:a16="http://schemas.microsoft.com/office/drawing/2014/main" id="{57CBD046-BD96-4EDB-8C8F-D6FAA11BADA1}"/>
+                <a16:creationId xmlns:a16="http://schemas.microsoft.com/office/drawing/2014/main" id="{1DFB2A62-2E51-4F44-87EB-4CF55D5681D8}"/>
               </a:ext>
             </a:extLst>
           </p:cNvPr>
@@ -5230,10 +5307,10 @@
       </p:sp>
       <p:sp>
         <p:nvSpPr>
-          <p:cNvPr id="6" name="Motor da mão Valida e contabiliza Fornece visões filtradas">
+          <p:cNvPr id="6" name="Motor da mão Pré-flop, river ou runout Valida raise e all-in">
             <a:extLst xmlns:a="http://schemas.openxmlformats.org/drawingml/2006/main">
               <a:ext uri="{FF2B5EF4-FFF2-40B4-BE49-F238E27FC236}">
-                <a16:creationId xmlns:a16="http://schemas.microsoft.com/office/drawing/2014/main" id="{B666DED8-B4AA-4DAA-99A2-D3DB2E9E919D}"/>
+                <a16:creationId xmlns:a16="http://schemas.microsoft.com/office/drawing/2014/main" id="{C9784493-01E5-43A9-B879-07B7DDF3544A}"/>
               </a:ext>
             </a:extLst>
           </p:cNvPr>
@@ -5266,7 +5343,7 @@
           <a:lstStyle xmlns:a="http://schemas.openxmlformats.org/drawingml/2006/main"/>
           <a:p xmlns:a="http://schemas.openxmlformats.org/drawingml/2006/main">
             <a:pPr algn="ctr">
-              <a:defRPr sz="1950" b="0">
+              <a:defRPr sz="1800" b="0">
                 <a:solidFill>
                   <a:srgbClr val="14755E"/>
                 </a:solidFill>
@@ -5276,7 +5353,7 @@
               </a:defRPr>
             </a:pPr>
             <a:r>
-              <a:rPr sz="1950" b="0">
+              <a:rPr sz="1800" b="0">
                 <a:solidFill>
                   <a:srgbClr val="14755E"/>
                 </a:solidFill>
@@ -5289,7 +5366,7 @@
           </a:p>
           <a:p xmlns:a="http://schemas.openxmlformats.org/drawingml/2006/main">
             <a:pPr algn="ctr">
-              <a:defRPr sz="1950" b="0">
+              <a:defRPr sz="1800" b="0">
                 <a:solidFill>
                   <a:srgbClr val="14755E"/>
                 </a:solidFill>
@@ -5299,7 +5376,7 @@
               </a:defRPr>
             </a:pPr>
             <a:r>
-              <a:rPr sz="1950" b="0">
+              <a:rPr sz="1800" b="0">
                 <a:solidFill>
                   <a:srgbClr val="14755E"/>
                 </a:solidFill>
@@ -5307,12 +5384,12 @@
                 <a:ea typeface="Arial"/>
                 <a:cs typeface="Arial"/>
               </a:rPr>
-              <a:t>Valida e contabiliza</a:t>
+              <a:t>Pré-flop, river ou runout</a:t>
             </a:r>
           </a:p>
           <a:p xmlns:a="http://schemas.openxmlformats.org/drawingml/2006/main">
             <a:pPr algn="ctr">
-              <a:defRPr sz="1950" b="0">
+              <a:defRPr sz="1800" b="0">
                 <a:solidFill>
                   <a:srgbClr val="14755E"/>
                 </a:solidFill>
@@ -5322,7 +5399,7 @@
               </a:defRPr>
             </a:pPr>
             <a:r>
-              <a:rPr sz="1950" b="0">
+              <a:rPr sz="1800" b="0">
                 <a:solidFill>
                   <a:srgbClr val="14755E"/>
                 </a:solidFill>
@@ -5330,7 +5407,7 @@
                 <a:ea typeface="Arial"/>
                 <a:cs typeface="Arial"/>
               </a:rPr>
-              <a:t>Fornece visões filtradas</a:t>
+              <a:t>Valida raise e all-in</a:t>
             </a:r>
           </a:p>
         </p:txBody>
@@ -5340,7 +5417,7 @@
           <p:cNvPr id="7" name="Registro interno Auditoria após a mão">
             <a:extLst xmlns:a="http://schemas.openxmlformats.org/drawingml/2006/main">
               <a:ext uri="{FF2B5EF4-FFF2-40B4-BE49-F238E27FC236}">
-                <a16:creationId xmlns:a16="http://schemas.microsoft.com/office/drawing/2014/main" id="{313B94A1-010B-484C-BC98-7336B823D817}"/>
+                <a16:creationId xmlns:a16="http://schemas.microsoft.com/office/drawing/2014/main" id="{ADA16DD6-D850-44BD-99ED-2AD17695A8B2}"/>
               </a:ext>
             </a:extLst>
           </p:cNvPr>
@@ -5424,7 +5501,7 @@
           <p:cNvPr id="8" name="Operador do grupo Analisa cenário">
             <a:extLst xmlns:a="http://schemas.openxmlformats.org/drawingml/2006/main">
               <a:ext uri="{FF2B5EF4-FFF2-40B4-BE49-F238E27FC236}">
-                <a16:creationId xmlns:a16="http://schemas.microsoft.com/office/drawing/2014/main" id="{51BB1F35-2726-4270-A4BD-6C3A370EFD95}"/>
+                <a16:creationId xmlns:a16="http://schemas.microsoft.com/office/drawing/2014/main" id="{95A6F9F0-A473-44EA-A907-2BEC78D80EAC}"/>
               </a:ext>
             </a:extLst>
           </p:cNvPr>
@@ -5508,7 +5585,7 @@
           <p:cNvPr id="9" name="Preservar integridade, sigilo e progresso">
             <a:extLst xmlns:a="http://schemas.openxmlformats.org/drawingml/2006/main">
               <a:ext uri="{FF2B5EF4-FFF2-40B4-BE49-F238E27FC236}">
-                <a16:creationId xmlns:a16="http://schemas.microsoft.com/office/drawing/2014/main" id="{CEEF9496-418D-4E2E-86BA-A724A3BBC94F}"/>
+                <a16:creationId xmlns:a16="http://schemas.microsoft.com/office/drawing/2014/main" id="{7ACD8EF6-6955-4A60-A92E-8D3FAD42C188}"/>
               </a:ext>
             </a:extLst>
           </p:cNvPr>
@@ -5725,7 +5802,7 @@
     </p:spTree>
     <p:extLst>
       <p:ext uri="{BB962C8B-B14F-4D97-AF65-F5344CB8AC3E}">
-        <p14:creationId xmlns:p14="http://schemas.microsoft.com/office/powerpoint/2010/main" val="462050210"/>
+        <p14:creationId xmlns:p14="http://schemas.microsoft.com/office/powerpoint/2010/main" val="1942301214"/>
       </p:ext>
     </p:extLst>
   </p:cSld>
@@ -5756,7 +5833,7 @@
           <p:cNvPr id="8" name="Decisão estática no river">
             <a:extLst xmlns:a="http://schemas.openxmlformats.org/drawingml/2006/main">
               <a:ext uri="{FF2B5EF4-FFF2-40B4-BE49-F238E27FC236}">
-                <a16:creationId xmlns:a16="http://schemas.microsoft.com/office/drawing/2014/main" id="{1449164D-4A11-4942-90A2-AACE10B42AA5}"/>
+                <a16:creationId xmlns:a16="http://schemas.microsoft.com/office/drawing/2014/main" id="{B26D193A-B284-45D0-8D2B-DC8FE975F16F}"/>
               </a:ext>
             </a:extLst>
           </p:cNvPr>
@@ -5813,7 +5890,7 @@
           <p:cNvPr id="2" name="Grupo 7 · Poker Adversarial · 4/12">
             <a:extLst xmlns:a="http://schemas.openxmlformats.org/drawingml/2006/main">
               <a:ext uri="{FF2B5EF4-FFF2-40B4-BE49-F238E27FC236}">
-                <a16:creationId xmlns:a16="http://schemas.microsoft.com/office/drawing/2014/main" id="{1569B30F-5BFA-4F5B-A93E-6EBE3349D694}"/>
+                <a16:creationId xmlns:a16="http://schemas.microsoft.com/office/drawing/2014/main" id="{76268008-410D-4019-94D3-56A175691E3B}"/>
               </a:ext>
             </a:extLst>
           </p:cNvPr>
@@ -5867,10 +5944,10 @@
       </p:sp>
       <p:sp>
         <p:nvSpPr>
-          <p:cNvPr id="3" name="Pote 40 · aposta 20 · B vence na revelação do cenário fixo">
+          <p:cNvPr id="3" name="Após check de B: pote 80, aposta 20, B vence na revelação">
             <a:extLst xmlns:a="http://schemas.openxmlformats.org/drawingml/2006/main">
               <a:ext uri="{FF2B5EF4-FFF2-40B4-BE49-F238E27FC236}">
-                <a16:creationId xmlns:a16="http://schemas.microsoft.com/office/drawing/2014/main" id="{F817EF28-5689-4AAC-86D1-C2AB17A77A69}"/>
+                <a16:creationId xmlns:a16="http://schemas.microsoft.com/office/drawing/2014/main" id="{949C8145-29EA-4319-B066-92AD42BF1ED4}"/>
               </a:ext>
             </a:extLst>
           </p:cNvPr>
@@ -5917,7 +5994,7 @@
                 <a:ea typeface="Arial"/>
                 <a:cs typeface="Arial"/>
               </a:rPr>
-              <a:t>Pote 40 · aposta 20 · B vence na revelação do cenário fixo</a:t>
+              <a:t>Após check de B: pote 80, aposta 20, B vence na revelação</a:t>
             </a:r>
           </a:p>
         </p:txBody>
@@ -6199,7 +6276,7 @@
           <p:cNvPr id="5" name="Pares = preferência de A e B. Maior valor = resultado preferido.">
             <a:extLst xmlns:a="http://schemas.openxmlformats.org/drawingml/2006/main">
               <a:ext uri="{FF2B5EF4-FFF2-40B4-BE49-F238E27FC236}">
-                <a16:creationId xmlns:a16="http://schemas.microsoft.com/office/drawing/2014/main" id="{A1266FDF-D081-4E3C-ABA0-846170D76663}"/>
+                <a16:creationId xmlns:a16="http://schemas.microsoft.com/office/drawing/2014/main" id="{18E395E0-C99E-4671-8B37-4572C235BDAA}"/>
               </a:ext>
             </a:extLst>
           </p:cNvPr>
@@ -6253,10 +6330,10 @@
       </p:sp>
       <p:sp>
         <p:nvSpPr>
-          <p:cNvPr id="6" name="Call: A perde 20 e B ganha 60. Fold: A ganha 40.">
+          <p:cNvPr id="6" name="Call: A perde 20 e B ganha 100. Fold: A ganha 80.">
             <a:extLst xmlns:a="http://schemas.openxmlformats.org/drawingml/2006/main">
               <a:ext uri="{FF2B5EF4-FFF2-40B4-BE49-F238E27FC236}">
-                <a16:creationId xmlns:a16="http://schemas.microsoft.com/office/drawing/2014/main" id="{F51A84E5-D15E-4AE3-AE93-C1E972C47B46}"/>
+                <a16:creationId xmlns:a16="http://schemas.microsoft.com/office/drawing/2014/main" id="{AF289344-F799-45A7-97BB-0C8D877774F4}"/>
               </a:ext>
             </a:extLst>
           </p:cNvPr>
@@ -6303,17 +6380,17 @@
                 <a:ea typeface="Arial"/>
                 <a:cs typeface="Arial"/>
               </a:rPr>
-              <a:t>Call: A perde 20 e B ganha 60. Fold: A ganha 40.</a:t>
-            </a:r>
-          </a:p>
-        </p:txBody>
-      </p:sp>
-      <p:sp>
-        <p:nvSpPr>
-          <p:cNvPr id="7" name="Análise retrospectiva com cartas fixadas pelo analista. Os agente">
+              <a:t>Call: A perde 20 e B ganha 100. Fold: A ganha 80.</a:t>
+            </a:r>
+          </a:p>
+        </p:txBody>
+      </p:sp>
+      <p:sp>
+        <p:nvSpPr>
+          <p:cNvPr id="7" name="Tabela reduzida sem raise/all-in. Cartas fixadas pelo analista, o">
             <a:extLst xmlns:a="http://schemas.openxmlformats.org/drawingml/2006/main">
               <a:ext uri="{FF2B5EF4-FFF2-40B4-BE49-F238E27FC236}">
-                <a16:creationId xmlns:a16="http://schemas.microsoft.com/office/drawing/2014/main" id="{99072B67-7F7B-4619-8751-FA007A26B737}"/>
+                <a16:creationId xmlns:a16="http://schemas.microsoft.com/office/drawing/2014/main" id="{86115313-AA52-490F-96D8-4CB68D782BDB}"/>
               </a:ext>
             </a:extLst>
           </p:cNvPr>
@@ -6360,7 +6437,7 @@
                 <a:ea typeface="Arial"/>
                 <a:cs typeface="Arial"/>
               </a:rPr>
-              <a:t>Análise retrospectiva com cartas fixadas pelo analista. Os agentes continuam com informação parcial.</a:t>
+              <a:t>Tabela reduzida sem raise/all-in. Cartas fixadas pelo analista, ocultas dos agentes.</a:t>
             </a:r>
           </a:p>
         </p:txBody>
@@ -6368,7 +6445,7 @@
     </p:spTree>
     <p:extLst>
       <p:ext uri="{BB962C8B-B14F-4D97-AF65-F5344CB8AC3E}">
-        <p14:creationId xmlns:p14="http://schemas.microsoft.com/office/powerpoint/2010/main" val="666300835"/>
+        <p14:creationId xmlns:p14="http://schemas.microsoft.com/office/powerpoint/2010/main" val="2143352713"/>
       </p:ext>
     </p:extLst>
   </p:cSld>
@@ -6399,7 +6476,7 @@
           <p:cNvPr id="8" name="Melhores respostas e equilíbrio">
             <a:extLst xmlns:a="http://schemas.openxmlformats.org/drawingml/2006/main">
               <a:ext uri="{FF2B5EF4-FFF2-40B4-BE49-F238E27FC236}">
-                <a16:creationId xmlns:a16="http://schemas.microsoft.com/office/drawing/2014/main" id="{532B66D7-9A5F-48B2-B3B4-C9860895F6D7}"/>
+                <a16:creationId xmlns:a16="http://schemas.microsoft.com/office/drawing/2014/main" id="{C1C5D64C-8D2D-4300-A210-6E460BF79CFA}"/>
               </a:ext>
             </a:extLst>
           </p:cNvPr>
@@ -6456,7 +6533,7 @@
           <p:cNvPr id="2" name="Grupo 7 · Poker Adversarial · 5/12">
             <a:extLst xmlns:a="http://schemas.openxmlformats.org/drawingml/2006/main">
               <a:ext uri="{FF2B5EF4-FFF2-40B4-BE49-F238E27FC236}">
-                <a16:creationId xmlns:a16="http://schemas.microsoft.com/office/drawing/2014/main" id="{354F15B6-9137-4CAA-AD4D-CE515DC5928F}"/>
+                <a16:creationId xmlns:a16="http://schemas.microsoft.com/office/drawing/2014/main" id="{D638D6E8-58FF-44DD-A159-4AE86022F40E}"/>
               </a:ext>
             </a:extLst>
           </p:cNvPr>
@@ -6815,7 +6892,7 @@
           <p:cNvPr id="4" name="A: sem dominante">
             <a:extLst xmlns:a="http://schemas.openxmlformats.org/drawingml/2006/main">
               <a:ext uri="{FF2B5EF4-FFF2-40B4-BE49-F238E27FC236}">
-                <a16:creationId xmlns:a16="http://schemas.microsoft.com/office/drawing/2014/main" id="{CF9BD9BF-273A-415C-A40B-4FBADDE77D5C}"/>
+                <a16:creationId xmlns:a16="http://schemas.microsoft.com/office/drawing/2014/main" id="{2771BBD3-93D6-4738-88E6-181983B592A7}"/>
               </a:ext>
             </a:extLst>
           </p:cNvPr>
@@ -6872,7 +6949,7 @@
           <p:cNvPr id="5" name="B1 domina fracamente">
             <a:extLst xmlns:a="http://schemas.openxmlformats.org/drawingml/2006/main">
               <a:ext uri="{FF2B5EF4-FFF2-40B4-BE49-F238E27FC236}">
-                <a16:creationId xmlns:a16="http://schemas.microsoft.com/office/drawing/2014/main" id="{576F2773-FEE7-4C1C-9A21-E7B3EBD85856}"/>
+                <a16:creationId xmlns:a16="http://schemas.microsoft.com/office/drawing/2014/main" id="{0D011983-2A87-46A4-AF83-C859783D2C91}"/>
               </a:ext>
             </a:extLst>
           </p:cNvPr>
@@ -6929,7 +7006,7 @@
           <p:cNvPr id="6" name="Equilíbrio puro&#10;(A2, B1)">
             <a:extLst xmlns:a="http://schemas.openxmlformats.org/drawingml/2006/main">
               <a:ext uri="{FF2B5EF4-FFF2-40B4-BE49-F238E27FC236}">
-                <a16:creationId xmlns:a16="http://schemas.microsoft.com/office/drawing/2014/main" id="{86ADEC73-492C-4F4F-B5C7-394321A128AC}"/>
+                <a16:creationId xmlns:a16="http://schemas.microsoft.com/office/drawing/2014/main" id="{FE86E0D7-6B25-4E1C-BE21-062B8ED5EDF9}"/>
               </a:ext>
             </a:extLst>
           </p:cNvPr>
@@ -7009,7 +7086,7 @@
           <p:cNvPr id="7" name="Equilíbrio da tabela retrospectiva. Sigilo e justiça dependem tam">
             <a:extLst xmlns:a="http://schemas.openxmlformats.org/drawingml/2006/main">
               <a:ext uri="{FF2B5EF4-FFF2-40B4-BE49-F238E27FC236}">
-                <a16:creationId xmlns:a16="http://schemas.microsoft.com/office/drawing/2014/main" id="{BDAD1AF0-F95D-48BA-A2DF-533C40174058}"/>
+                <a16:creationId xmlns:a16="http://schemas.microsoft.com/office/drawing/2014/main" id="{E4B50F0C-622A-4B8A-B365-4ABEB85F10FD}"/>
               </a:ext>
             </a:extLst>
           </p:cNvPr>
@@ -7064,7 +7141,7 @@
     </p:spTree>
     <p:extLst>
       <p:ext uri="{BB962C8B-B14F-4D97-AF65-F5344CB8AC3E}">
-        <p14:creationId xmlns:p14="http://schemas.microsoft.com/office/powerpoint/2010/main" val="438036300"/>
+        <p14:creationId xmlns:p14="http://schemas.microsoft.com/office/powerpoint/2010/main" val="1536549038"/>
       </p:ext>
     </p:extLst>
   </p:cSld>
@@ -7092,10 +7169,10 @@
       </p:grpSpPr>
       <p:sp>
         <p:nvSpPr>
-          <p:cNvPr id="8" name="Três rodadas e mudança de política">
+          <p:cNvPr id="8" name="Quatro etapas e adaptação">
             <a:extLst xmlns:a="http://schemas.openxmlformats.org/drawingml/2006/main">
               <a:ext uri="{FF2B5EF4-FFF2-40B4-BE49-F238E27FC236}">
-                <a16:creationId xmlns:a16="http://schemas.microsoft.com/office/drawing/2014/main" id="{4BF04084-1BD7-4D54-9E4A-795D4B919C86}"/>
+                <a16:creationId xmlns:a16="http://schemas.microsoft.com/office/drawing/2014/main" id="{28AAEFA1-0B37-4621-B6C8-2113C2AEEBA0}"/>
               </a:ext>
             </a:extLst>
           </p:cNvPr>
@@ -7142,7 +7219,7 @@
                 <a:ea typeface="Arial"/>
                 <a:cs typeface="Arial"/>
               </a:rPr>
-              <a:t>Três rodadas e mudança de política</a:t>
+              <a:t>Quatro etapas e adaptação</a:t>
             </a:r>
           </a:p>
         </p:txBody>
@@ -7152,7 +7229,7 @@
           <p:cNvPr id="2" name="Grupo 7 · Poker Adversarial · 6/12">
             <a:extLst xmlns:a="http://schemas.openxmlformats.org/drawingml/2006/main">
               <a:ext uri="{FF2B5EF4-FFF2-40B4-BE49-F238E27FC236}">
-                <a16:creationId xmlns:a16="http://schemas.microsoft.com/office/drawing/2014/main" id="{69B09375-09B5-4DAB-B162-B4E99510FCB5}"/>
+                <a16:creationId xmlns:a16="http://schemas.microsoft.com/office/drawing/2014/main" id="{E9743E39-B7AC-4160-8B9B-9F217358D540}"/>
               </a:ext>
             </a:extLst>
           </p:cNvPr>
@@ -7212,18 +7289,18 @@
         </p:nvGraphicFramePr>
         <p:xfrm>
           <a:off xmlns:a="http://schemas.openxmlformats.org/drawingml/2006/main" x="571500" y="1409700"/>
-          <a:ext xmlns:a="http://schemas.openxmlformats.org/drawingml/2006/main" cx="11049000" cy="2800350"/>
+          <a:ext xmlns:a="http://schemas.openxmlformats.org/drawingml/2006/main" cx="11049000" cy="3143250"/>
         </p:xfrm>
         <a:graphic xmlns:a="http://schemas.openxmlformats.org/drawingml/2006/main">
           <a:graphicData uri="http://schemas.openxmlformats.org/drawingml/2006/table">
             <a:tbl>
               <a:tblPr/>
               <a:tblGrid>
-                <a:gridCol w="1619250"/>
-                <a:gridCol w="3714750"/>
-                <a:gridCol w="5715000"/>
+                <a:gridCol w="1524000"/>
+                <a:gridCol w="4191000"/>
+                <a:gridCol w="5334000"/>
               </a:tblGrid>
-              <a:tr h="700088">
+              <a:tr h="628650">
                 <a:tc>
                   <a:txBody>
                     <a:bodyPr>
@@ -7233,7 +7310,7 @@
                     <a:p>
                       <a:pPr algn="l"/>
                       <a:r>
-                        <a:rPr sz="2025" b="1">
+                        <a:rPr sz="1800" b="1">
                           <a:solidFill>
                             <a:srgbClr val="FFFFFF"/>
                           </a:solidFill>
@@ -7260,7 +7337,7 @@
                     <a:p>
                       <a:pPr algn="l"/>
                       <a:r>
-                        <a:rPr sz="2025" b="1">
+                        <a:rPr sz="1800" b="1">
                           <a:solidFill>
                             <a:srgbClr val="FFFFFF"/>
                           </a:solidFill>
@@ -7287,7 +7364,7 @@
                     <a:p>
                       <a:pPr algn="l"/>
                       <a:r>
-                        <a:rPr sz="2025" b="1">
+                        <a:rPr sz="1800" b="1">
                           <a:solidFill>
                             <a:srgbClr val="FFFFFF"/>
                           </a:solidFill>
@@ -7306,7 +7383,7 @@
                   </a:tcPr>
                 </a:tc>
               </a:tr>
-              <a:tr h="700088">
+              <a:tr h="628650">
                 <a:tc>
                   <a:txBody>
                     <a:bodyPr>
@@ -7316,7 +7393,7 @@
                     <a:p>
                       <a:pPr algn="l"/>
                       <a:r>
-                        <a:rPr sz="2025" b="0">
+                        <a:rPr sz="1800" b="0">
                           <a:solidFill>
                             <a:srgbClr val="143042"/>
                           </a:solidFill>
@@ -7324,7 +7401,7 @@
                           <a:ea typeface="Arial"/>
                           <a:cs typeface="Arial"/>
                         </a:rPr>
-                        <a:t>Flop</a:t>
+                        <a:t>Pré-flop</a:t>
                       </a:r>
                     </a:p>
                   </a:txBody>
@@ -7343,7 +7420,7 @@
                     <a:p>
                       <a:pPr algn="l"/>
                       <a:r>
-                        <a:rPr sz="2025" b="0">
+                        <a:rPr sz="1800" b="0">
                           <a:solidFill>
                             <a:srgbClr val="143042"/>
                           </a:solidFill>
@@ -7351,7 +7428,7 @@
                           <a:ea typeface="Arial"/>
                           <a:cs typeface="Arial"/>
                         </a:rPr>
-                        <a:t>A bet 10 / B call</a:t>
+                        <a:t>A raise 20 / B call</a:t>
                       </a:r>
                     </a:p>
                   </a:txBody>
@@ -7370,7 +7447,7 @@
                     <a:p>
                       <a:pPr algn="l"/>
                       <a:r>
-                        <a:rPr sz="2025" b="0">
+                        <a:rPr sz="1800" b="0">
                           <a:solidFill>
                             <a:srgbClr val="143042"/>
                           </a:solidFill>
@@ -7378,7 +7455,7 @@
                           <a:ea typeface="Arial"/>
                           <a:cs typeface="Arial"/>
                         </a:rPr>
-                        <a:t>A recua e B prepara indução</a:t>
+                        <a:t>A mantém teste. B prepara raise</a:t>
                       </a:r>
                     </a:p>
                   </a:txBody>
@@ -7389,7 +7466,7 @@
                   </a:tcPr>
                 </a:tc>
               </a:tr>
-              <a:tr h="700088">
+              <a:tr h="628650">
                 <a:tc>
                   <a:txBody>
                     <a:bodyPr>
@@ -7399,7 +7476,7 @@
                     <a:p>
                       <a:pPr algn="l"/>
                       <a:r>
-                        <a:rPr sz="2025" b="0">
+                        <a:rPr sz="1800" b="0">
                           <a:solidFill>
                             <a:srgbClr val="143042"/>
                           </a:solidFill>
@@ -7407,7 +7484,7 @@
                           <a:ea typeface="Arial"/>
                           <a:cs typeface="Arial"/>
                         </a:rPr>
-                        <a:t>Turn</a:t>
+                        <a:t>Flop</a:t>
                       </a:r>
                     </a:p>
                   </a:txBody>
@@ -7426,7 +7503,7 @@
                     <a:p>
                       <a:pPr algn="l"/>
                       <a:r>
-                        <a:rPr sz="2025" b="0">
+                        <a:rPr sz="1800" b="0">
                           <a:solidFill>
                             <a:srgbClr val="143042"/>
                           </a:solidFill>
@@ -7434,7 +7511,21 @@
                           <a:ea typeface="Arial"/>
                           <a:cs typeface="Arial"/>
                         </a:rPr>
-                        <a:t>Check / check</a:t>
+                        <a:t>B check / A bet 10</a:t>
+                      </a:r>
+                    </a:p>
+                    <a:p>
+                      <a:pPr algn="l"/>
+                      <a:r>
+                        <a:rPr sz="1800" b="0">
+                          <a:solidFill>
+                            <a:srgbClr val="143042"/>
+                          </a:solidFill>
+                          <a:latin typeface="Arial"/>
+                          <a:ea typeface="Arial"/>
+                          <a:cs typeface="Arial"/>
+                        </a:rPr>
+                        <a:t>B raise 20 / A call +10</a:t>
                       </a:r>
                     </a:p>
                   </a:txBody>
@@ -7453,7 +7544,7 @@
                     <a:p>
                       <a:pPr algn="l"/>
                       <a:r>
-                        <a:rPr sz="2025" b="0">
+                        <a:rPr sz="1800" b="0">
                           <a:solidFill>
                             <a:srgbClr val="143042"/>
                           </a:solidFill>
@@ -7461,7 +7552,7 @@
                           <a:ea typeface="Arial"/>
                           <a:cs typeface="Arial"/>
                         </a:rPr>
-                        <a:t>B induz e A interpreta fraqueza</a:t>
+                        <a:t>A recua. B muda para indução</a:t>
                       </a:r>
                     </a:p>
                   </a:txBody>
@@ -7472,7 +7563,7 @@
                   </a:tcPr>
                 </a:tc>
               </a:tr>
-              <a:tr h="700088">
+              <a:tr h="628650">
                 <a:tc>
                   <a:txBody>
                     <a:bodyPr>
@@ -7482,7 +7573,7 @@
                     <a:p>
                       <a:pPr algn="l"/>
                       <a:r>
-                        <a:rPr sz="2025" b="0">
+                        <a:rPr sz="1800" b="0">
                           <a:solidFill>
                             <a:srgbClr val="143042"/>
                           </a:solidFill>
@@ -7490,7 +7581,7 @@
                           <a:ea typeface="Arial"/>
                           <a:cs typeface="Arial"/>
                         </a:rPr>
-                        <a:t>River</a:t>
+                        <a:t>Turn</a:t>
                       </a:r>
                     </a:p>
                   </a:txBody>
@@ -7509,7 +7600,7 @@
                     <a:p>
                       <a:pPr algn="l"/>
                       <a:r>
-                        <a:rPr sz="2025" b="0">
+                        <a:rPr sz="1800" b="0">
                           <a:solidFill>
                             <a:srgbClr val="143042"/>
                           </a:solidFill>
@@ -7517,7 +7608,7 @@
                           <a:ea typeface="Arial"/>
                           <a:cs typeface="Arial"/>
                         </a:rPr>
-                        <a:t>A bet 20 / B call</a:t>
+                        <a:t>B check / A check</a:t>
                       </a:r>
                     </a:p>
                   </a:txBody>
@@ -7536,7 +7627,7 @@
                     <a:p>
                       <a:pPr algn="l"/>
                       <a:r>
-                        <a:rPr sz="2025" b="0">
+                        <a:rPr sz="1800" b="0">
                           <a:solidFill>
                             <a:srgbClr val="143042"/>
                           </a:solidFill>
@@ -7544,7 +7635,7 @@
                           <a:ea typeface="Arial"/>
                           <a:cs typeface="Arial"/>
                         </a:rPr>
-                        <a:t>Leitura de A falha na revelação</a:t>
+                        <a:t>A lê fraqueza. B mantém indução</a:t>
                       </a:r>
                     </a:p>
                   </a:txBody>
@@ -7555,16 +7646,99 @@
                   </a:tcPr>
                 </a:tc>
               </a:tr>
+              <a:tr h="628650">
+                <a:tc>
+                  <a:txBody>
+                    <a:bodyPr>
+                      <a:noAutofit/>
+                    </a:bodyPr>
+                    <a:lstStyle/>
+                    <a:p>
+                      <a:pPr algn="l"/>
+                      <a:r>
+                        <a:rPr sz="1800" b="0">
+                          <a:solidFill>
+                            <a:srgbClr val="143042"/>
+                          </a:solidFill>
+                          <a:latin typeface="Arial"/>
+                          <a:ea typeface="Arial"/>
+                          <a:cs typeface="Arial"/>
+                        </a:rPr>
+                        <a:t>River</a:t>
+                      </a:r>
+                    </a:p>
+                  </a:txBody>
+                  <a:tcPr marL="142875" marR="114300" marT="114300" marB="95250" anchor="ctr">
+                    <a:solidFill>
+                      <a:srgbClr val="F8FAFB"/>
+                    </a:solidFill>
+                  </a:tcPr>
+                </a:tc>
+                <a:tc>
+                  <a:txBody>
+                    <a:bodyPr>
+                      <a:noAutofit/>
+                    </a:bodyPr>
+                    <a:lstStyle/>
+                    <a:p>
+                      <a:pPr algn="l"/>
+                      <a:r>
+                        <a:rPr sz="1800" b="0">
+                          <a:solidFill>
+                            <a:srgbClr val="143042"/>
+                          </a:solidFill>
+                          <a:latin typeface="Arial"/>
+                          <a:ea typeface="Arial"/>
+                          <a:cs typeface="Arial"/>
+                        </a:rPr>
+                        <a:t>B check / A bet 20 / B call</a:t>
+                      </a:r>
+                    </a:p>
+                  </a:txBody>
+                  <a:tcPr marL="142875" marR="114300" marT="114300" marB="95250" anchor="ctr">
+                    <a:solidFill>
+                      <a:srgbClr val="F8FAFB"/>
+                    </a:solidFill>
+                  </a:tcPr>
+                </a:tc>
+                <a:tc>
+                  <a:txBody>
+                    <a:bodyPr>
+                      <a:noAutofit/>
+                    </a:bodyPr>
+                    <a:lstStyle/>
+                    <a:p>
+                      <a:pPr algn="l"/>
+                      <a:r>
+                        <a:rPr sz="1800" b="0">
+                          <a:solidFill>
+                            <a:srgbClr val="143042"/>
+                          </a:solidFill>
+                          <a:latin typeface="Arial"/>
+                          <a:ea typeface="Arial"/>
+                          <a:cs typeface="Arial"/>
+                        </a:rPr>
+                        <a:t>A erra a leitura. B vence</a:t>
+                      </a:r>
+                    </a:p>
+                  </a:txBody>
+                  <a:tcPr marL="142875" marR="114300" marT="114300" marB="95250" anchor="ctr">
+                    <a:solidFill>
+                      <a:srgbClr val="F8FAFB"/>
+                    </a:solidFill>
+                  </a:tcPr>
+                </a:tc>
+              </a:tr>
             </a:tbl>
           </a:graphicData>
         </a:graphic>
       </p:graphicFrame>
       <p:sp>
         <p:nvSpPr>
-          <p:cNvPr id="4" name="Cartas de A: 7♣ 2♦     Cartas de B: A♥ A♦">
+          <p:cNvPr id="4" name="A: 7♣ 2♦    B: A♥ A♦    Mesa: A♠ 9♥ 4♣ K♣ 3♦">
             <a:extLst xmlns:a="http://schemas.openxmlformats.org/drawingml/2006/main">
               <a:ext uri="{FF2B5EF4-FFF2-40B4-BE49-F238E27FC236}">
-                <a16:creationId xmlns:a16="http://schemas.microsoft.com/office/drawing/2014/main" id="{292AF591-02F8-4F60-91AF-8E5AAD67BDFF}"/>
+                <a16:creationId xmlns:a16="http://schemas.microsoft.com/office/drawing/2014/main" id="{237BE957-AF98-4A86-BAE2-3064D15EBEB0}"/>
               </a:ext>
             </a:extLst>
           </p:cNvPr>
@@ -7575,7 +7749,64 @@
         </p:nvSpPr>
         <p:spPr>
           <a:xfrm xmlns:a="http://schemas.openxmlformats.org/drawingml/2006/main">
-            <a:off x="571500" y="4476750"/>
+            <a:off x="571500" y="4752975"/>
+            <a:ext cx="11049000" cy="381000"/>
+          </a:xfrm>
+          <a:prstGeom xmlns:a="http://schemas.openxmlformats.org/drawingml/2006/main" prst="rect">
+            <a:avLst/>
+          </a:prstGeom>
+          <a:noFill xmlns:a="http://schemas.openxmlformats.org/drawingml/2006/main"/>
+          <a:ln xmlns:a="http://schemas.openxmlformats.org/drawingml/2006/main" w="0">
+            <a:noFill/>
+          </a:ln>
+        </p:spPr>
+        <p:txBody>
+          <a:bodyPr xmlns:a="http://schemas.openxmlformats.org/drawingml/2006/main" wrap="square" lIns="0" tIns="0" rIns="0" bIns="0" anchor="t">
+            <a:noAutofit/>
+          </a:bodyPr>
+          <a:lstStyle xmlns:a="http://schemas.openxmlformats.org/drawingml/2006/main"/>
+          <a:p xmlns:a="http://schemas.openxmlformats.org/drawingml/2006/main">
+            <a:pPr algn="l">
+              <a:defRPr sz="2025" b="0">
+                <a:solidFill>
+                  <a:srgbClr val="143042"/>
+                </a:solidFill>
+                <a:latin typeface="Arial"/>
+                <a:ea typeface="Arial"/>
+                <a:cs typeface="Arial"/>
+              </a:defRPr>
+            </a:pPr>
+            <a:r>
+              <a:rPr sz="2025" b="0">
+                <a:solidFill>
+                  <a:srgbClr val="143042"/>
+                </a:solidFill>
+                <a:latin typeface="Arial"/>
+                <a:ea typeface="Arial"/>
+                <a:cs typeface="Arial"/>
+              </a:rPr>
+              <a:t>A: 7♣ 2♦    B: A♥ A♦    Mesa: A♠ 9♥ 4♣ K♣ 3♦</a:t>
+            </a:r>
+          </a:p>
+        </p:txBody>
+      </p:sp>
+      <p:sp>
+        <p:nvSpPr>
+          <p:cNvPr id="5" name="Final: A 50, B 170. Total conservado: 220 fichas.">
+            <a:extLst xmlns:a="http://schemas.openxmlformats.org/drawingml/2006/main">
+              <a:ext uri="{FF2B5EF4-FFF2-40B4-BE49-F238E27FC236}">
+                <a16:creationId xmlns:a16="http://schemas.microsoft.com/office/drawing/2014/main" id="{71D73DAC-4CF8-4BFB-A168-F8588D564964}"/>
+              </a:ext>
+            </a:extLst>
+          </p:cNvPr>
+          <p:cNvSpPr>
+            <a:spLocks xmlns:a="http://schemas.openxmlformats.org/drawingml/2006/main" noGrp="1"/>
+          </p:cNvSpPr>
+          <p:nvPr/>
+        </p:nvSpPr>
+        <p:spPr>
+          <a:xfrm xmlns:a="http://schemas.openxmlformats.org/drawingml/2006/main">
+            <a:off x="571500" y="5191125"/>
             <a:ext cx="11049000" cy="409575"/>
           </a:xfrm>
           <a:prstGeom xmlns:a="http://schemas.openxmlformats.org/drawingml/2006/main" prst="rect">
@@ -7593,9 +7824,9 @@
           <a:lstStyle xmlns:a="http://schemas.openxmlformats.org/drawingml/2006/main"/>
           <a:p xmlns:a="http://schemas.openxmlformats.org/drawingml/2006/main">
             <a:pPr algn="l">
-              <a:defRPr sz="2175" b="0">
-                <a:solidFill>
-                  <a:srgbClr val="143042"/>
+              <a:defRPr sz="2175" b="1">
+                <a:solidFill>
+                  <a:srgbClr val="14755E"/>
                 </a:solidFill>
                 <a:latin typeface="Arial"/>
                 <a:ea typeface="Arial"/>
@@ -7603,25 +7834,25 @@
               </a:defRPr>
             </a:pPr>
             <a:r>
-              <a:rPr sz="2175" b="0">
-                <a:solidFill>
-                  <a:srgbClr val="143042"/>
+              <a:rPr sz="2175" b="1">
+                <a:solidFill>
+                  <a:srgbClr val="14755E"/>
                 </a:solidFill>
                 <a:latin typeface="Arial"/>
                 <a:ea typeface="Arial"/>
                 <a:cs typeface="Arial"/>
               </a:rPr>
-              <a:t>Cartas de A: 7♣ 2♦     Cartas de B: A♥ A♦</a:t>
-            </a:r>
-          </a:p>
-        </p:txBody>
-      </p:sp>
-      <p:sp>
-        <p:nvSpPr>
-          <p:cNvPr id="5" name="Mesa: A♠ 9♥ 4♣ K♣ 3♦     B vence com trinca de ases">
+              <a:t>Final: A 50, B 170. Total conservado: 220 fichas.</a:t>
+            </a:r>
+          </a:p>
+        </p:txBody>
+      </p:sp>
+      <p:sp>
+        <p:nvSpPr>
+          <p:cNvPr id="6" name="All-in pré-flop alternativo: fold 120/100, call 0/220">
             <a:extLst xmlns:a="http://schemas.openxmlformats.org/drawingml/2006/main">
               <a:ext uri="{FF2B5EF4-FFF2-40B4-BE49-F238E27FC236}">
-                <a16:creationId xmlns:a16="http://schemas.microsoft.com/office/drawing/2014/main" id="{85047ECE-EC77-4D26-9845-21D2E11282BA}"/>
+                <a16:creationId xmlns:a16="http://schemas.microsoft.com/office/drawing/2014/main" id="{56A1DF8D-1006-496D-9EC8-B95DC81216D4}"/>
               </a:ext>
             </a:extLst>
           </p:cNvPr>
@@ -7632,8 +7863,8 @@
         </p:nvSpPr>
         <p:spPr>
           <a:xfrm xmlns:a="http://schemas.openxmlformats.org/drawingml/2006/main">
-            <a:off x="571500" y="4953000"/>
-            <a:ext cx="11049000" cy="409575"/>
+            <a:off x="571500" y="5657850"/>
+            <a:ext cx="11049000" cy="381000"/>
           </a:xfrm>
           <a:prstGeom xmlns:a="http://schemas.openxmlformats.org/drawingml/2006/main" prst="rect">
             <a:avLst/>
@@ -7650,9 +7881,9 @@
           <a:lstStyle xmlns:a="http://schemas.openxmlformats.org/drawingml/2006/main"/>
           <a:p xmlns:a="http://schemas.openxmlformats.org/drawingml/2006/main">
             <a:pPr algn="l">
-              <a:defRPr sz="2175" b="1">
-                <a:solidFill>
-                  <a:srgbClr val="14755E"/>
+              <a:defRPr sz="2025" b="0">
+                <a:solidFill>
+                  <a:srgbClr val="143042"/>
                 </a:solidFill>
                 <a:latin typeface="Arial"/>
                 <a:ea typeface="Arial"/>
@@ -7660,25 +7891,25 @@
               </a:defRPr>
             </a:pPr>
             <a:r>
-              <a:rPr sz="2175" b="1">
-                <a:solidFill>
-                  <a:srgbClr val="14755E"/>
+              <a:rPr sz="2025" b="0">
+                <a:solidFill>
+                  <a:srgbClr val="143042"/>
                 </a:solidFill>
                 <a:latin typeface="Arial"/>
                 <a:ea typeface="Arial"/>
                 <a:cs typeface="Arial"/>
               </a:rPr>
-              <a:t>Mesa: A♠ 9♥ 4♣ K♣ 3♦     B vence com trinca de ases</a:t>
-            </a:r>
-          </a:p>
-        </p:txBody>
-      </p:sp>
-      <p:sp>
-        <p:nvSpPr>
-          <p:cNvPr id="6" name="Saldos finais: A 70, B 150. Total conservado: 220 fichas.">
+              <a:t>All-in pré-flop alternativo: fold 120/100, call 0/220</a:t>
+            </a:r>
+          </a:p>
+        </p:txBody>
+      </p:sp>
+      <p:sp>
+        <p:nvSpPr>
+          <p:cNvPr id="7" name="Cenários manuais. No all-in pago, a mesa abre sem novas decisões ">
             <a:extLst xmlns:a="http://schemas.openxmlformats.org/drawingml/2006/main">
               <a:ext uri="{FF2B5EF4-FFF2-40B4-BE49-F238E27FC236}">
-                <a16:creationId xmlns:a16="http://schemas.microsoft.com/office/drawing/2014/main" id="{6AB36281-1350-4810-BB1E-AAA332D7E6E0}"/>
+                <a16:creationId xmlns:a16="http://schemas.microsoft.com/office/drawing/2014/main" id="{07DA28A2-B8EE-4901-846F-7CAAA686F71D}"/>
               </a:ext>
             </a:extLst>
           </p:cNvPr>
@@ -7689,8 +7920,8 @@
         </p:nvSpPr>
         <p:spPr>
           <a:xfrm xmlns:a="http://schemas.openxmlformats.org/drawingml/2006/main">
-            <a:off x="571500" y="5486400"/>
-            <a:ext cx="11049000" cy="457200"/>
+            <a:off x="571500" y="6115050"/>
+            <a:ext cx="11049000" cy="238125"/>
           </a:xfrm>
           <a:prstGeom xmlns:a="http://schemas.openxmlformats.org/drawingml/2006/main" prst="rect">
             <a:avLst/>
@@ -7707,9 +7938,9 @@
           <a:lstStyle xmlns:a="http://schemas.openxmlformats.org/drawingml/2006/main"/>
           <a:p xmlns:a="http://schemas.openxmlformats.org/drawingml/2006/main">
             <a:pPr algn="l">
-              <a:defRPr sz="2250" b="1">
-                <a:solidFill>
-                  <a:srgbClr val="143042"/>
+              <a:defRPr sz="1350" b="0">
+                <a:solidFill>
+                  <a:srgbClr val="486274"/>
                 </a:solidFill>
                 <a:latin typeface="Arial"/>
                 <a:ea typeface="Arial"/>
@@ -7717,72 +7948,15 @@
               </a:defRPr>
             </a:pPr>
             <a:r>
-              <a:rPr sz="2250" b="1">
-                <a:solidFill>
-                  <a:srgbClr val="143042"/>
+              <a:rPr sz="1350" b="0">
+                <a:solidFill>
+                  <a:srgbClr val="486274"/>
                 </a:solidFill>
                 <a:latin typeface="Arial"/>
                 <a:ea typeface="Arial"/>
                 <a:cs typeface="Arial"/>
               </a:rPr>
-              <a:t>Saldos finais: A 70, B 150. Total conservado: 220 fichas.</a:t>
-            </a:r>
-          </a:p>
-        </p:txBody>
-      </p:sp>
-      <p:sp>
-        <p:nvSpPr>
-          <p:cNvPr id="7" name="Cenário manual. B abre mão de apostar para induzir nova pressão d">
-            <a:extLst xmlns:a="http://schemas.openxmlformats.org/drawingml/2006/main">
-              <a:ext uri="{FF2B5EF4-FFF2-40B4-BE49-F238E27FC236}">
-                <a16:creationId xmlns:a16="http://schemas.microsoft.com/office/drawing/2014/main" id="{D7C73915-E059-46F9-A4A4-F5C54BB60F78}"/>
-              </a:ext>
-            </a:extLst>
-          </p:cNvPr>
-          <p:cNvSpPr>
-            <a:spLocks xmlns:a="http://schemas.openxmlformats.org/drawingml/2006/main" noGrp="1"/>
-          </p:cNvSpPr>
-          <p:nvPr/>
-        </p:nvSpPr>
-        <p:spPr>
-          <a:xfrm xmlns:a="http://schemas.openxmlformats.org/drawingml/2006/main">
-            <a:off x="571500" y="6038850"/>
-            <a:ext cx="11049000" cy="285750"/>
-          </a:xfrm>
-          <a:prstGeom xmlns:a="http://schemas.openxmlformats.org/drawingml/2006/main" prst="rect">
-            <a:avLst/>
-          </a:prstGeom>
-          <a:noFill xmlns:a="http://schemas.openxmlformats.org/drawingml/2006/main"/>
-          <a:ln xmlns:a="http://schemas.openxmlformats.org/drawingml/2006/main" w="0">
-            <a:noFill/>
-          </a:ln>
-        </p:spPr>
-        <p:txBody>
-          <a:bodyPr xmlns:a="http://schemas.openxmlformats.org/drawingml/2006/main" wrap="square" lIns="0" tIns="0" rIns="0" bIns="0" anchor="t">
-            <a:noAutofit/>
-          </a:bodyPr>
-          <a:lstStyle xmlns:a="http://schemas.openxmlformats.org/drawingml/2006/main"/>
-          <a:p xmlns:a="http://schemas.openxmlformats.org/drawingml/2006/main">
-            <a:pPr algn="l">
-              <a:defRPr sz="1500" b="0">
-                <a:solidFill>
-                  <a:srgbClr val="486274"/>
-                </a:solidFill>
-                <a:latin typeface="Arial"/>
-                <a:ea typeface="Arial"/>
-                <a:cs typeface="Arial"/>
-              </a:defRPr>
-            </a:pPr>
-            <a:r>
-              <a:rPr sz="1500" b="0">
-                <a:solidFill>
-                  <a:srgbClr val="486274"/>
-                </a:solidFill>
-                <a:latin typeface="Arial"/>
-                <a:ea typeface="Arial"/>
-                <a:cs typeface="Arial"/>
-              </a:rPr>
-              <a:t>Cenário manual. B abre mão de apostar para induzir nova pressão de A.</a:t>
+              <a:t>Cenários manuais. No all-in pago, a mesa abre sem novas decisões de aposta.</a:t>
             </a:r>
           </a:p>
         </p:txBody>
@@ -7790,7 +7964,7 @@
     </p:spTree>
     <p:extLst>
       <p:ext uri="{BB962C8B-B14F-4D97-AF65-F5344CB8AC3E}">
-        <p14:creationId xmlns:p14="http://schemas.microsoft.com/office/powerpoint/2010/main" val="461304653"/>
+        <p14:creationId xmlns:p14="http://schemas.microsoft.com/office/powerpoint/2010/main" val="1368907498"/>
       </p:ext>
     </p:extLst>
   </p:cSld>
@@ -7821,7 +7995,7 @@
           <p:cNvPr id="19" name="Superfície de ataque">
             <a:extLst xmlns:a="http://schemas.openxmlformats.org/drawingml/2006/main">
               <a:ext uri="{FF2B5EF4-FFF2-40B4-BE49-F238E27FC236}">
-                <a16:creationId xmlns:a16="http://schemas.microsoft.com/office/drawing/2014/main" id="{49E78FF9-54AC-4278-90F9-49BB111AE330}"/>
+                <a16:creationId xmlns:a16="http://schemas.microsoft.com/office/drawing/2014/main" id="{E44DF9E7-0AB6-4D6B-AA55-97D4E07CF696}"/>
               </a:ext>
             </a:extLst>
           </p:cNvPr>
@@ -7878,7 +8052,7 @@
           <p:cNvPr id="2" name="Grupo 7 · Poker Adversarial · 7/12">
             <a:extLst xmlns:a="http://schemas.openxmlformats.org/drawingml/2006/main">
               <a:ext uri="{FF2B5EF4-FFF2-40B4-BE49-F238E27FC236}">
-                <a16:creationId xmlns:a16="http://schemas.microsoft.com/office/drawing/2014/main" id="{B3904A06-FDDD-4E86-8BAC-3A10DEC61390}"/>
+                <a16:creationId xmlns:a16="http://schemas.microsoft.com/office/drawing/2014/main" id="{235D8FCE-1BBB-42F3-BE91-EF158FCF6ADC}"/>
               </a:ext>
             </a:extLst>
           </p:cNvPr>
@@ -7935,7 +8109,7 @@
           <p:cNvPr id="3" name="Módulo adversarial">
             <a:extLst xmlns:a="http://schemas.openxmlformats.org/drawingml/2006/main">
               <a:ext uri="{FF2B5EF4-FFF2-40B4-BE49-F238E27FC236}">
-                <a16:creationId xmlns:a16="http://schemas.microsoft.com/office/drawing/2014/main" id="{73F97ECC-50F4-47E5-B850-90DAF53FC567}"/>
+                <a16:creationId xmlns:a16="http://schemas.microsoft.com/office/drawing/2014/main" id="{7C895B03-56A1-4043-A81A-428B29C0BEC9}"/>
               </a:ext>
             </a:extLst>
           </p:cNvPr>
@@ -7996,7 +8170,7 @@
           <p:cNvPr id="4" name="T1: visão e histórico Campo privado sem filtro Falha de P1">
             <a:extLst xmlns:a="http://schemas.openxmlformats.org/drawingml/2006/main">
               <a:ext uri="{FF2B5EF4-FFF2-40B4-BE49-F238E27FC236}">
-                <a16:creationId xmlns:a16="http://schemas.microsoft.com/office/drawing/2014/main" id="{D9034AAE-61EE-4E0B-8047-E7415F89E161}"/>
+                <a16:creationId xmlns:a16="http://schemas.microsoft.com/office/drawing/2014/main" id="{7BAEAD23-06CF-4F4B-B945-7345EB480262}"/>
               </a:ext>
             </a:extLst>
           </p:cNvPr>
@@ -8100,10 +8274,10 @@
       </p:sp>
       <p:sp>
         <p:nvSpPr>
-          <p:cNvPr id="5" name="T2: entrada de ações Valor ou vez sem validação Falha de P2">
+          <p:cNvPr id="5" name="T2: entrada de ações Raise, call ou devolução inválidos Falha de P2">
             <a:extLst xmlns:a="http://schemas.openxmlformats.org/drawingml/2006/main">
               <a:ext uri="{FF2B5EF4-FFF2-40B4-BE49-F238E27FC236}">
-                <a16:creationId xmlns:a16="http://schemas.microsoft.com/office/drawing/2014/main" id="{7C39047A-EB3E-4AF1-8391-3EC8095FB09C}"/>
+                <a16:creationId xmlns:a16="http://schemas.microsoft.com/office/drawing/2014/main" id="{29A9A203-0BE0-42BD-BBE3-3D3FE18867C9}"/>
               </a:ext>
             </a:extLst>
           </p:cNvPr>
@@ -8136,7 +8310,7 @@
           <a:lstStyle xmlns:a="http://schemas.openxmlformats.org/drawingml/2006/main"/>
           <a:p xmlns:a="http://schemas.openxmlformats.org/drawingml/2006/main">
             <a:pPr algn="ctr">
-              <a:defRPr sz="1800" b="0">
+              <a:defRPr sz="1650" b="0">
                 <a:solidFill>
                   <a:srgbClr val="143042"/>
                 </a:solidFill>
@@ -8146,7 +8320,7 @@
               </a:defRPr>
             </a:pPr>
             <a:r>
-              <a:rPr sz="1800" b="0">
+              <a:rPr sz="1650" b="0">
                 <a:solidFill>
                   <a:srgbClr val="143042"/>
                 </a:solidFill>
@@ -8159,7 +8333,7 @@
           </a:p>
           <a:p xmlns:a="http://schemas.openxmlformats.org/drawingml/2006/main">
             <a:pPr algn="ctr">
-              <a:defRPr sz="1800" b="0">
+              <a:defRPr sz="1650" b="0">
                 <a:solidFill>
                   <a:srgbClr val="143042"/>
                 </a:solidFill>
@@ -8169,7 +8343,7 @@
               </a:defRPr>
             </a:pPr>
             <a:r>
-              <a:rPr sz="1800" b="0">
+              <a:rPr sz="1650" b="0">
                 <a:solidFill>
                   <a:srgbClr val="143042"/>
                 </a:solidFill>
@@ -8177,12 +8351,12 @@
                 <a:ea typeface="Arial"/>
                 <a:cs typeface="Arial"/>
               </a:rPr>
-              <a:t>Valor ou vez sem validação</a:t>
+              <a:t>Raise, call ou devolução inválidos</a:t>
             </a:r>
           </a:p>
           <a:p xmlns:a="http://schemas.openxmlformats.org/drawingml/2006/main">
             <a:pPr algn="ctr">
-              <a:defRPr sz="1800" b="0">
+              <a:defRPr sz="1650" b="0">
                 <a:solidFill>
                   <a:srgbClr val="143042"/>
                 </a:solidFill>
@@ -8192,7 +8366,7 @@
               </a:defRPr>
             </a:pPr>
             <a:r>
-              <a:rPr sz="1800" b="0">
+              <a:rPr sz="1650" b="0">
                 <a:solidFill>
                   <a:srgbClr val="143042"/>
                 </a:solidFill>
@@ -8210,7 +8384,7 @@
           <p:cNvPr id="6" name="T3: executor Decisão sem limite Falha de P3">
             <a:extLst xmlns:a="http://schemas.openxmlformats.org/drawingml/2006/main">
               <a:ext uri="{FF2B5EF4-FFF2-40B4-BE49-F238E27FC236}">
-                <a16:creationId xmlns:a16="http://schemas.microsoft.com/office/drawing/2014/main" id="{6B29F13D-4C75-47A9-A5CA-497B805D02F9}"/>
+                <a16:creationId xmlns:a16="http://schemas.microsoft.com/office/drawing/2014/main" id="{A7FEF7F8-C6DB-4554-A6ED-ABD5AD95CEB5}"/>
               </a:ext>
             </a:extLst>
           </p:cNvPr>
@@ -8317,7 +8491,7 @@
           <p:cNvPr id="7" name="Sigilo e justiça Risco 9">
             <a:extLst xmlns:a="http://schemas.openxmlformats.org/drawingml/2006/main">
               <a:ext uri="{FF2B5EF4-FFF2-40B4-BE49-F238E27FC236}">
-                <a16:creationId xmlns:a16="http://schemas.microsoft.com/office/drawing/2014/main" id="{DA63B170-7828-486D-8F9B-829A22D7144D}"/>
+                <a16:creationId xmlns:a16="http://schemas.microsoft.com/office/drawing/2014/main" id="{253E76E6-0EA0-470B-A3E8-B0772159E77C}"/>
               </a:ext>
             </a:extLst>
           </p:cNvPr>
@@ -8401,7 +8575,7 @@
           <p:cNvPr id="8" name="Integridade e fichas Risco 9">
             <a:extLst xmlns:a="http://schemas.openxmlformats.org/drawingml/2006/main">
               <a:ext uri="{FF2B5EF4-FFF2-40B4-BE49-F238E27FC236}">
-                <a16:creationId xmlns:a16="http://schemas.microsoft.com/office/drawing/2014/main" id="{B1341F29-CFD2-434A-89D9-C6EF3F62C3E2}"/>
+                <a16:creationId xmlns:a16="http://schemas.microsoft.com/office/drawing/2014/main" id="{D504BDD3-3411-4F86-9C81-AEB9E15AD4F7}"/>
               </a:ext>
             </a:extLst>
           </p:cNvPr>
@@ -8485,7 +8659,7 @@
           <p:cNvPr id="9" name="Progresso Risco 6">
             <a:extLst xmlns:a="http://schemas.openxmlformats.org/drawingml/2006/main">
               <a:ext uri="{FF2B5EF4-FFF2-40B4-BE49-F238E27FC236}">
-                <a16:creationId xmlns:a16="http://schemas.microsoft.com/office/drawing/2014/main" id="{2837C4F7-B5D8-47BB-BEF3-0E75DFA0361D}"/>
+                <a16:creationId xmlns:a16="http://schemas.microsoft.com/office/drawing/2014/main" id="{129A74F4-7586-49FD-9B87-706F53380FC2}"/>
               </a:ext>
             </a:extLst>
           </p:cNvPr>
@@ -8731,7 +8905,7 @@
           <p:cNvPr id="16" name="C1: filtrar saídas">
             <a:extLst xmlns:a="http://schemas.openxmlformats.org/drawingml/2006/main">
               <a:ext uri="{FF2B5EF4-FFF2-40B4-BE49-F238E27FC236}">
-                <a16:creationId xmlns:a16="http://schemas.microsoft.com/office/drawing/2014/main" id="{21F680B0-1C72-43E6-8CD0-C5E4BB35997C}"/>
+                <a16:creationId xmlns:a16="http://schemas.microsoft.com/office/drawing/2014/main" id="{E3B928B9-22A3-4455-8863-039A4DAC51C2}"/>
               </a:ext>
             </a:extLst>
           </p:cNvPr>
@@ -8785,10 +8959,10 @@
       </p:sp>
       <p:sp>
         <p:nvSpPr>
-          <p:cNvPr id="17" name="C2/C3: validar, aplicar uma vez">
+          <p:cNvPr id="17" name="C2/C3: validar fichas e aplicar uma vez">
             <a:extLst xmlns:a="http://schemas.openxmlformats.org/drawingml/2006/main">
               <a:ext uri="{FF2B5EF4-FFF2-40B4-BE49-F238E27FC236}">
-                <a16:creationId xmlns:a16="http://schemas.microsoft.com/office/drawing/2014/main" id="{6B7148EA-562A-4A16-A9E2-5346B43F3E29}"/>
+                <a16:creationId xmlns:a16="http://schemas.microsoft.com/office/drawing/2014/main" id="{7561E733-94FD-43DD-8ECC-926607225055}"/>
               </a:ext>
             </a:extLst>
           </p:cNvPr>
@@ -8835,7 +9009,7 @@
                 <a:ea typeface="Arial"/>
                 <a:cs typeface="Arial"/>
               </a:rPr>
-              <a:t>C2/C3: validar, aplicar uma vez</a:t>
+              <a:t>C2/C3: validar fichas e aplicar uma vez</a:t>
             </a:r>
           </a:p>
         </p:txBody>
@@ -8845,7 +9019,7 @@
           <p:cNvPr id="18" name="C4: orçamento e ação padrão">
             <a:extLst xmlns:a="http://schemas.openxmlformats.org/drawingml/2006/main">
               <a:ext uri="{FF2B5EF4-FFF2-40B4-BE49-F238E27FC236}">
-                <a16:creationId xmlns:a16="http://schemas.microsoft.com/office/drawing/2014/main" id="{A9322526-7F74-4D2E-9B60-3AA2D62CC591}"/>
+                <a16:creationId xmlns:a16="http://schemas.microsoft.com/office/drawing/2014/main" id="{92A605C0-0502-417C-A8E9-7E02E6621F32}"/>
               </a:ext>
             </a:extLst>
           </p:cNvPr>
@@ -8900,7 +9074,7 @@
     </p:spTree>
     <p:extLst>
       <p:ext uri="{BB962C8B-B14F-4D97-AF65-F5344CB8AC3E}">
-        <p14:creationId xmlns:p14="http://schemas.microsoft.com/office/powerpoint/2010/main" val="1289381786"/>
+        <p14:creationId xmlns:p14="http://schemas.microsoft.com/office/powerpoint/2010/main" val="491582510"/>
       </p:ext>
     </p:extLst>
   </p:cSld>
@@ -8931,7 +9105,7 @@
           <p:cNvPr id="7" name="Cenários e avaliação dos riscos">
             <a:extLst xmlns:a="http://schemas.openxmlformats.org/drawingml/2006/main">
               <a:ext uri="{FF2B5EF4-FFF2-40B4-BE49-F238E27FC236}">
-                <a16:creationId xmlns:a16="http://schemas.microsoft.com/office/drawing/2014/main" id="{B4A4D1F5-3091-40D9-B246-ADC2EEF60808}"/>
+                <a16:creationId xmlns:a16="http://schemas.microsoft.com/office/drawing/2014/main" id="{3D7BE038-4AB0-4713-AE99-361357C6740A}"/>
               </a:ext>
             </a:extLst>
           </p:cNvPr>
@@ -8988,7 +9162,7 @@
           <p:cNvPr id="2" name="Grupo 7 · Poker Adversarial · 8/12">
             <a:extLst xmlns:a="http://schemas.openxmlformats.org/drawingml/2006/main">
               <a:ext uri="{FF2B5EF4-FFF2-40B4-BE49-F238E27FC236}">
-                <a16:creationId xmlns:a16="http://schemas.microsoft.com/office/drawing/2014/main" id="{B9B4D3CE-6F8F-4D69-87DD-0952879E21EC}"/>
+                <a16:creationId xmlns:a16="http://schemas.microsoft.com/office/drawing/2014/main" id="{E8924BD9-8D6B-4175-AB2E-FE0AC22FA72E}"/>
               </a:ext>
             </a:extLst>
           </p:cNvPr>
@@ -9618,7 +9792,7 @@
           <p:cNvPr id="4" name="P = sucesso da tentativa, supondo a fraqueza presente">
             <a:extLst xmlns:a="http://schemas.openxmlformats.org/drawingml/2006/main">
               <a:ext uri="{FF2B5EF4-FFF2-40B4-BE49-F238E27FC236}">
-                <a16:creationId xmlns:a16="http://schemas.microsoft.com/office/drawing/2014/main" id="{59748950-2F36-4B80-BE3B-09127378241F}"/>
+                <a16:creationId xmlns:a16="http://schemas.microsoft.com/office/drawing/2014/main" id="{58EA5865-92AA-40F9-AF4E-1AE24B389964}"/>
               </a:ext>
             </a:extLst>
           </p:cNvPr>
@@ -9675,7 +9849,7 @@
           <p:cNvPr id="5" name="Leitura, ação inválida e bloqueio são diretos sem os controles.">
             <a:extLst xmlns:a="http://schemas.openxmlformats.org/drawingml/2006/main">
               <a:ext uri="{FF2B5EF4-FFF2-40B4-BE49-F238E27FC236}">
-                <a16:creationId xmlns:a16="http://schemas.microsoft.com/office/drawing/2014/main" id="{3F848D59-8E1D-427D-8A0E-E76E526724C6}"/>
+                <a16:creationId xmlns:a16="http://schemas.microsoft.com/office/drawing/2014/main" id="{F0F69C93-1F42-4FF1-A02A-641D4AE7E0C4}"/>
               </a:ext>
             </a:extLst>
           </p:cNvPr>
@@ -9732,7 +9906,7 @@
           <p:cNvPr id="6" name="Impacto: T1/T2 invalidam justiça. T3 interrompe o progresso.">
             <a:extLst xmlns:a="http://schemas.openxmlformats.org/drawingml/2006/main">
               <a:ext uri="{FF2B5EF4-FFF2-40B4-BE49-F238E27FC236}">
-                <a16:creationId xmlns:a16="http://schemas.microsoft.com/office/drawing/2014/main" id="{4649FD20-B1D3-4279-A717-C7C94C6861C0}"/>
+                <a16:creationId xmlns:a16="http://schemas.microsoft.com/office/drawing/2014/main" id="{7EF81933-48E8-4C0D-8763-2D3A15EB97A4}"/>
               </a:ext>
             </a:extLst>
           </p:cNvPr>
@@ -9787,7 +9961,7 @@
     </p:spTree>
     <p:extLst>
       <p:ext uri="{BB962C8B-B14F-4D97-AF65-F5344CB8AC3E}">
-        <p14:creationId xmlns:p14="http://schemas.microsoft.com/office/powerpoint/2010/main" val="2108390995"/>
+        <p14:creationId xmlns:p14="http://schemas.microsoft.com/office/powerpoint/2010/main" val="1720446291"/>
       </p:ext>
     </p:extLst>
   </p:cSld>
@@ -9818,7 +9992,7 @@
           <p:cNvPr id="13" name="Prioridade e próxima adaptação">
             <a:extLst xmlns:a="http://schemas.openxmlformats.org/drawingml/2006/main">
               <a:ext uri="{FF2B5EF4-FFF2-40B4-BE49-F238E27FC236}">
-                <a16:creationId xmlns:a16="http://schemas.microsoft.com/office/drawing/2014/main" id="{9F860050-C58D-48A7-8F86-26A7F30ACAFE}"/>
+                <a16:creationId xmlns:a16="http://schemas.microsoft.com/office/drawing/2014/main" id="{ED2A4493-D3B3-4F87-AD6B-6FF9C3F633E9}"/>
               </a:ext>
             </a:extLst>
           </p:cNvPr>
@@ -9875,7 +10049,7 @@
           <p:cNvPr id="2" name="Grupo 7 · Poker Adversarial · 9/12">
             <a:extLst xmlns:a="http://schemas.openxmlformats.org/drawingml/2006/main">
               <a:ext uri="{FF2B5EF4-FFF2-40B4-BE49-F238E27FC236}">
-                <a16:creationId xmlns:a16="http://schemas.microsoft.com/office/drawing/2014/main" id="{B6AD2D8B-57B0-4E9A-A90C-BEA96ECE6B40}"/>
+                <a16:creationId xmlns:a16="http://schemas.microsoft.com/office/drawing/2014/main" id="{DDA4B219-A17E-4659-B19B-758D6CA2ED7A}"/>
               </a:ext>
             </a:extLst>
           </p:cNvPr>
@@ -9932,7 +10106,7 @@
           <p:cNvPr id="3" name="T1 e T2 empatam em 9. A informação exposta não pode ser esquecida">
             <a:extLst xmlns:a="http://schemas.openxmlformats.org/drawingml/2006/main">
               <a:ext uri="{FF2B5EF4-FFF2-40B4-BE49-F238E27FC236}">
-                <a16:creationId xmlns:a16="http://schemas.microsoft.com/office/drawing/2014/main" id="{7612A51C-7E8A-444A-892E-E29696452DFA}"/>
+                <a16:creationId xmlns:a16="http://schemas.microsoft.com/office/drawing/2014/main" id="{5E22645F-D2FB-4596-AB07-577AEB4D56E4}"/>
               </a:ext>
             </a:extLst>
           </p:cNvPr>
@@ -9989,7 +10163,7 @@
           <p:cNvPr id="4" name="Consulta campo privado">
             <a:extLst xmlns:a="http://schemas.openxmlformats.org/drawingml/2006/main">
               <a:ext uri="{FF2B5EF4-FFF2-40B4-BE49-F238E27FC236}">
-                <a16:creationId xmlns:a16="http://schemas.microsoft.com/office/drawing/2014/main" id="{DA42603D-140D-4572-BCCD-4EB340B55D80}"/>
+                <a16:creationId xmlns:a16="http://schemas.microsoft.com/office/drawing/2014/main" id="{63CC6E9C-4F92-480B-B684-AAAAF3E7B990}"/>
               </a:ext>
             </a:extLst>
           </p:cNvPr>
@@ -10050,7 +10224,7 @@
           <p:cNvPr id="5" name="Recebe visão filtrada">
             <a:extLst xmlns:a="http://schemas.openxmlformats.org/drawingml/2006/main">
               <a:ext uri="{FF2B5EF4-FFF2-40B4-BE49-F238E27FC236}">
-                <a16:creationId xmlns:a16="http://schemas.microsoft.com/office/drawing/2014/main" id="{8B5FFDAC-239F-4559-BA97-D12212AC4383}"/>
+                <a16:creationId xmlns:a16="http://schemas.microsoft.com/office/drawing/2014/main" id="{C3A4B6B8-E033-4AA2-AA9C-5A44B9078378}"/>
               </a:ext>
             </a:extLst>
           </p:cNvPr>
@@ -10111,7 +10285,7 @@
           <p:cNvPr id="6" name="Procura no histórico">
             <a:extLst xmlns:a="http://schemas.openxmlformats.org/drawingml/2006/main">
               <a:ext uri="{FF2B5EF4-FFF2-40B4-BE49-F238E27FC236}">
-                <a16:creationId xmlns:a16="http://schemas.microsoft.com/office/drawing/2014/main" id="{17320700-125A-4412-B4BE-08D12C06E2DE}"/>
+                <a16:creationId xmlns:a16="http://schemas.microsoft.com/office/drawing/2014/main" id="{7C8ABE0D-D994-4B77-8745-0B9E835E7FEA}"/>
               </a:ext>
             </a:extLst>
           </p:cNvPr>
@@ -10172,7 +10346,7 @@
           <p:cNvPr id="7" name="Histórico também filtrado">
             <a:extLst xmlns:a="http://schemas.openxmlformats.org/drawingml/2006/main">
               <a:ext uri="{FF2B5EF4-FFF2-40B4-BE49-F238E27FC236}">
-                <a16:creationId xmlns:a16="http://schemas.microsoft.com/office/drawing/2014/main" id="{C5059E6F-DA33-4DD3-AECE-E32726ADE413}"/>
+                <a16:creationId xmlns:a16="http://schemas.microsoft.com/office/drawing/2014/main" id="{AA374612-16D0-4A86-A50D-11C9B1818012}"/>
               </a:ext>
             </a:extLst>
           </p:cNvPr>
@@ -10315,7 +10489,7 @@
           <p:cNvPr id="11" name="Custo: filtro pode omitir informação pública necessária.">
             <a:extLst xmlns:a="http://schemas.openxmlformats.org/drawingml/2006/main">
               <a:ext uri="{FF2B5EF4-FFF2-40B4-BE49-F238E27FC236}">
-                <a16:creationId xmlns:a16="http://schemas.microsoft.com/office/drawing/2014/main" id="{BBE04DD6-667D-4B64-B5E3-19BEC4669E4E}"/>
+                <a16:creationId xmlns:a16="http://schemas.microsoft.com/office/drawing/2014/main" id="{FF11DEA2-C3FF-4B75-A1DD-3A2D48354F80}"/>
               </a:ext>
             </a:extLst>
           </p:cNvPr>
@@ -10372,7 +10546,7 @@
           <p:cNvPr id="12" name="Risco residual: outro canal pode expor dados. Sequência hipotétic">
             <a:extLst xmlns:a="http://schemas.openxmlformats.org/drawingml/2006/main">
               <a:ext uri="{FF2B5EF4-FFF2-40B4-BE49-F238E27FC236}">
-                <a16:creationId xmlns:a16="http://schemas.microsoft.com/office/drawing/2014/main" id="{2E3260D7-D4BA-47C9-8001-3ADC4F275FFA}"/>
+                <a16:creationId xmlns:a16="http://schemas.microsoft.com/office/drawing/2014/main" id="{1EFF8C75-02EF-4D57-B8F3-2D918B6BA204}"/>
               </a:ext>
             </a:extLst>
           </p:cNvPr>
@@ -10427,7 +10601,7 @@
     </p:spTree>
     <p:extLst>
       <p:ext uri="{BB962C8B-B14F-4D97-AF65-F5344CB8AC3E}">
-        <p14:creationId xmlns:p14="http://schemas.microsoft.com/office/powerpoint/2010/main" val="1201825517"/>
+        <p14:creationId xmlns:p14="http://schemas.microsoft.com/office/powerpoint/2010/main" val="755095469"/>
       </p:ext>
     </p:extLst>
   </p:cSld>

</xml_diff>

<commit_message>
docs: organiza relatório de entrega e adiciona guia interno
</commit_message>
<xml_diff>
--- a/apresentacao/slides.pptx
+++ b/apresentacao/slides.pptx
@@ -2,24 +2,24 @@
 <file path=ppt/presentation.xml><?xml version="1.0" encoding="utf-8"?>
 <p:presentation xmlns:p="http://schemas.openxmlformats.org/presentationml/2006/main">
   <p:sldMasterIdLst>
-    <p:sldMasterId xmlns:r="http://schemas.openxmlformats.org/officeDocument/2006/relationships" id="2147483648" r:id="Rd38427a096644d9b"/>
+    <p:sldMasterId xmlns:r="http://schemas.openxmlformats.org/officeDocument/2006/relationships" id="2147483648" r:id="R2b85727b264d4d73"/>
   </p:sldMasterIdLst>
   <p:notesMasterIdLst>
-    <p:notesMasterId xmlns:r="http://schemas.openxmlformats.org/officeDocument/2006/relationships" r:id="R0abed77a871940ae"/>
+    <p:notesMasterId xmlns:r="http://schemas.openxmlformats.org/officeDocument/2006/relationships" r:id="Read567d4262045e1"/>
   </p:notesMasterIdLst>
   <p:sldIdLst>
-    <p:sldId xmlns:r="http://schemas.openxmlformats.org/officeDocument/2006/relationships" id="256" r:id="R137e381d852643ea"/>
-    <p:sldId xmlns:r="http://schemas.openxmlformats.org/officeDocument/2006/relationships" id="257" r:id="R0787c6c2874f4ce2"/>
-    <p:sldId xmlns:r="http://schemas.openxmlformats.org/officeDocument/2006/relationships" id="258" r:id="Rfe2aee3268884f0f"/>
-    <p:sldId xmlns:r="http://schemas.openxmlformats.org/officeDocument/2006/relationships" id="259" r:id="Rd7bb33d73029403b"/>
-    <p:sldId xmlns:r="http://schemas.openxmlformats.org/officeDocument/2006/relationships" id="260" r:id="R5e19af5675634f78"/>
-    <p:sldId xmlns:r="http://schemas.openxmlformats.org/officeDocument/2006/relationships" id="261" r:id="Re0f244a3d4f345c6"/>
-    <p:sldId xmlns:r="http://schemas.openxmlformats.org/officeDocument/2006/relationships" id="262" r:id="R4a2cb2ce3f4d484c"/>
-    <p:sldId xmlns:r="http://schemas.openxmlformats.org/officeDocument/2006/relationships" id="263" r:id="R539accbb9e264954"/>
-    <p:sldId xmlns:r="http://schemas.openxmlformats.org/officeDocument/2006/relationships" id="264" r:id="Rb39e84e8cb5143a7"/>
-    <p:sldId xmlns:r="http://schemas.openxmlformats.org/officeDocument/2006/relationships" id="265" r:id="R618a110478994bf1"/>
-    <p:sldId xmlns:r="http://schemas.openxmlformats.org/officeDocument/2006/relationships" id="266" r:id="R6a65515d42b64873"/>
-    <p:sldId xmlns:r="http://schemas.openxmlformats.org/officeDocument/2006/relationships" id="267" r:id="R059ea6cb228346ff"/>
+    <p:sldId xmlns:r="http://schemas.openxmlformats.org/officeDocument/2006/relationships" id="256" r:id="R42d3bd3b868e47d6"/>
+    <p:sldId xmlns:r="http://schemas.openxmlformats.org/officeDocument/2006/relationships" id="257" r:id="Rf2670fc440b543b0"/>
+    <p:sldId xmlns:r="http://schemas.openxmlformats.org/officeDocument/2006/relationships" id="258" r:id="Rcb2b7a4bf6104756"/>
+    <p:sldId xmlns:r="http://schemas.openxmlformats.org/officeDocument/2006/relationships" id="259" r:id="Rc7aa0538badd4a27"/>
+    <p:sldId xmlns:r="http://schemas.openxmlformats.org/officeDocument/2006/relationships" id="260" r:id="R37bf1d7b6daf49b1"/>
+    <p:sldId xmlns:r="http://schemas.openxmlformats.org/officeDocument/2006/relationships" id="261" r:id="R8cc6e27674624ec5"/>
+    <p:sldId xmlns:r="http://schemas.openxmlformats.org/officeDocument/2006/relationships" id="262" r:id="Rd451fd3b172c47cc"/>
+    <p:sldId xmlns:r="http://schemas.openxmlformats.org/officeDocument/2006/relationships" id="263" r:id="R42630e70a02b4ca2"/>
+    <p:sldId xmlns:r="http://schemas.openxmlformats.org/officeDocument/2006/relationships" id="264" r:id="Rc991b9c8a5c443b9"/>
+    <p:sldId xmlns:r="http://schemas.openxmlformats.org/officeDocument/2006/relationships" id="265" r:id="R5fb6462987f94fcb"/>
+    <p:sldId xmlns:r="http://schemas.openxmlformats.org/officeDocument/2006/relationships" id="266" r:id="R6ba241c58a0043a8"/>
+    <p:sldId xmlns:r="http://schemas.openxmlformats.org/officeDocument/2006/relationships" id="267" r:id="Rb51a4075f5b047cf"/>
   </p:sldIdLst>
   <p:sldSz cx="12192000" cy="6858000"/>
   <p:notesSz cx="6858000" cy="9144000"/>
@@ -473,7 +473,7 @@
           </a:p>
           <a:p xmlns:a="http://schemas.openxmlformats.org/drawingml/2006/main">
             <a:r>
-              <a:t>Cenário sintético e análise de planejamento. Revisão humana e gravação pendentes.</a:t>
+              <a:t>Cenário sintético e análise de planejamento.</a:t>
             </a:r>
           </a:p>
         </p:txBody>
@@ -568,7 +568,7 @@
           </a:p>
           <a:p xmlns:a="http://schemas.openxmlformats.org/drawingml/2006/main">
             <a:r>
-              <a:t>Cenário sintético e análise de planejamento. Revisão humana e gravação pendentes.</a:t>
+              <a:t>Cenário sintético e análise de planejamento.</a:t>
             </a:r>
           </a:p>
         </p:txBody>
@@ -663,7 +663,7 @@
           </a:p>
           <a:p xmlns:a="http://schemas.openxmlformats.org/drawingml/2006/main">
             <a:r>
-              <a:t>Cenário sintético e análise de planejamento. Revisão humana e gravação pendentes.</a:t>
+              <a:t>Cenário sintético e análise de planejamento.</a:t>
             </a:r>
           </a:p>
         </p:txBody>
@@ -733,7 +733,7 @@
           <a:lstStyle xmlns:a="http://schemas.openxmlformats.org/drawingml/2006/main"/>
           <a:p xmlns:a="http://schemas.openxmlformats.org/drawingml/2006/main">
             <a:r>
-              <a:t>Depois da resposta, o outro lado aprende com as ações e os limites observáveis. Pode mudar seus blefes, suas decisões de pagar ou o caminho pelo qual procura informação. Apesar disso, o sistema precisa preservar sigilo, fichas e progresso da mão. As fontes que sustentam regras e conceitos ficam no relatório, junto da declaração das tarefas em que usamos IA. Antes de entregar, cada integrante deve conferir contas e conceitos e registrar sua contribuição real. Essa verificação inclui explicar a adaptação dos dois agentes, os limites da matriz e os critérios dos riscos. A análise resultante será a base da implementação no Trabalho 2.</a:t>
+              <a:t>Depois da resposta, o outro lado aprende com as ações e os limites observáveis. Pode mudar seus blefes, suas decisões de pagar ou o caminho pelo qual procura informação. Apesar disso, o sistema precisa preservar sigilo, fichas e progresso da mão. As fontes que sustentam regras e conceitos ficam no relatório, junto da declaração das tarefas em que usamos IA. A adaptação dos dois agentes, os limites da matriz e os critérios dos riscos fazem parte da análise. As contribuições registradas estão no relatório e no Git. Essa análise será a base da implementação no Trabalho 2.</a:t>
             </a:r>
           </a:p>
           <a:p xmlns:a="http://schemas.openxmlformats.org/drawingml/2006/main">
@@ -783,7 +783,7 @@
           </a:p>
           <a:p xmlns:a="http://schemas.openxmlformats.org/drawingml/2006/main">
             <a:r>
-              <a:t>Cenário sintético e análise de planejamento. Revisão humana e gravação pendentes.</a:t>
+              <a:t>Cenário sintético e análise de planejamento.</a:t>
             </a:r>
           </a:p>
         </p:txBody>
@@ -878,7 +878,7 @@
           </a:p>
           <a:p xmlns:a="http://schemas.openxmlformats.org/drawingml/2006/main">
             <a:r>
-              <a:t>Cenário sintético e análise de planejamento. Revisão humana e gravação pendentes.</a:t>
+              <a:t>Cenário sintético e análise de planejamento.</a:t>
             </a:r>
           </a:p>
         </p:txBody>
@@ -968,7 +968,7 @@
           </a:p>
           <a:p xmlns:a="http://schemas.openxmlformats.org/drawingml/2006/main">
             <a:r>
-              <a:t>Cenário sintético e análise de planejamento. Revisão humana e gravação pendentes.</a:t>
+              <a:t>Cenário sintético e análise de planejamento.</a:t>
             </a:r>
           </a:p>
         </p:txBody>
@@ -1058,7 +1058,7 @@
           </a:p>
           <a:p xmlns:a="http://schemas.openxmlformats.org/drawingml/2006/main">
             <a:r>
-              <a:t>Cenário sintético e análise de planejamento. Revisão humana e gravação pendentes.</a:t>
+              <a:t>Cenário sintético e análise de planejamento.</a:t>
             </a:r>
           </a:p>
         </p:txBody>
@@ -1148,7 +1148,7 @@
           </a:p>
           <a:p xmlns:a="http://schemas.openxmlformats.org/drawingml/2006/main">
             <a:r>
-              <a:t>Cenário sintético e análise de planejamento. Revisão humana e gravação pendentes.</a:t>
+              <a:t>Cenário sintético e análise de planejamento.</a:t>
             </a:r>
           </a:p>
         </p:txBody>
@@ -1248,7 +1248,7 @@
           </a:p>
           <a:p xmlns:a="http://schemas.openxmlformats.org/drawingml/2006/main">
             <a:r>
-              <a:t>Cenário sintético e análise de planejamento. Revisão humana e gravação pendentes.</a:t>
+              <a:t>Cenário sintético e análise de planejamento.</a:t>
             </a:r>
           </a:p>
         </p:txBody>
@@ -1338,7 +1338,7 @@
           </a:p>
           <a:p xmlns:a="http://schemas.openxmlformats.org/drawingml/2006/main">
             <a:r>
-              <a:t>Cenário sintético e análise de planejamento. Revisão humana e gravação pendentes.</a:t>
+              <a:t>Cenário sintético e análise de planejamento.</a:t>
             </a:r>
           </a:p>
         </p:txBody>
@@ -1428,7 +1428,7 @@
           </a:p>
           <a:p xmlns:a="http://schemas.openxmlformats.org/drawingml/2006/main">
             <a:r>
-              <a:t>Cenário sintético e análise de planejamento. Revisão humana e gravação pendentes.</a:t>
+              <a:t>Cenário sintético e análise de planejamento.</a:t>
             </a:r>
           </a:p>
         </p:txBody>
@@ -1518,7 +1518,7 @@
           </a:p>
           <a:p xmlns:a="http://schemas.openxmlformats.org/drawingml/2006/main">
             <a:r>
-              <a:t>Cenário sintético e análise de planejamento. Revisão humana e gravação pendentes.</a:t>
+              <a:t>Cenário sintético e análise de planejamento.</a:t>
             </a:r>
           </a:p>
         </p:txBody>
@@ -1586,7 +1586,7 @@
   </p:cSld>
   <p:clrMap bg1="lt1" tx1="dk1" bg2="lt2" tx2="dk2" accent1="accent1" accent2="accent2" accent3="accent3" accent4="accent4" accent5="accent5" accent6="accent6" hlink="hlink" folHlink="folHlink"/>
   <p:sldLayoutIdLst>
-    <p:sldLayoutId xmlns:r="http://schemas.openxmlformats.org/officeDocument/2006/relationships" id="2147483649" r:id="R5bd41a7dbbb34125"/>
+    <p:sldLayoutId xmlns:r="http://schemas.openxmlformats.org/officeDocument/2006/relationships" id="2147483649" r:id="R15474761b88d4665"/>
   </p:sldLayoutIdLst>
   <p:txStyles>
     <p:titleStyle>
@@ -2166,6 +2166,7 @@
           <a:lstStyle xmlns:a="http://schemas.openxmlformats.org/drawingml/2006/main"/>
           <a:p xmlns:a="http://schemas.openxmlformats.org/drawingml/2006/main">
             <a:pPr algn="l">
+              <a:buNone/>
               <a:defRPr sz="3300" b="1">
                 <a:solidFill>
                   <a:srgbClr val="143042"/>
@@ -2223,6 +2224,7 @@
           <a:lstStyle xmlns:a="http://schemas.openxmlformats.org/drawingml/2006/main"/>
           <a:p xmlns:a="http://schemas.openxmlformats.org/drawingml/2006/main">
             <a:pPr algn="l">
+              <a:buNone/>
               <a:defRPr sz="1275" b="0">
                 <a:solidFill>
                   <a:srgbClr val="486274"/>
@@ -2280,6 +2282,7 @@
           <a:lstStyle xmlns:a="http://schemas.openxmlformats.org/drawingml/2006/main"/>
           <a:p xmlns:a="http://schemas.openxmlformats.org/drawingml/2006/main">
             <a:pPr algn="l">
+              <a:buNone/>
               <a:defRPr sz="3225" b="1">
                 <a:solidFill>
                   <a:srgbClr val="14755E"/>
@@ -2337,6 +2340,7 @@
           <a:lstStyle xmlns:a="http://schemas.openxmlformats.org/drawingml/2006/main"/>
           <a:p xmlns:a="http://schemas.openxmlformats.org/drawingml/2006/main">
             <a:pPr algn="l">
+              <a:buNone/>
               <a:defRPr sz="2175" b="0">
                 <a:solidFill>
                   <a:srgbClr val="143042"/>
@@ -2394,6 +2398,7 @@
           <a:lstStyle xmlns:a="http://schemas.openxmlformats.org/drawingml/2006/main"/>
           <a:p xmlns:a="http://schemas.openxmlformats.org/drawingml/2006/main">
             <a:pPr algn="l">
+              <a:buNone/>
               <a:defRPr sz="2025" b="0">
                 <a:solidFill>
                   <a:srgbClr val="486274"/>
@@ -2417,6 +2422,7 @@
           </a:p>
           <a:p xmlns:a="http://schemas.openxmlformats.org/drawingml/2006/main">
             <a:pPr algn="l">
+              <a:buNone/>
               <a:defRPr sz="2025" b="0">
                 <a:solidFill>
                   <a:srgbClr val="486274"/>
@@ -2440,6 +2446,7 @@
           </a:p>
           <a:p xmlns:a="http://schemas.openxmlformats.org/drawingml/2006/main">
             <a:pPr algn="l">
+              <a:buNone/>
               <a:defRPr sz="2025" b="0">
                 <a:solidFill>
                   <a:srgbClr val="486274"/>
@@ -2463,6 +2470,7 @@
           </a:p>
           <a:p xmlns:a="http://schemas.openxmlformats.org/drawingml/2006/main">
             <a:pPr algn="l">
+              <a:buNone/>
               <a:defRPr sz="2025" b="0">
                 <a:solidFill>
                   <a:srgbClr val="486274"/>
@@ -2549,6 +2557,7 @@
           <a:lstStyle xmlns:a="http://schemas.openxmlformats.org/drawingml/2006/main"/>
           <a:p xmlns:a="http://schemas.openxmlformats.org/drawingml/2006/main">
             <a:pPr algn="l">
+              <a:buNone/>
               <a:defRPr sz="3300" b="1">
                 <a:solidFill>
                   <a:srgbClr val="143042"/>
@@ -2606,6 +2615,7 @@
           <a:lstStyle xmlns:a="http://schemas.openxmlformats.org/drawingml/2006/main"/>
           <a:p xmlns:a="http://schemas.openxmlformats.org/drawingml/2006/main">
             <a:pPr algn="l">
+              <a:buNone/>
               <a:defRPr sz="1275" b="0">
                 <a:solidFill>
                   <a:srgbClr val="486274"/>
@@ -2631,7 +2641,7 @@
       </p:sp>
       <p:graphicFrame>
         <p:nvGraphicFramePr>
-          <p:cNvPr id="8" name=""/>
+          <p:cNvPr id="10" name=""/>
           <p:cNvGraphicFramePr/>
           <p:nvPr/>
         </p:nvGraphicFramePr>
@@ -2656,7 +2666,9 @@
                     </a:bodyPr>
                     <a:lstStyle/>
                     <a:p>
-                      <a:pPr algn="l"/>
+                      <a:pPr algn="l">
+                        <a:buNone/>
+                      </a:pPr>
                       <a:r>
                         <a:rPr sz="2025" b="1">
                           <a:solidFill>
@@ -2683,7 +2695,9 @@
                     </a:bodyPr>
                     <a:lstStyle/>
                     <a:p>
-                      <a:pPr algn="l"/>
+                      <a:pPr algn="l">
+                        <a:buNone/>
+                      </a:pPr>
                       <a:r>
                         <a:rPr sz="2025" b="1">
                           <a:solidFill>
@@ -2710,7 +2724,9 @@
                     </a:bodyPr>
                     <a:lstStyle/>
                     <a:p>
-                      <a:pPr algn="l"/>
+                      <a:pPr algn="l">
+                        <a:buNone/>
+                      </a:pPr>
                       <a:r>
                         <a:rPr sz="2025" b="1">
                           <a:solidFill>
@@ -2739,7 +2755,9 @@
                     </a:bodyPr>
                     <a:lstStyle/>
                     <a:p>
-                      <a:pPr algn="l"/>
+                      <a:pPr algn="l">
+                        <a:buNone/>
+                      </a:pPr>
                       <a:r>
                         <a:rPr sz="2025" b="0">
                           <a:solidFill>
@@ -2766,7 +2784,9 @@
                     </a:bodyPr>
                     <a:lstStyle/>
                     <a:p>
-                      <a:pPr algn="l"/>
+                      <a:pPr algn="l">
+                        <a:buNone/>
+                      </a:pPr>
                       <a:r>
                         <a:rPr sz="2025" b="0">
                           <a:solidFill>
@@ -2793,7 +2813,9 @@
                     </a:bodyPr>
                     <a:lstStyle/>
                     <a:p>
-                      <a:pPr algn="l"/>
+                      <a:pPr algn="l">
+                        <a:buNone/>
+                      </a:pPr>
                       <a:r>
                         <a:rPr sz="2025" b="0">
                           <a:solidFill>
@@ -2822,7 +2844,9 @@
                     </a:bodyPr>
                     <a:lstStyle/>
                     <a:p>
-                      <a:pPr algn="l"/>
+                      <a:pPr algn="l">
+                        <a:buNone/>
+                      </a:pPr>
                       <a:r>
                         <a:rPr sz="2025" b="0">
                           <a:solidFill>
@@ -2849,7 +2873,9 @@
                     </a:bodyPr>
                     <a:lstStyle/>
                     <a:p>
-                      <a:pPr algn="l"/>
+                      <a:pPr algn="l">
+                        <a:buNone/>
+                      </a:pPr>
                       <a:r>
                         <a:rPr sz="2025" b="0">
                           <a:solidFill>
@@ -2876,7 +2902,9 @@
                     </a:bodyPr>
                     <a:lstStyle/>
                     <a:p>
-                      <a:pPr algn="l"/>
+                      <a:pPr algn="l">
+                        <a:buNone/>
+                      </a:pPr>
                       <a:r>
                         <a:rPr sz="2025" b="0">
                           <a:solidFill>
@@ -2905,7 +2933,9 @@
                     </a:bodyPr>
                     <a:lstStyle/>
                     <a:p>
-                      <a:pPr algn="l"/>
+                      <a:pPr algn="l">
+                        <a:buNone/>
+                      </a:pPr>
                       <a:r>
                         <a:rPr sz="2025" b="0">
                           <a:solidFill>
@@ -2932,7 +2962,9 @@
                     </a:bodyPr>
                     <a:lstStyle/>
                     <a:p>
-                      <a:pPr algn="l"/>
+                      <a:pPr algn="l">
+                        <a:buNone/>
+                      </a:pPr>
                       <a:r>
                         <a:rPr sz="2025" b="0">
                           <a:solidFill>
@@ -2959,7 +2991,9 @@
                     </a:bodyPr>
                     <a:lstStyle/>
                     <a:p>
-                      <a:pPr algn="l"/>
+                      <a:pPr algn="l">
+                        <a:buNone/>
+                      </a:pPr>
                       <a:r>
                         <a:rPr sz="2025" b="0">
                           <a:solidFill>
@@ -3018,6 +3052,7 @@
           <a:lstStyle xmlns:a="http://schemas.openxmlformats.org/drawingml/2006/main"/>
           <a:p xmlns:a="http://schemas.openxmlformats.org/drawingml/2006/main">
             <a:pPr algn="l">
+              <a:buNone/>
               <a:defRPr sz="2250" b="1">
                 <a:solidFill>
                   <a:srgbClr val="14755E"/>
@@ -3075,6 +3110,7 @@
           <a:lstStyle xmlns:a="http://schemas.openxmlformats.org/drawingml/2006/main"/>
           <a:p xmlns:a="http://schemas.openxmlformats.org/drawingml/2006/main">
             <a:pPr algn="l">
+              <a:buNone/>
               <a:defRPr sz="1800" b="0">
                 <a:solidFill>
                   <a:srgbClr val="486274"/>
@@ -3161,6 +3197,7 @@
           <a:lstStyle xmlns:a="http://schemas.openxmlformats.org/drawingml/2006/main"/>
           <a:p xmlns:a="http://schemas.openxmlformats.org/drawingml/2006/main">
             <a:pPr algn="l">
+              <a:buNone/>
               <a:defRPr sz="3300" b="1">
                 <a:solidFill>
                   <a:srgbClr val="143042"/>
@@ -3218,6 +3255,7 @@
           <a:lstStyle xmlns:a="http://schemas.openxmlformats.org/drawingml/2006/main"/>
           <a:p xmlns:a="http://schemas.openxmlformats.org/drawingml/2006/main">
             <a:pPr algn="l">
+              <a:buNone/>
               <a:defRPr sz="1275" b="0">
                 <a:solidFill>
                   <a:srgbClr val="486274"/>
@@ -3279,6 +3317,7 @@
           <a:lstStyle xmlns:a="http://schemas.openxmlformats.org/drawingml/2006/main"/>
           <a:p xmlns:a="http://schemas.openxmlformats.org/drawingml/2006/main">
             <a:pPr algn="ctr">
+              <a:buNone/>
               <a:defRPr sz="1875" b="0">
                 <a:solidFill>
                   <a:srgbClr val="143042"/>
@@ -3340,6 +3379,7 @@
           <a:lstStyle xmlns:a="http://schemas.openxmlformats.org/drawingml/2006/main"/>
           <a:p xmlns:a="http://schemas.openxmlformats.org/drawingml/2006/main">
             <a:pPr algn="ctr">
+              <a:buNone/>
               <a:defRPr sz="1875" b="0">
                 <a:solidFill>
                   <a:srgbClr val="143042"/>
@@ -3401,6 +3441,7 @@
           <a:lstStyle xmlns:a="http://schemas.openxmlformats.org/drawingml/2006/main"/>
           <a:p xmlns:a="http://schemas.openxmlformats.org/drawingml/2006/main">
             <a:pPr algn="ctr">
+              <a:buNone/>
               <a:defRPr sz="1875" b="0">
                 <a:solidFill>
                   <a:srgbClr val="143042"/>
@@ -3462,6 +3503,7 @@
           <a:lstStyle xmlns:a="http://schemas.openxmlformats.org/drawingml/2006/main"/>
           <a:p xmlns:a="http://schemas.openxmlformats.org/drawingml/2006/main">
             <a:pPr algn="ctr">
+              <a:buNone/>
               <a:defRPr sz="1875" b="0">
                 <a:solidFill>
                   <a:srgbClr val="143042"/>
@@ -3523,6 +3565,7 @@
           <a:lstStyle xmlns:a="http://schemas.openxmlformats.org/drawingml/2006/main"/>
           <a:p xmlns:a="http://schemas.openxmlformats.org/drawingml/2006/main">
             <a:pPr algn="ctr">
+              <a:buNone/>
               <a:defRPr sz="1875" b="0">
                 <a:solidFill>
                   <a:srgbClr val="143042"/>
@@ -3548,7 +3591,7 @@
       </p:sp>
       <p:cxnSp>
         <p:nvCxnSpPr>
-          <p:cNvPr id="24" name=""/>
+          <p:cNvPr id="48" name=""/>
           <p:cNvCxnSpPr>
             <a:stCxn xmlns:a="http://schemas.openxmlformats.org/drawingml/2006/main" id="3" idx="3"/>
             <a:endCxn xmlns:a="http://schemas.openxmlformats.org/drawingml/2006/main" id="4" idx="1"/>
@@ -3574,7 +3617,7 @@
       </p:cxnSp>
       <p:cxnSp>
         <p:nvCxnSpPr>
-          <p:cNvPr id="25" name=""/>
+          <p:cNvPr id="49" name=""/>
           <p:cNvCxnSpPr>
             <a:stCxn xmlns:a="http://schemas.openxmlformats.org/drawingml/2006/main" id="4" idx="3"/>
             <a:endCxn xmlns:a="http://schemas.openxmlformats.org/drawingml/2006/main" id="5" idx="1"/>
@@ -3600,7 +3643,7 @@
       </p:cxnSp>
       <p:cxnSp>
         <p:nvCxnSpPr>
-          <p:cNvPr id="26" name=""/>
+          <p:cNvPr id="50" name=""/>
           <p:cNvCxnSpPr>
             <a:stCxn xmlns:a="http://schemas.openxmlformats.org/drawingml/2006/main" id="5" idx="2"/>
             <a:endCxn xmlns:a="http://schemas.openxmlformats.org/drawingml/2006/main" id="6" idx="0"/>
@@ -3626,7 +3669,7 @@
       </p:cxnSp>
       <p:cxnSp>
         <p:nvCxnSpPr>
-          <p:cNvPr id="27" name=""/>
+          <p:cNvPr id="51" name=""/>
           <p:cNvCxnSpPr>
             <a:stCxn xmlns:a="http://schemas.openxmlformats.org/drawingml/2006/main" id="6" idx="1"/>
             <a:endCxn xmlns:a="http://schemas.openxmlformats.org/drawingml/2006/main" id="7" idx="3"/>
@@ -3652,7 +3695,7 @@
       </p:cxnSp>
       <p:cxnSp>
         <p:nvCxnSpPr>
-          <p:cNvPr id="28" name=""/>
+          <p:cNvPr id="52" name=""/>
           <p:cNvCxnSpPr>
             <a:stCxn xmlns:a="http://schemas.openxmlformats.org/drawingml/2006/main" id="7" idx="1"/>
             <a:endCxn xmlns:a="http://schemas.openxmlformats.org/drawingml/2006/main" id="3" idx="2"/>
@@ -3710,6 +3753,7 @@
           <a:lstStyle xmlns:a="http://schemas.openxmlformats.org/drawingml/2006/main"/>
           <a:p xmlns:a="http://schemas.openxmlformats.org/drawingml/2006/main">
             <a:pPr algn="l">
+              <a:buNone/>
               <a:defRPr sz="2250" b="1">
                 <a:solidFill>
                   <a:srgbClr val="14755E"/>
@@ -3767,6 +3811,7 @@
           <a:lstStyle xmlns:a="http://schemas.openxmlformats.org/drawingml/2006/main"/>
           <a:p xmlns:a="http://schemas.openxmlformats.org/drawingml/2006/main">
             <a:pPr algn="l">
+              <a:buNone/>
               <a:defRPr sz="2025" b="0">
                 <a:solidFill>
                   <a:srgbClr val="143042"/>
@@ -3824,6 +3869,7 @@
           <a:lstStyle xmlns:a="http://schemas.openxmlformats.org/drawingml/2006/main"/>
           <a:p xmlns:a="http://schemas.openxmlformats.org/drawingml/2006/main">
             <a:pPr algn="l">
+              <a:buNone/>
               <a:defRPr sz="1650" b="0">
                 <a:solidFill>
                   <a:srgbClr val="486274"/>
@@ -3881,6 +3927,7 @@
           <a:lstStyle xmlns:a="http://schemas.openxmlformats.org/drawingml/2006/main"/>
           <a:p xmlns:a="http://schemas.openxmlformats.org/drawingml/2006/main">
             <a:pPr algn="l">
+              <a:buNone/>
               <a:defRPr sz="1350" b="0">
                 <a:solidFill>
                   <a:srgbClr val="486274"/>
@@ -3967,6 +4014,7 @@
           <a:lstStyle xmlns:a="http://schemas.openxmlformats.org/drawingml/2006/main"/>
           <a:p xmlns:a="http://schemas.openxmlformats.org/drawingml/2006/main">
             <a:pPr algn="l">
+              <a:buNone/>
               <a:defRPr sz="3300" b="1">
                 <a:solidFill>
                   <a:srgbClr val="143042"/>
@@ -4024,6 +4072,7 @@
           <a:lstStyle xmlns:a="http://schemas.openxmlformats.org/drawingml/2006/main"/>
           <a:p xmlns:a="http://schemas.openxmlformats.org/drawingml/2006/main">
             <a:pPr algn="l">
+              <a:buNone/>
               <a:defRPr sz="1275" b="0">
                 <a:solidFill>
                   <a:srgbClr val="486274"/>
@@ -4081,6 +4130,7 @@
           <a:lstStyle xmlns:a="http://schemas.openxmlformats.org/drawingml/2006/main"/>
           <a:p xmlns:a="http://schemas.openxmlformats.org/drawingml/2006/main">
             <a:pPr algn="l">
+              <a:buNone/>
               <a:defRPr sz="2850" b="1">
                 <a:solidFill>
                   <a:srgbClr val="14755E"/>
@@ -4138,6 +4188,7 @@
           <a:lstStyle xmlns:a="http://schemas.openxmlformats.org/drawingml/2006/main"/>
           <a:p xmlns:a="http://schemas.openxmlformats.org/drawingml/2006/main">
             <a:pPr algn="l">
+              <a:buNone/>
               <a:defRPr sz="2325" b="0">
                 <a:solidFill>
                   <a:srgbClr val="143042"/>
@@ -4195,6 +4246,7 @@
           <a:lstStyle xmlns:a="http://schemas.openxmlformats.org/drawingml/2006/main"/>
           <a:p xmlns:a="http://schemas.openxmlformats.org/drawingml/2006/main">
             <a:pPr algn="l">
+              <a:buNone/>
               <a:defRPr sz="2550" b="1">
                 <a:solidFill>
                   <a:srgbClr val="143042"/>
@@ -4252,6 +4304,7 @@
           <a:lstStyle xmlns:a="http://schemas.openxmlformats.org/drawingml/2006/main"/>
           <a:p xmlns:a="http://schemas.openxmlformats.org/drawingml/2006/main">
             <a:pPr algn="l">
+              <a:buNone/>
               <a:defRPr sz="1950" b="0">
                 <a:solidFill>
                   <a:srgbClr val="486274"/>
@@ -4275,6 +4328,7 @@
           </a:p>
           <a:p xmlns:a="http://schemas.openxmlformats.org/drawingml/2006/main">
             <a:pPr algn="l">
+              <a:buNone/>
               <a:defRPr sz="1950" b="0">
                 <a:solidFill>
                   <a:srgbClr val="486274"/>
@@ -4332,6 +4386,7 @@
           <a:lstStyle xmlns:a="http://schemas.openxmlformats.org/drawingml/2006/main"/>
           <a:p xmlns:a="http://schemas.openxmlformats.org/drawingml/2006/main">
             <a:pPr algn="l">
+              <a:buNone/>
               <a:defRPr sz="1800" b="0">
                 <a:solidFill>
                   <a:srgbClr val="486274"/>
@@ -4355,6 +4410,7 @@
           </a:p>
           <a:p xmlns:a="http://schemas.openxmlformats.org/drawingml/2006/main">
             <a:pPr algn="l">
+              <a:buNone/>
               <a:defRPr sz="1800" b="0">
                 <a:solidFill>
                   <a:srgbClr val="486274"/>
@@ -4373,7 +4429,7 @@
                 <a:ea typeface="Arial"/>
                 <a:cs typeface="Arial"/>
               </a:rPr>
-              <a:t>Revisão humana e contribuições reais do grupo ainda pendentes.</a:t>
+              <a:t>Declaração de IA e contribuições no relatório.</a:t>
             </a:r>
           </a:p>
         </p:txBody>
@@ -4441,6 +4497,7 @@
           <a:lstStyle xmlns:a="http://schemas.openxmlformats.org/drawingml/2006/main"/>
           <a:p xmlns:a="http://schemas.openxmlformats.org/drawingml/2006/main">
             <a:pPr algn="l">
+              <a:buNone/>
               <a:defRPr sz="3300" b="1">
                 <a:solidFill>
                   <a:srgbClr val="143042"/>
@@ -4498,6 +4555,7 @@
           <a:lstStyle xmlns:a="http://schemas.openxmlformats.org/drawingml/2006/main"/>
           <a:p xmlns:a="http://schemas.openxmlformats.org/drawingml/2006/main">
             <a:pPr algn="l">
+              <a:buNone/>
               <a:defRPr sz="1275" b="0">
                 <a:solidFill>
                   <a:srgbClr val="486274"/>
@@ -4523,7 +4581,7 @@
       </p:sp>
       <p:graphicFrame>
         <p:nvGraphicFramePr>
-          <p:cNvPr id="8" name=""/>
+          <p:cNvPr id="10" name=""/>
           <p:cNvGraphicFramePr/>
           <p:nvPr/>
         </p:nvGraphicFramePr>
@@ -4547,7 +4605,9 @@
                     </a:bodyPr>
                     <a:lstStyle/>
                     <a:p>
-                      <a:pPr algn="l"/>
+                      <a:pPr algn="l">
+                        <a:buNone/>
+                      </a:pPr>
                       <a:r>
                         <a:rPr sz="2175" b="1">
                           <a:solidFill>
@@ -4574,7 +4634,9 @@
                     </a:bodyPr>
                     <a:lstStyle/>
                     <a:p>
-                      <a:pPr algn="l"/>
+                      <a:pPr algn="l">
+                        <a:buNone/>
+                      </a:pPr>
                       <a:r>
                         <a:rPr sz="2175" b="1">
                           <a:solidFill>
@@ -4603,7 +4665,9 @@
                     </a:bodyPr>
                     <a:lstStyle/>
                     <a:p>
-                      <a:pPr algn="l"/>
+                      <a:pPr algn="l">
+                        <a:buNone/>
+                      </a:pPr>
                       <a:r>
                         <a:rPr sz="2175" b="0">
                           <a:solidFill>
@@ -4630,7 +4694,9 @@
                     </a:bodyPr>
                     <a:lstStyle/>
                     <a:p>
-                      <a:pPr algn="l"/>
+                      <a:pPr algn="l">
+                        <a:buNone/>
+                      </a:pPr>
                       <a:r>
                         <a:rPr sz="2175" b="0">
                           <a:solidFill>
@@ -4659,7 +4725,9 @@
                     </a:bodyPr>
                     <a:lstStyle/>
                     <a:p>
-                      <a:pPr algn="l"/>
+                      <a:pPr algn="l">
+                        <a:buNone/>
+                      </a:pPr>
                       <a:r>
                         <a:rPr sz="2175" b="0">
                           <a:solidFill>
@@ -4686,7 +4754,9 @@
                     </a:bodyPr>
                     <a:lstStyle/>
                     <a:p>
-                      <a:pPr algn="l"/>
+                      <a:pPr algn="l">
+                        <a:buNone/>
+                      </a:pPr>
                       <a:r>
                         <a:rPr sz="2175" b="0">
                           <a:solidFill>
@@ -4715,7 +4785,9 @@
                     </a:bodyPr>
                     <a:lstStyle/>
                     <a:p>
-                      <a:pPr algn="l"/>
+                      <a:pPr algn="l">
+                        <a:buNone/>
+                      </a:pPr>
                       <a:r>
                         <a:rPr sz="2175" b="0">
                           <a:solidFill>
@@ -4742,7 +4814,9 @@
                     </a:bodyPr>
                     <a:lstStyle/>
                     <a:p>
-                      <a:pPr algn="l"/>
+                      <a:pPr algn="l">
+                        <a:buNone/>
+                      </a:pPr>
                       <a:r>
                         <a:rPr sz="2175" b="0">
                           <a:solidFill>
@@ -4771,7 +4845,9 @@
                     </a:bodyPr>
                     <a:lstStyle/>
                     <a:p>
-                      <a:pPr algn="l"/>
+                      <a:pPr algn="l">
+                        <a:buNone/>
+                      </a:pPr>
                       <a:r>
                         <a:rPr sz="2175" b="0">
                           <a:solidFill>
@@ -4798,7 +4874,9 @@
                     </a:bodyPr>
                     <a:lstStyle/>
                     <a:p>
-                      <a:pPr algn="l"/>
+                      <a:pPr algn="l">
+                        <a:buNone/>
+                      </a:pPr>
                       <a:r>
                         <a:rPr sz="2175" b="0">
                           <a:solidFill>
@@ -4857,6 +4935,7 @@
           <a:lstStyle xmlns:a="http://schemas.openxmlformats.org/drawingml/2006/main"/>
           <a:p xmlns:a="http://schemas.openxmlformats.org/drawingml/2006/main">
             <a:pPr algn="l">
+              <a:buNone/>
               <a:defRPr sz="2025" b="1">
                 <a:solidFill>
                   <a:srgbClr val="14755E"/>
@@ -4914,6 +4993,7 @@
           <a:lstStyle xmlns:a="http://schemas.openxmlformats.org/drawingml/2006/main"/>
           <a:p xmlns:a="http://schemas.openxmlformats.org/drawingml/2006/main">
             <a:pPr algn="l">
+              <a:buNone/>
               <a:defRPr sz="1350" b="0">
                 <a:solidFill>
                   <a:srgbClr val="486274"/>
@@ -5000,6 +5080,7 @@
           <a:lstStyle xmlns:a="http://schemas.openxmlformats.org/drawingml/2006/main"/>
           <a:p xmlns:a="http://schemas.openxmlformats.org/drawingml/2006/main">
             <a:pPr algn="l">
+              <a:buNone/>
               <a:defRPr sz="3300" b="1">
                 <a:solidFill>
                   <a:srgbClr val="143042"/>
@@ -5057,6 +5138,7 @@
           <a:lstStyle xmlns:a="http://schemas.openxmlformats.org/drawingml/2006/main"/>
           <a:p xmlns:a="http://schemas.openxmlformats.org/drawingml/2006/main">
             <a:pPr algn="l">
+              <a:buNone/>
               <a:defRPr sz="1275" b="0">
                 <a:solidFill>
                   <a:srgbClr val="486274"/>
@@ -5114,6 +5196,7 @@
           <a:lstStyle xmlns:a="http://schemas.openxmlformats.org/drawingml/2006/main"/>
           <a:p xmlns:a="http://schemas.openxmlformats.org/drawingml/2006/main">
             <a:pPr algn="l">
+              <a:buNone/>
               <a:defRPr sz="2100" b="0">
                 <a:solidFill>
                   <a:srgbClr val="486274"/>
@@ -5175,6 +5258,7 @@
           <a:lstStyle xmlns:a="http://schemas.openxmlformats.org/drawingml/2006/main"/>
           <a:p xmlns:a="http://schemas.openxmlformats.org/drawingml/2006/main">
             <a:pPr algn="ctr">
+              <a:buNone/>
               <a:defRPr sz="1875" b="0">
                 <a:solidFill>
                   <a:srgbClr val="143042"/>
@@ -5198,6 +5282,7 @@
           </a:p>
           <a:p xmlns:a="http://schemas.openxmlformats.org/drawingml/2006/main">
             <a:pPr algn="ctr">
+              <a:buNone/>
               <a:defRPr sz="1875" b="0">
                 <a:solidFill>
                   <a:srgbClr val="143042"/>
@@ -5259,6 +5344,7 @@
           <a:lstStyle xmlns:a="http://schemas.openxmlformats.org/drawingml/2006/main"/>
           <a:p xmlns:a="http://schemas.openxmlformats.org/drawingml/2006/main">
             <a:pPr algn="ctr">
+              <a:buNone/>
               <a:defRPr sz="1875" b="0">
                 <a:solidFill>
                   <a:srgbClr val="143042"/>
@@ -5282,6 +5368,7 @@
           </a:p>
           <a:p xmlns:a="http://schemas.openxmlformats.org/drawingml/2006/main">
             <a:pPr algn="ctr">
+              <a:buNone/>
               <a:defRPr sz="1875" b="0">
                 <a:solidFill>
                   <a:srgbClr val="143042"/>
@@ -5343,6 +5430,7 @@
           <a:lstStyle xmlns:a="http://schemas.openxmlformats.org/drawingml/2006/main"/>
           <a:p xmlns:a="http://schemas.openxmlformats.org/drawingml/2006/main">
             <a:pPr algn="ctr">
+              <a:buNone/>
               <a:defRPr sz="1800" b="0">
                 <a:solidFill>
                   <a:srgbClr val="14755E"/>
@@ -5366,6 +5454,7 @@
           </a:p>
           <a:p xmlns:a="http://schemas.openxmlformats.org/drawingml/2006/main">
             <a:pPr algn="ctr">
+              <a:buNone/>
               <a:defRPr sz="1800" b="0">
                 <a:solidFill>
                   <a:srgbClr val="14755E"/>
@@ -5389,6 +5478,7 @@
           </a:p>
           <a:p xmlns:a="http://schemas.openxmlformats.org/drawingml/2006/main">
             <a:pPr algn="ctr">
+              <a:buNone/>
               <a:defRPr sz="1800" b="0">
                 <a:solidFill>
                   <a:srgbClr val="14755E"/>
@@ -5450,6 +5540,7 @@
           <a:lstStyle xmlns:a="http://schemas.openxmlformats.org/drawingml/2006/main"/>
           <a:p xmlns:a="http://schemas.openxmlformats.org/drawingml/2006/main">
             <a:pPr algn="ctr">
+              <a:buNone/>
               <a:defRPr sz="1875" b="0">
                 <a:solidFill>
                   <a:srgbClr val="143042"/>
@@ -5473,6 +5564,7 @@
           </a:p>
           <a:p xmlns:a="http://schemas.openxmlformats.org/drawingml/2006/main">
             <a:pPr algn="ctr">
+              <a:buNone/>
               <a:defRPr sz="1875" b="0">
                 <a:solidFill>
                   <a:srgbClr val="143042"/>
@@ -5534,6 +5626,7 @@
           <a:lstStyle xmlns:a="http://schemas.openxmlformats.org/drawingml/2006/main"/>
           <a:p xmlns:a="http://schemas.openxmlformats.org/drawingml/2006/main">
             <a:pPr algn="ctr">
+              <a:buNone/>
               <a:defRPr sz="1800" b="0">
                 <a:solidFill>
                   <a:srgbClr val="486274"/>
@@ -5557,6 +5650,7 @@
           </a:p>
           <a:p xmlns:a="http://schemas.openxmlformats.org/drawingml/2006/main">
             <a:pPr algn="ctr">
+              <a:buNone/>
               <a:defRPr sz="1800" b="0">
                 <a:solidFill>
                   <a:srgbClr val="486274"/>
@@ -5618,6 +5712,7 @@
           <a:lstStyle xmlns:a="http://schemas.openxmlformats.org/drawingml/2006/main"/>
           <a:p xmlns:a="http://schemas.openxmlformats.org/drawingml/2006/main">
             <a:pPr algn="ctr">
+              <a:buNone/>
               <a:defRPr sz="1950" b="0">
                 <a:solidFill>
                   <a:srgbClr val="14755E"/>
@@ -5641,6 +5736,7 @@
           </a:p>
           <a:p xmlns:a="http://schemas.openxmlformats.org/drawingml/2006/main">
             <a:pPr algn="ctr">
+              <a:buNone/>
               <a:defRPr sz="1950" b="0">
                 <a:solidFill>
                   <a:srgbClr val="14755E"/>
@@ -5666,7 +5762,7 @@
       </p:sp>
       <p:cxnSp>
         <p:nvCxnSpPr>
-          <p:cNvPr id="24" name=""/>
+          <p:cNvPr id="52" name=""/>
           <p:cNvCxnSpPr>
             <a:stCxn xmlns:a="http://schemas.openxmlformats.org/drawingml/2006/main" id="4" idx="3"/>
             <a:endCxn xmlns:a="http://schemas.openxmlformats.org/drawingml/2006/main" id="6" idx="1"/>
@@ -5693,7 +5789,7 @@
       </p:cxnSp>
       <p:cxnSp>
         <p:nvCxnSpPr>
-          <p:cNvPr id="25" name=""/>
+          <p:cNvPr id="53" name=""/>
           <p:cNvCxnSpPr>
             <a:stCxn xmlns:a="http://schemas.openxmlformats.org/drawingml/2006/main" id="5" idx="1"/>
             <a:endCxn xmlns:a="http://schemas.openxmlformats.org/drawingml/2006/main" id="6" idx="3"/>
@@ -5720,7 +5816,7 @@
       </p:cxnSp>
       <p:cxnSp>
         <p:nvCxnSpPr>
-          <p:cNvPr id="26" name=""/>
+          <p:cNvPr id="54" name=""/>
           <p:cNvCxnSpPr>
             <a:stCxn xmlns:a="http://schemas.openxmlformats.org/drawingml/2006/main" id="6" idx="2"/>
             <a:endCxn xmlns:a="http://schemas.openxmlformats.org/drawingml/2006/main" id="7" idx="0"/>
@@ -5746,7 +5842,7 @@
       </p:cxnSp>
       <p:cxnSp>
         <p:nvCxnSpPr>
-          <p:cNvPr id="27" name=""/>
+          <p:cNvPr id="55" name=""/>
           <p:cNvCxnSpPr>
             <a:stCxn xmlns:a="http://schemas.openxmlformats.org/drawingml/2006/main" id="7" idx="3"/>
             <a:endCxn xmlns:a="http://schemas.openxmlformats.org/drawingml/2006/main" id="8" idx="1"/>
@@ -5772,7 +5868,7 @@
       </p:cxnSp>
       <p:cxnSp>
         <p:nvCxnSpPr>
-          <p:cNvPr id="28" name=""/>
+          <p:cNvPr id="56" name=""/>
           <p:cNvCxnSpPr>
             <a:stCxn xmlns:a="http://schemas.openxmlformats.org/drawingml/2006/main" id="6" idx="2"/>
             <a:endCxn xmlns:a="http://schemas.openxmlformats.org/drawingml/2006/main" id="9" idx="0"/>
@@ -5862,6 +5958,7 @@
           <a:lstStyle xmlns:a="http://schemas.openxmlformats.org/drawingml/2006/main"/>
           <a:p xmlns:a="http://schemas.openxmlformats.org/drawingml/2006/main">
             <a:pPr algn="l">
+              <a:buNone/>
               <a:defRPr sz="3300" b="1">
                 <a:solidFill>
                   <a:srgbClr val="143042"/>
@@ -5919,6 +6016,7 @@
           <a:lstStyle xmlns:a="http://schemas.openxmlformats.org/drawingml/2006/main"/>
           <a:p xmlns:a="http://schemas.openxmlformats.org/drawingml/2006/main">
             <a:pPr algn="l">
+              <a:buNone/>
               <a:defRPr sz="1275" b="0">
                 <a:solidFill>
                   <a:srgbClr val="486274"/>
@@ -5976,6 +6074,7 @@
           <a:lstStyle xmlns:a="http://schemas.openxmlformats.org/drawingml/2006/main"/>
           <a:p xmlns:a="http://schemas.openxmlformats.org/drawingml/2006/main">
             <a:pPr algn="l">
+              <a:buNone/>
               <a:defRPr sz="2175" b="0">
                 <a:solidFill>
                   <a:srgbClr val="143042"/>
@@ -6001,7 +6100,7 @@
       </p:sp>
       <p:graphicFrame>
         <p:nvGraphicFramePr>
-          <p:cNvPr id="11" name=""/>
+          <p:cNvPr id="13" name=""/>
           <p:cNvGraphicFramePr/>
           <p:nvPr/>
         </p:nvGraphicFramePr>
@@ -6026,7 +6125,9 @@
                     </a:bodyPr>
                     <a:lstStyle/>
                     <a:p>
-                      <a:pPr algn="l"/>
+                      <a:pPr algn="l">
+                        <a:buNone/>
+                      </a:pPr>
                       <a:r>
                         <a:rPr sz="2400" b="1">
                           <a:solidFill>
@@ -6053,7 +6154,9 @@
                     </a:bodyPr>
                     <a:lstStyle/>
                     <a:p>
-                      <a:pPr algn="l"/>
+                      <a:pPr algn="l">
+                        <a:buNone/>
+                      </a:pPr>
                       <a:r>
                         <a:rPr sz="2400" b="1">
                           <a:solidFill>
@@ -6080,7 +6183,9 @@
                     </a:bodyPr>
                     <a:lstStyle/>
                     <a:p>
-                      <a:pPr algn="l"/>
+                      <a:pPr algn="l">
+                        <a:buNone/>
+                      </a:pPr>
                       <a:r>
                         <a:rPr sz="2400" b="1">
                           <a:solidFill>
@@ -6109,7 +6214,9 @@
                     </a:bodyPr>
                     <a:lstStyle/>
                     <a:p>
-                      <a:pPr algn="l"/>
+                      <a:pPr algn="l">
+                        <a:buNone/>
+                      </a:pPr>
                       <a:r>
                         <a:rPr sz="2400" b="0">
                           <a:solidFill>
@@ -6136,7 +6243,9 @@
                     </a:bodyPr>
                     <a:lstStyle/>
                     <a:p>
-                      <a:pPr algn="l"/>
+                      <a:pPr algn="l">
+                        <a:buNone/>
+                      </a:pPr>
                       <a:r>
                         <a:rPr sz="2400" b="0">
                           <a:solidFill>
@@ -6163,7 +6272,9 @@
                     </a:bodyPr>
                     <a:lstStyle/>
                     <a:p>
-                      <a:pPr algn="l"/>
+                      <a:pPr algn="l">
+                        <a:buNone/>
+                      </a:pPr>
                       <a:r>
                         <a:rPr sz="2400" b="0">
                           <a:solidFill>
@@ -6192,7 +6303,9 @@
                     </a:bodyPr>
                     <a:lstStyle/>
                     <a:p>
-                      <a:pPr algn="l"/>
+                      <a:pPr algn="l">
+                        <a:buNone/>
+                      </a:pPr>
                       <a:r>
                         <a:rPr sz="2400" b="0">
                           <a:solidFill>
@@ -6219,7 +6332,9 @@
                     </a:bodyPr>
                     <a:lstStyle/>
                     <a:p>
-                      <a:pPr algn="l"/>
+                      <a:pPr algn="l">
+                        <a:buNone/>
+                      </a:pPr>
                       <a:r>
                         <a:rPr sz="2400" b="0">
                           <a:solidFill>
@@ -6246,7 +6361,9 @@
                     </a:bodyPr>
                     <a:lstStyle/>
                     <a:p>
-                      <a:pPr algn="l"/>
+                      <a:pPr algn="l">
+                        <a:buNone/>
+                      </a:pPr>
                       <a:r>
                         <a:rPr sz="2400" b="0">
                           <a:solidFill>
@@ -6305,6 +6422,7 @@
           <a:lstStyle xmlns:a="http://schemas.openxmlformats.org/drawingml/2006/main"/>
           <a:p xmlns:a="http://schemas.openxmlformats.org/drawingml/2006/main">
             <a:pPr algn="l">
+              <a:buNone/>
               <a:defRPr sz="2100" b="0">
                 <a:solidFill>
                   <a:srgbClr val="143042"/>
@@ -6362,6 +6480,7 @@
           <a:lstStyle xmlns:a="http://schemas.openxmlformats.org/drawingml/2006/main"/>
           <a:p xmlns:a="http://schemas.openxmlformats.org/drawingml/2006/main">
             <a:pPr algn="l">
+              <a:buNone/>
               <a:defRPr sz="2100" b="1">
                 <a:solidFill>
                   <a:srgbClr val="14755E"/>
@@ -6419,6 +6538,7 @@
           <a:lstStyle xmlns:a="http://schemas.openxmlformats.org/drawingml/2006/main"/>
           <a:p xmlns:a="http://schemas.openxmlformats.org/drawingml/2006/main">
             <a:pPr algn="l">
+              <a:buNone/>
               <a:defRPr sz="1500" b="0">
                 <a:solidFill>
                   <a:srgbClr val="486274"/>
@@ -6505,6 +6625,7 @@
           <a:lstStyle xmlns:a="http://schemas.openxmlformats.org/drawingml/2006/main"/>
           <a:p xmlns:a="http://schemas.openxmlformats.org/drawingml/2006/main">
             <a:pPr algn="l">
+              <a:buNone/>
               <a:defRPr sz="3300" b="1">
                 <a:solidFill>
                   <a:srgbClr val="143042"/>
@@ -6562,6 +6683,7 @@
           <a:lstStyle xmlns:a="http://schemas.openxmlformats.org/drawingml/2006/main"/>
           <a:p xmlns:a="http://schemas.openxmlformats.org/drawingml/2006/main">
             <a:pPr algn="l">
+              <a:buNone/>
               <a:defRPr sz="1275" b="0">
                 <a:solidFill>
                   <a:srgbClr val="486274"/>
@@ -6587,7 +6709,7 @@
       </p:sp>
       <p:graphicFrame>
         <p:nvGraphicFramePr>
-          <p:cNvPr id="10" name=""/>
+          <p:cNvPr id="12" name=""/>
           <p:cNvGraphicFramePr/>
           <p:nvPr/>
         </p:nvGraphicFramePr>
@@ -6611,7 +6733,9 @@
                     </a:bodyPr>
                     <a:lstStyle/>
                     <a:p>
-                      <a:pPr algn="l"/>
+                      <a:pPr algn="l">
+                        <a:buNone/>
+                      </a:pPr>
                       <a:r>
                         <a:rPr sz="2025" b="1">
                           <a:solidFill>
@@ -6638,7 +6762,9 @@
                     </a:bodyPr>
                     <a:lstStyle/>
                     <a:p>
-                      <a:pPr algn="l"/>
+                      <a:pPr algn="l">
+                        <a:buNone/>
+                      </a:pPr>
                       <a:r>
                         <a:rPr sz="2025" b="1">
                           <a:solidFill>
@@ -6667,7 +6793,9 @@
                     </a:bodyPr>
                     <a:lstStyle/>
                     <a:p>
-                      <a:pPr algn="l"/>
+                      <a:pPr algn="l">
+                        <a:buNone/>
+                      </a:pPr>
                       <a:r>
                         <a:rPr sz="2025" b="0">
                           <a:solidFill>
@@ -6694,7 +6822,9 @@
                     </a:bodyPr>
                     <a:lstStyle/>
                     <a:p>
-                      <a:pPr algn="l"/>
+                      <a:pPr algn="l">
+                        <a:buNone/>
+                      </a:pPr>
                       <a:r>
                         <a:rPr sz="2025" b="0">
                           <a:solidFill>
@@ -6723,7 +6853,9 @@
                     </a:bodyPr>
                     <a:lstStyle/>
                     <a:p>
-                      <a:pPr algn="l"/>
+                      <a:pPr algn="l">
+                        <a:buNone/>
+                      </a:pPr>
                       <a:r>
                         <a:rPr sz="2025" b="0">
                           <a:solidFill>
@@ -6750,7 +6882,9 @@
                     </a:bodyPr>
                     <a:lstStyle/>
                     <a:p>
-                      <a:pPr algn="l"/>
+                      <a:pPr algn="l">
+                        <a:buNone/>
+                      </a:pPr>
                       <a:r>
                         <a:rPr sz="2025" b="0">
                           <a:solidFill>
@@ -6779,7 +6913,9 @@
                     </a:bodyPr>
                     <a:lstStyle/>
                     <a:p>
-                      <a:pPr algn="l"/>
+                      <a:pPr algn="l">
+                        <a:buNone/>
+                      </a:pPr>
                       <a:r>
                         <a:rPr sz="2025" b="0">
                           <a:solidFill>
@@ -6806,7 +6942,9 @@
                     </a:bodyPr>
                     <a:lstStyle/>
                     <a:p>
-                      <a:pPr algn="l"/>
+                      <a:pPr algn="l">
+                        <a:buNone/>
+                      </a:pPr>
                       <a:r>
                         <a:rPr sz="2025" b="0">
                           <a:solidFill>
@@ -6835,7 +6973,9 @@
                     </a:bodyPr>
                     <a:lstStyle/>
                     <a:p>
-                      <a:pPr algn="l"/>
+                      <a:pPr algn="l">
+                        <a:buNone/>
+                      </a:pPr>
                       <a:r>
                         <a:rPr sz="2025" b="0">
                           <a:solidFill>
@@ -6862,7 +7002,9 @@
                     </a:bodyPr>
                     <a:lstStyle/>
                     <a:p>
-                      <a:pPr algn="l"/>
+                      <a:pPr algn="l">
+                        <a:buNone/>
+                      </a:pPr>
                       <a:r>
                         <a:rPr sz="2025" b="0">
                           <a:solidFill>
@@ -6921,6 +7063,7 @@
           <a:lstStyle xmlns:a="http://schemas.openxmlformats.org/drawingml/2006/main"/>
           <a:p xmlns:a="http://schemas.openxmlformats.org/drawingml/2006/main">
             <a:pPr algn="l">
+              <a:buNone/>
               <a:defRPr sz="2250" b="1">
                 <a:solidFill>
                   <a:srgbClr val="143042"/>
@@ -6978,6 +7121,7 @@
           <a:lstStyle xmlns:a="http://schemas.openxmlformats.org/drawingml/2006/main"/>
           <a:p xmlns:a="http://schemas.openxmlformats.org/drawingml/2006/main">
             <a:pPr algn="l">
+              <a:buNone/>
               <a:defRPr sz="2250" b="1">
                 <a:solidFill>
                   <a:srgbClr val="143042"/>
@@ -7035,6 +7179,7 @@
           <a:lstStyle xmlns:a="http://schemas.openxmlformats.org/drawingml/2006/main"/>
           <a:p xmlns:a="http://schemas.openxmlformats.org/drawingml/2006/main">
             <a:pPr algn="l">
+              <a:buNone/>
               <a:defRPr sz="2850" b="1">
                 <a:solidFill>
                   <a:srgbClr val="14755E"/>
@@ -7058,6 +7203,7 @@
           </a:p>
           <a:p xmlns:a="http://schemas.openxmlformats.org/drawingml/2006/main">
             <a:pPr algn="l">
+              <a:buNone/>
               <a:defRPr sz="2850" b="1">
                 <a:solidFill>
                   <a:srgbClr val="14755E"/>
@@ -7115,6 +7261,7 @@
           <a:lstStyle xmlns:a="http://schemas.openxmlformats.org/drawingml/2006/main"/>
           <a:p xmlns:a="http://schemas.openxmlformats.org/drawingml/2006/main">
             <a:pPr algn="l">
+              <a:buNone/>
               <a:defRPr sz="2025" b="0">
                 <a:solidFill>
                   <a:srgbClr val="486274"/>
@@ -7201,6 +7348,7 @@
           <a:lstStyle xmlns:a="http://schemas.openxmlformats.org/drawingml/2006/main"/>
           <a:p xmlns:a="http://schemas.openxmlformats.org/drawingml/2006/main">
             <a:pPr algn="l">
+              <a:buNone/>
               <a:defRPr sz="3300" b="1">
                 <a:solidFill>
                   <a:srgbClr val="143042"/>
@@ -7258,6 +7406,7 @@
           <a:lstStyle xmlns:a="http://schemas.openxmlformats.org/drawingml/2006/main"/>
           <a:p xmlns:a="http://schemas.openxmlformats.org/drawingml/2006/main">
             <a:pPr algn="l">
+              <a:buNone/>
               <a:defRPr sz="1275" b="0">
                 <a:solidFill>
                   <a:srgbClr val="486274"/>
@@ -7283,7 +7432,7 @@
       </p:sp>
       <p:graphicFrame>
         <p:nvGraphicFramePr>
-          <p:cNvPr id="10" name=""/>
+          <p:cNvPr id="12" name=""/>
           <p:cNvGraphicFramePr/>
           <p:nvPr/>
         </p:nvGraphicFramePr>
@@ -7308,7 +7457,9 @@
                     </a:bodyPr>
                     <a:lstStyle/>
                     <a:p>
-                      <a:pPr algn="l"/>
+                      <a:pPr algn="l">
+                        <a:buNone/>
+                      </a:pPr>
                       <a:r>
                         <a:rPr sz="1800" b="1">
                           <a:solidFill>
@@ -7335,7 +7486,9 @@
                     </a:bodyPr>
                     <a:lstStyle/>
                     <a:p>
-                      <a:pPr algn="l"/>
+                      <a:pPr algn="l">
+                        <a:buNone/>
+                      </a:pPr>
                       <a:r>
                         <a:rPr sz="1800" b="1">
                           <a:solidFill>
@@ -7362,7 +7515,9 @@
                     </a:bodyPr>
                     <a:lstStyle/>
                     <a:p>
-                      <a:pPr algn="l"/>
+                      <a:pPr algn="l">
+                        <a:buNone/>
+                      </a:pPr>
                       <a:r>
                         <a:rPr sz="1800" b="1">
                           <a:solidFill>
@@ -7391,7 +7546,9 @@
                     </a:bodyPr>
                     <a:lstStyle/>
                     <a:p>
-                      <a:pPr algn="l"/>
+                      <a:pPr algn="l">
+                        <a:buNone/>
+                      </a:pPr>
                       <a:r>
                         <a:rPr sz="1800" b="0">
                           <a:solidFill>
@@ -7418,7 +7575,9 @@
                     </a:bodyPr>
                     <a:lstStyle/>
                     <a:p>
-                      <a:pPr algn="l"/>
+                      <a:pPr algn="l">
+                        <a:buNone/>
+                      </a:pPr>
                       <a:r>
                         <a:rPr sz="1800" b="0">
                           <a:solidFill>
@@ -7445,7 +7604,9 @@
                     </a:bodyPr>
                     <a:lstStyle/>
                     <a:p>
-                      <a:pPr algn="l"/>
+                      <a:pPr algn="l">
+                        <a:buNone/>
+                      </a:pPr>
                       <a:r>
                         <a:rPr sz="1800" b="0">
                           <a:solidFill>
@@ -7474,7 +7635,9 @@
                     </a:bodyPr>
                     <a:lstStyle/>
                     <a:p>
-                      <a:pPr algn="l"/>
+                      <a:pPr algn="l">
+                        <a:buNone/>
+                      </a:pPr>
                       <a:r>
                         <a:rPr sz="1800" b="0">
                           <a:solidFill>
@@ -7501,7 +7664,9 @@
                     </a:bodyPr>
                     <a:lstStyle/>
                     <a:p>
-                      <a:pPr algn="l"/>
+                      <a:pPr algn="l">
+                        <a:buNone/>
+                      </a:pPr>
                       <a:r>
                         <a:rPr sz="1800" b="0">
                           <a:solidFill>
@@ -7515,7 +7680,9 @@
                       </a:r>
                     </a:p>
                     <a:p>
-                      <a:pPr algn="l"/>
+                      <a:pPr algn="l">
+                        <a:buNone/>
+                      </a:pPr>
                       <a:r>
                         <a:rPr sz="1800" b="0">
                           <a:solidFill>
@@ -7542,7 +7709,9 @@
                     </a:bodyPr>
                     <a:lstStyle/>
                     <a:p>
-                      <a:pPr algn="l"/>
+                      <a:pPr algn="l">
+                        <a:buNone/>
+                      </a:pPr>
                       <a:r>
                         <a:rPr sz="1800" b="0">
                           <a:solidFill>
@@ -7571,7 +7740,9 @@
                     </a:bodyPr>
                     <a:lstStyle/>
                     <a:p>
-                      <a:pPr algn="l"/>
+                      <a:pPr algn="l">
+                        <a:buNone/>
+                      </a:pPr>
                       <a:r>
                         <a:rPr sz="1800" b="0">
                           <a:solidFill>
@@ -7598,7 +7769,9 @@
                     </a:bodyPr>
                     <a:lstStyle/>
                     <a:p>
-                      <a:pPr algn="l"/>
+                      <a:pPr algn="l">
+                        <a:buNone/>
+                      </a:pPr>
                       <a:r>
                         <a:rPr sz="1800" b="0">
                           <a:solidFill>
@@ -7625,7 +7798,9 @@
                     </a:bodyPr>
                     <a:lstStyle/>
                     <a:p>
-                      <a:pPr algn="l"/>
+                      <a:pPr algn="l">
+                        <a:buNone/>
+                      </a:pPr>
                       <a:r>
                         <a:rPr sz="1800" b="0">
                           <a:solidFill>
@@ -7654,7 +7829,9 @@
                     </a:bodyPr>
                     <a:lstStyle/>
                     <a:p>
-                      <a:pPr algn="l"/>
+                      <a:pPr algn="l">
+                        <a:buNone/>
+                      </a:pPr>
                       <a:r>
                         <a:rPr sz="1800" b="0">
                           <a:solidFill>
@@ -7681,7 +7858,9 @@
                     </a:bodyPr>
                     <a:lstStyle/>
                     <a:p>
-                      <a:pPr algn="l"/>
+                      <a:pPr algn="l">
+                        <a:buNone/>
+                      </a:pPr>
                       <a:r>
                         <a:rPr sz="1800" b="0">
                           <a:solidFill>
@@ -7708,7 +7887,9 @@
                     </a:bodyPr>
                     <a:lstStyle/>
                     <a:p>
-                      <a:pPr algn="l"/>
+                      <a:pPr algn="l">
+                        <a:buNone/>
+                      </a:pPr>
                       <a:r>
                         <a:rPr sz="1800" b="0">
                           <a:solidFill>
@@ -7767,6 +7948,7 @@
           <a:lstStyle xmlns:a="http://schemas.openxmlformats.org/drawingml/2006/main"/>
           <a:p xmlns:a="http://schemas.openxmlformats.org/drawingml/2006/main">
             <a:pPr algn="l">
+              <a:buNone/>
               <a:defRPr sz="2025" b="0">
                 <a:solidFill>
                   <a:srgbClr val="143042"/>
@@ -7824,6 +8006,7 @@
           <a:lstStyle xmlns:a="http://schemas.openxmlformats.org/drawingml/2006/main"/>
           <a:p xmlns:a="http://schemas.openxmlformats.org/drawingml/2006/main">
             <a:pPr algn="l">
+              <a:buNone/>
               <a:defRPr sz="2175" b="1">
                 <a:solidFill>
                   <a:srgbClr val="14755E"/>
@@ -7881,6 +8064,7 @@
           <a:lstStyle xmlns:a="http://schemas.openxmlformats.org/drawingml/2006/main"/>
           <a:p xmlns:a="http://schemas.openxmlformats.org/drawingml/2006/main">
             <a:pPr algn="l">
+              <a:buNone/>
               <a:defRPr sz="2025" b="0">
                 <a:solidFill>
                   <a:srgbClr val="143042"/>
@@ -7938,6 +8122,7 @@
           <a:lstStyle xmlns:a="http://schemas.openxmlformats.org/drawingml/2006/main"/>
           <a:p xmlns:a="http://schemas.openxmlformats.org/drawingml/2006/main">
             <a:pPr algn="l">
+              <a:buNone/>
               <a:defRPr sz="1350" b="0">
                 <a:solidFill>
                   <a:srgbClr val="486274"/>
@@ -8024,6 +8209,7 @@
           <a:lstStyle xmlns:a="http://schemas.openxmlformats.org/drawingml/2006/main"/>
           <a:p xmlns:a="http://schemas.openxmlformats.org/drawingml/2006/main">
             <a:pPr algn="l">
+              <a:buNone/>
               <a:defRPr sz="3300" b="1">
                 <a:solidFill>
                   <a:srgbClr val="143042"/>
@@ -8081,6 +8267,7 @@
           <a:lstStyle xmlns:a="http://schemas.openxmlformats.org/drawingml/2006/main"/>
           <a:p xmlns:a="http://schemas.openxmlformats.org/drawingml/2006/main">
             <a:pPr algn="l">
+              <a:buNone/>
               <a:defRPr sz="1275" b="0">
                 <a:solidFill>
                   <a:srgbClr val="486274"/>
@@ -8142,6 +8329,7 @@
           <a:lstStyle xmlns:a="http://schemas.openxmlformats.org/drawingml/2006/main"/>
           <a:p xmlns:a="http://schemas.openxmlformats.org/drawingml/2006/main">
             <a:pPr algn="ctr">
+              <a:buNone/>
               <a:defRPr sz="1950" b="0">
                 <a:solidFill>
                   <a:srgbClr val="143042"/>
@@ -8203,6 +8391,7 @@
           <a:lstStyle xmlns:a="http://schemas.openxmlformats.org/drawingml/2006/main"/>
           <a:p xmlns:a="http://schemas.openxmlformats.org/drawingml/2006/main">
             <a:pPr algn="ctr">
+              <a:buNone/>
               <a:defRPr sz="1800" b="0">
                 <a:solidFill>
                   <a:srgbClr val="143042"/>
@@ -8226,6 +8415,7 @@
           </a:p>
           <a:p xmlns:a="http://schemas.openxmlformats.org/drawingml/2006/main">
             <a:pPr algn="ctr">
+              <a:buNone/>
               <a:defRPr sz="1800" b="0">
                 <a:solidFill>
                   <a:srgbClr val="143042"/>
@@ -8249,6 +8439,7 @@
           </a:p>
           <a:p xmlns:a="http://schemas.openxmlformats.org/drawingml/2006/main">
             <a:pPr algn="ctr">
+              <a:buNone/>
               <a:defRPr sz="1800" b="0">
                 <a:solidFill>
                   <a:srgbClr val="143042"/>
@@ -8310,6 +8501,7 @@
           <a:lstStyle xmlns:a="http://schemas.openxmlformats.org/drawingml/2006/main"/>
           <a:p xmlns:a="http://schemas.openxmlformats.org/drawingml/2006/main">
             <a:pPr algn="ctr">
+              <a:buNone/>
               <a:defRPr sz="1650" b="0">
                 <a:solidFill>
                   <a:srgbClr val="143042"/>
@@ -8333,6 +8525,7 @@
           </a:p>
           <a:p xmlns:a="http://schemas.openxmlformats.org/drawingml/2006/main">
             <a:pPr algn="ctr">
+              <a:buNone/>
               <a:defRPr sz="1650" b="0">
                 <a:solidFill>
                   <a:srgbClr val="143042"/>
@@ -8356,6 +8549,7 @@
           </a:p>
           <a:p xmlns:a="http://schemas.openxmlformats.org/drawingml/2006/main">
             <a:pPr algn="ctr">
+              <a:buNone/>
               <a:defRPr sz="1650" b="0">
                 <a:solidFill>
                   <a:srgbClr val="143042"/>
@@ -8417,6 +8611,7 @@
           <a:lstStyle xmlns:a="http://schemas.openxmlformats.org/drawingml/2006/main"/>
           <a:p xmlns:a="http://schemas.openxmlformats.org/drawingml/2006/main">
             <a:pPr algn="ctr">
+              <a:buNone/>
               <a:defRPr sz="1800" b="0">
                 <a:solidFill>
                   <a:srgbClr val="143042"/>
@@ -8440,6 +8635,7 @@
           </a:p>
           <a:p xmlns:a="http://schemas.openxmlformats.org/drawingml/2006/main">
             <a:pPr algn="ctr">
+              <a:buNone/>
               <a:defRPr sz="1800" b="0">
                 <a:solidFill>
                   <a:srgbClr val="143042"/>
@@ -8463,6 +8659,7 @@
           </a:p>
           <a:p xmlns:a="http://schemas.openxmlformats.org/drawingml/2006/main">
             <a:pPr algn="ctr">
+              <a:buNone/>
               <a:defRPr sz="1800" b="0">
                 <a:solidFill>
                   <a:srgbClr val="143042"/>
@@ -8524,6 +8721,7 @@
           <a:lstStyle xmlns:a="http://schemas.openxmlformats.org/drawingml/2006/main"/>
           <a:p xmlns:a="http://schemas.openxmlformats.org/drawingml/2006/main">
             <a:pPr algn="ctr">
+              <a:buNone/>
               <a:defRPr sz="1875" b="0">
                 <a:solidFill>
                   <a:srgbClr val="A73532"/>
@@ -8547,6 +8745,7 @@
           </a:p>
           <a:p xmlns:a="http://schemas.openxmlformats.org/drawingml/2006/main">
             <a:pPr algn="ctr">
+              <a:buNone/>
               <a:defRPr sz="1875" b="0">
                 <a:solidFill>
                   <a:srgbClr val="A73532"/>
@@ -8608,6 +8807,7 @@
           <a:lstStyle xmlns:a="http://schemas.openxmlformats.org/drawingml/2006/main"/>
           <a:p xmlns:a="http://schemas.openxmlformats.org/drawingml/2006/main">
             <a:pPr algn="ctr">
+              <a:buNone/>
               <a:defRPr sz="1875" b="0">
                 <a:solidFill>
                   <a:srgbClr val="A73532"/>
@@ -8631,6 +8831,7 @@
           </a:p>
           <a:p xmlns:a="http://schemas.openxmlformats.org/drawingml/2006/main">
             <a:pPr algn="ctr">
+              <a:buNone/>
               <a:defRPr sz="1875" b="0">
                 <a:solidFill>
                   <a:srgbClr val="A73532"/>
@@ -8692,6 +8893,7 @@
           <a:lstStyle xmlns:a="http://schemas.openxmlformats.org/drawingml/2006/main"/>
           <a:p xmlns:a="http://schemas.openxmlformats.org/drawingml/2006/main">
             <a:pPr algn="ctr">
+              <a:buNone/>
               <a:defRPr sz="1875" b="0">
                 <a:solidFill>
                   <a:srgbClr val="A73532"/>
@@ -8715,6 +8917,7 @@
           </a:p>
           <a:p xmlns:a="http://schemas.openxmlformats.org/drawingml/2006/main">
             <a:pPr algn="ctr">
+              <a:buNone/>
               <a:defRPr sz="1875" b="0">
                 <a:solidFill>
                   <a:srgbClr val="A73532"/>
@@ -8740,7 +8943,7 @@
       </p:sp>
       <p:cxnSp>
         <p:nvCxnSpPr>
-          <p:cNvPr id="28" name=""/>
+          <p:cNvPr id="58" name=""/>
           <p:cNvCxnSpPr>
             <a:stCxn xmlns:a="http://schemas.openxmlformats.org/drawingml/2006/main" id="3" idx="3"/>
             <a:endCxn xmlns:a="http://schemas.openxmlformats.org/drawingml/2006/main" id="4" idx="1"/>
@@ -8768,7 +8971,7 @@
       </p:cxnSp>
       <p:cxnSp>
         <p:nvCxnSpPr>
-          <p:cNvPr id="29" name=""/>
+          <p:cNvPr id="59" name=""/>
           <p:cNvCxnSpPr>
             <a:stCxn xmlns:a="http://schemas.openxmlformats.org/drawingml/2006/main" id="3" idx="3"/>
             <a:endCxn xmlns:a="http://schemas.openxmlformats.org/drawingml/2006/main" id="5" idx="1"/>
@@ -8796,7 +8999,7 @@
       </p:cxnSp>
       <p:cxnSp>
         <p:nvCxnSpPr>
-          <p:cNvPr id="30" name=""/>
+          <p:cNvPr id="60" name=""/>
           <p:cNvCxnSpPr>
             <a:stCxn xmlns:a="http://schemas.openxmlformats.org/drawingml/2006/main" id="3" idx="3"/>
             <a:endCxn xmlns:a="http://schemas.openxmlformats.org/drawingml/2006/main" id="6" idx="1"/>
@@ -8824,7 +9027,7 @@
       </p:cxnSp>
       <p:cxnSp>
         <p:nvCxnSpPr>
-          <p:cNvPr id="31" name=""/>
+          <p:cNvPr id="61" name=""/>
           <p:cNvCxnSpPr>
             <a:stCxn xmlns:a="http://schemas.openxmlformats.org/drawingml/2006/main" id="4" idx="3"/>
             <a:endCxn xmlns:a="http://schemas.openxmlformats.org/drawingml/2006/main" id="7" idx="1"/>
@@ -8850,7 +9053,7 @@
       </p:cxnSp>
       <p:cxnSp>
         <p:nvCxnSpPr>
-          <p:cNvPr id="32" name=""/>
+          <p:cNvPr id="62" name=""/>
           <p:cNvCxnSpPr>
             <a:stCxn xmlns:a="http://schemas.openxmlformats.org/drawingml/2006/main" id="5" idx="3"/>
             <a:endCxn xmlns:a="http://schemas.openxmlformats.org/drawingml/2006/main" id="8" idx="1"/>
@@ -8876,7 +9079,7 @@
       </p:cxnSp>
       <p:cxnSp>
         <p:nvCxnSpPr>
-          <p:cNvPr id="33" name=""/>
+          <p:cNvPr id="63" name=""/>
           <p:cNvCxnSpPr>
             <a:stCxn xmlns:a="http://schemas.openxmlformats.org/drawingml/2006/main" id="6" idx="3"/>
             <a:endCxn xmlns:a="http://schemas.openxmlformats.org/drawingml/2006/main" id="9" idx="1"/>
@@ -8934,6 +9137,7 @@
           <a:lstStyle xmlns:a="http://schemas.openxmlformats.org/drawingml/2006/main"/>
           <a:p xmlns:a="http://schemas.openxmlformats.org/drawingml/2006/main">
             <a:pPr algn="l">
+              <a:buNone/>
               <a:defRPr sz="1575" b="1">
                 <a:solidFill>
                   <a:srgbClr val="14755E"/>
@@ -8991,6 +9195,7 @@
           <a:lstStyle xmlns:a="http://schemas.openxmlformats.org/drawingml/2006/main"/>
           <a:p xmlns:a="http://schemas.openxmlformats.org/drawingml/2006/main">
             <a:pPr algn="l">
+              <a:buNone/>
               <a:defRPr sz="1500" b="1">
                 <a:solidFill>
                   <a:srgbClr val="14755E"/>
@@ -9048,6 +9253,7 @@
           <a:lstStyle xmlns:a="http://schemas.openxmlformats.org/drawingml/2006/main"/>
           <a:p xmlns:a="http://schemas.openxmlformats.org/drawingml/2006/main">
             <a:pPr algn="l">
+              <a:buNone/>
               <a:defRPr sz="1500" b="1">
                 <a:solidFill>
                   <a:srgbClr val="14755E"/>
@@ -9134,6 +9340,7 @@
           <a:lstStyle xmlns:a="http://schemas.openxmlformats.org/drawingml/2006/main"/>
           <a:p xmlns:a="http://schemas.openxmlformats.org/drawingml/2006/main">
             <a:pPr algn="l">
+              <a:buNone/>
               <a:defRPr sz="3300" b="1">
                 <a:solidFill>
                   <a:srgbClr val="143042"/>
@@ -9191,6 +9398,7 @@
           <a:lstStyle xmlns:a="http://schemas.openxmlformats.org/drawingml/2006/main"/>
           <a:p xmlns:a="http://schemas.openxmlformats.org/drawingml/2006/main">
             <a:pPr algn="l">
+              <a:buNone/>
               <a:defRPr sz="1275" b="0">
                 <a:solidFill>
                   <a:srgbClr val="486274"/>
@@ -9216,7 +9424,7 @@
       </p:sp>
       <p:graphicFrame>
         <p:nvGraphicFramePr>
-          <p:cNvPr id="9" name=""/>
+          <p:cNvPr id="11" name=""/>
           <p:cNvGraphicFramePr/>
           <p:nvPr/>
         </p:nvGraphicFramePr>
@@ -9243,7 +9451,9 @@
                     </a:bodyPr>
                     <a:lstStyle/>
                     <a:p>
-                      <a:pPr algn="l"/>
+                      <a:pPr algn="l">
+                        <a:buNone/>
+                      </a:pPr>
                       <a:r>
                         <a:rPr sz="2175" b="1">
                           <a:solidFill>
@@ -9270,7 +9480,9 @@
                     </a:bodyPr>
                     <a:lstStyle/>
                     <a:p>
-                      <a:pPr algn="l"/>
+                      <a:pPr algn="l">
+                        <a:buNone/>
+                      </a:pPr>
                       <a:r>
                         <a:rPr sz="2175" b="1">
                           <a:solidFill>
@@ -9297,7 +9509,9 @@
                     </a:bodyPr>
                     <a:lstStyle/>
                     <a:p>
-                      <a:pPr algn="l"/>
+                      <a:pPr algn="l">
+                        <a:buNone/>
+                      </a:pPr>
                       <a:r>
                         <a:rPr sz="2175" b="1">
                           <a:solidFill>
@@ -9324,7 +9538,9 @@
                     </a:bodyPr>
                     <a:lstStyle/>
                     <a:p>
-                      <a:pPr algn="l"/>
+                      <a:pPr algn="l">
+                        <a:buNone/>
+                      </a:pPr>
                       <a:r>
                         <a:rPr sz="2175" b="1">
                           <a:solidFill>
@@ -9351,7 +9567,9 @@
                     </a:bodyPr>
                     <a:lstStyle/>
                     <a:p>
-                      <a:pPr algn="l"/>
+                      <a:pPr algn="l">
+                        <a:buNone/>
+                      </a:pPr>
                       <a:r>
                         <a:rPr sz="2175" b="1">
                           <a:solidFill>
@@ -9380,7 +9598,9 @@
                     </a:bodyPr>
                     <a:lstStyle/>
                     <a:p>
-                      <a:pPr algn="l"/>
+                      <a:pPr algn="l">
+                        <a:buNone/>
+                      </a:pPr>
                       <a:r>
                         <a:rPr sz="2175" b="0">
                           <a:solidFill>
@@ -9407,7 +9627,9 @@
                     </a:bodyPr>
                     <a:lstStyle/>
                     <a:p>
-                      <a:pPr algn="l"/>
+                      <a:pPr algn="l">
+                        <a:buNone/>
+                      </a:pPr>
                       <a:r>
                         <a:rPr sz="2175" b="0">
                           <a:solidFill>
@@ -9434,7 +9656,9 @@
                     </a:bodyPr>
                     <a:lstStyle/>
                     <a:p>
-                      <a:pPr algn="l"/>
+                      <a:pPr algn="l">
+                        <a:buNone/>
+                      </a:pPr>
                       <a:r>
                         <a:rPr sz="2175" b="0">
                           <a:solidFill>
@@ -9461,7 +9685,9 @@
                     </a:bodyPr>
                     <a:lstStyle/>
                     <a:p>
-                      <a:pPr algn="l"/>
+                      <a:pPr algn="l">
+                        <a:buNone/>
+                      </a:pPr>
                       <a:r>
                         <a:rPr sz="2175" b="0">
                           <a:solidFill>
@@ -9488,7 +9714,9 @@
                     </a:bodyPr>
                     <a:lstStyle/>
                     <a:p>
-                      <a:pPr algn="l"/>
+                      <a:pPr algn="l">
+                        <a:buNone/>
+                      </a:pPr>
                       <a:r>
                         <a:rPr sz="2175" b="0">
                           <a:solidFill>
@@ -9517,7 +9745,9 @@
                     </a:bodyPr>
                     <a:lstStyle/>
                     <a:p>
-                      <a:pPr algn="l"/>
+                      <a:pPr algn="l">
+                        <a:buNone/>
+                      </a:pPr>
                       <a:r>
                         <a:rPr sz="2175" b="0">
                           <a:solidFill>
@@ -9544,7 +9774,9 @@
                     </a:bodyPr>
                     <a:lstStyle/>
                     <a:p>
-                      <a:pPr algn="l"/>
+                      <a:pPr algn="l">
+                        <a:buNone/>
+                      </a:pPr>
                       <a:r>
                         <a:rPr sz="2175" b="0">
                           <a:solidFill>
@@ -9571,7 +9803,9 @@
                     </a:bodyPr>
                     <a:lstStyle/>
                     <a:p>
-                      <a:pPr algn="l"/>
+                      <a:pPr algn="l">
+                        <a:buNone/>
+                      </a:pPr>
                       <a:r>
                         <a:rPr sz="2175" b="0">
                           <a:solidFill>
@@ -9598,7 +9832,9 @@
                     </a:bodyPr>
                     <a:lstStyle/>
                     <a:p>
-                      <a:pPr algn="l"/>
+                      <a:pPr algn="l">
+                        <a:buNone/>
+                      </a:pPr>
                       <a:r>
                         <a:rPr sz="2175" b="0">
                           <a:solidFill>
@@ -9625,7 +9861,9 @@
                     </a:bodyPr>
                     <a:lstStyle/>
                     <a:p>
-                      <a:pPr algn="l"/>
+                      <a:pPr algn="l">
+                        <a:buNone/>
+                      </a:pPr>
                       <a:r>
                         <a:rPr sz="2175" b="0">
                           <a:solidFill>
@@ -9654,7 +9892,9 @@
                     </a:bodyPr>
                     <a:lstStyle/>
                     <a:p>
-                      <a:pPr algn="l"/>
+                      <a:pPr algn="l">
+                        <a:buNone/>
+                      </a:pPr>
                       <a:r>
                         <a:rPr sz="2175" b="0">
                           <a:solidFill>
@@ -9681,7 +9921,9 @@
                     </a:bodyPr>
                     <a:lstStyle/>
                     <a:p>
-                      <a:pPr algn="l"/>
+                      <a:pPr algn="l">
+                        <a:buNone/>
+                      </a:pPr>
                       <a:r>
                         <a:rPr sz="2175" b="0">
                           <a:solidFill>
@@ -9708,7 +9950,9 @@
                     </a:bodyPr>
                     <a:lstStyle/>
                     <a:p>
-                      <a:pPr algn="l"/>
+                      <a:pPr algn="l">
+                        <a:buNone/>
+                      </a:pPr>
                       <a:r>
                         <a:rPr sz="2175" b="0">
                           <a:solidFill>
@@ -9735,7 +9979,9 @@
                     </a:bodyPr>
                     <a:lstStyle/>
                     <a:p>
-                      <a:pPr algn="l"/>
+                      <a:pPr algn="l">
+                        <a:buNone/>
+                      </a:pPr>
                       <a:r>
                         <a:rPr sz="2175" b="0">
                           <a:solidFill>
@@ -9762,7 +10008,9 @@
                     </a:bodyPr>
                     <a:lstStyle/>
                     <a:p>
-                      <a:pPr algn="l"/>
+                      <a:pPr algn="l">
+                        <a:buNone/>
+                      </a:pPr>
                       <a:r>
                         <a:rPr sz="2175" b="0">
                           <a:solidFill>
@@ -9821,6 +10069,7 @@
           <a:lstStyle xmlns:a="http://schemas.openxmlformats.org/drawingml/2006/main"/>
           <a:p xmlns:a="http://schemas.openxmlformats.org/drawingml/2006/main">
             <a:pPr algn="l">
+              <a:buNone/>
               <a:defRPr sz="2250" b="1">
                 <a:solidFill>
                   <a:srgbClr val="143042"/>
@@ -9878,6 +10127,7 @@
           <a:lstStyle xmlns:a="http://schemas.openxmlformats.org/drawingml/2006/main"/>
           <a:p xmlns:a="http://schemas.openxmlformats.org/drawingml/2006/main">
             <a:pPr algn="l">
+              <a:buNone/>
               <a:defRPr sz="2025" b="0">
                 <a:solidFill>
                   <a:srgbClr val="143042"/>
@@ -9935,6 +10185,7 @@
           <a:lstStyle xmlns:a="http://schemas.openxmlformats.org/drawingml/2006/main"/>
           <a:p xmlns:a="http://schemas.openxmlformats.org/drawingml/2006/main">
             <a:pPr algn="l">
+              <a:buNone/>
               <a:defRPr sz="2025" b="0">
                 <a:solidFill>
                   <a:srgbClr val="486274"/>
@@ -10021,6 +10272,7 @@
           <a:lstStyle xmlns:a="http://schemas.openxmlformats.org/drawingml/2006/main"/>
           <a:p xmlns:a="http://schemas.openxmlformats.org/drawingml/2006/main">
             <a:pPr algn="l">
+              <a:buNone/>
               <a:defRPr sz="3300" b="1">
                 <a:solidFill>
                   <a:srgbClr val="143042"/>
@@ -10078,6 +10330,7 @@
           <a:lstStyle xmlns:a="http://schemas.openxmlformats.org/drawingml/2006/main"/>
           <a:p xmlns:a="http://schemas.openxmlformats.org/drawingml/2006/main">
             <a:pPr algn="l">
+              <a:buNone/>
               <a:defRPr sz="1275" b="0">
                 <a:solidFill>
                   <a:srgbClr val="486274"/>
@@ -10135,6 +10388,7 @@
           <a:lstStyle xmlns:a="http://schemas.openxmlformats.org/drawingml/2006/main"/>
           <a:p xmlns:a="http://schemas.openxmlformats.org/drawingml/2006/main">
             <a:pPr algn="l">
+              <a:buNone/>
               <a:defRPr sz="2325" b="1">
                 <a:solidFill>
                   <a:srgbClr val="14755E"/>
@@ -10196,6 +10450,7 @@
           <a:lstStyle xmlns:a="http://schemas.openxmlformats.org/drawingml/2006/main"/>
           <a:p xmlns:a="http://schemas.openxmlformats.org/drawingml/2006/main">
             <a:pPr algn="ctr">
+              <a:buNone/>
               <a:defRPr sz="1875" b="0">
                 <a:solidFill>
                   <a:srgbClr val="143042"/>
@@ -10257,6 +10512,7 @@
           <a:lstStyle xmlns:a="http://schemas.openxmlformats.org/drawingml/2006/main"/>
           <a:p xmlns:a="http://schemas.openxmlformats.org/drawingml/2006/main">
             <a:pPr algn="ctr">
+              <a:buNone/>
               <a:defRPr sz="1875" b="0">
                 <a:solidFill>
                   <a:srgbClr val="143042"/>
@@ -10318,6 +10574,7 @@
           <a:lstStyle xmlns:a="http://schemas.openxmlformats.org/drawingml/2006/main"/>
           <a:p xmlns:a="http://schemas.openxmlformats.org/drawingml/2006/main">
             <a:pPr algn="ctr">
+              <a:buNone/>
               <a:defRPr sz="1875" b="0">
                 <a:solidFill>
                   <a:srgbClr val="143042"/>
@@ -10379,6 +10636,7 @@
           <a:lstStyle xmlns:a="http://schemas.openxmlformats.org/drawingml/2006/main"/>
           <a:p xmlns:a="http://schemas.openxmlformats.org/drawingml/2006/main">
             <a:pPr algn="ctr">
+              <a:buNone/>
               <a:defRPr sz="1875" b="0">
                 <a:solidFill>
                   <a:srgbClr val="143042"/>
@@ -10404,7 +10662,7 @@
       </p:sp>
       <p:cxnSp>
         <p:nvCxnSpPr>
-          <p:cNvPr id="20" name=""/>
+          <p:cNvPr id="40" name=""/>
           <p:cNvCxnSpPr>
             <a:stCxn xmlns:a="http://schemas.openxmlformats.org/drawingml/2006/main" id="4" idx="3"/>
             <a:endCxn xmlns:a="http://schemas.openxmlformats.org/drawingml/2006/main" id="5" idx="1"/>
@@ -10430,7 +10688,7 @@
       </p:cxnSp>
       <p:cxnSp>
         <p:nvCxnSpPr>
-          <p:cNvPr id="21" name=""/>
+          <p:cNvPr id="41" name=""/>
           <p:cNvCxnSpPr>
             <a:stCxn xmlns:a="http://schemas.openxmlformats.org/drawingml/2006/main" id="5" idx="3"/>
             <a:endCxn xmlns:a="http://schemas.openxmlformats.org/drawingml/2006/main" id="6" idx="1"/>
@@ -10456,7 +10714,7 @@
       </p:cxnSp>
       <p:cxnSp>
         <p:nvCxnSpPr>
-          <p:cNvPr id="22" name=""/>
+          <p:cNvPr id="42" name=""/>
           <p:cNvCxnSpPr>
             <a:stCxn xmlns:a="http://schemas.openxmlformats.org/drawingml/2006/main" id="6" idx="2"/>
             <a:endCxn xmlns:a="http://schemas.openxmlformats.org/drawingml/2006/main" id="7" idx="3"/>
@@ -10518,6 +10776,7 @@
           <a:lstStyle xmlns:a="http://schemas.openxmlformats.org/drawingml/2006/main"/>
           <a:p xmlns:a="http://schemas.openxmlformats.org/drawingml/2006/main">
             <a:pPr algn="l">
+              <a:buNone/>
               <a:defRPr sz="2100" b="0">
                 <a:solidFill>
                   <a:srgbClr val="143042"/>
@@ -10575,6 +10834,7 @@
           <a:lstStyle xmlns:a="http://schemas.openxmlformats.org/drawingml/2006/main"/>
           <a:p xmlns:a="http://schemas.openxmlformats.org/drawingml/2006/main">
             <a:pPr algn="l">
+              <a:buNone/>
               <a:defRPr sz="1650" b="0">
                 <a:solidFill>
                   <a:srgbClr val="486274"/>

</xml_diff>